<commit_message>
brand: add ProofLend cross-chain mark
</commit_message>
<xml_diff>
--- a/submission/ProofLend_Hackathon_Deck.pptx
+++ b/submission/ProofLend_Hackathon_Deck.pptx
@@ -2,20 +2,20 @@
 <file path=ppt/presentation.xml><?xml version="1.0" encoding="utf-8"?>
 <p:presentation xmlns:p="http://schemas.openxmlformats.org/presentationml/2006/main">
   <p:sldMasterIdLst>
-    <p:sldMasterId xmlns:r="http://schemas.openxmlformats.org/officeDocument/2006/relationships" id="2147483648" r:id="Rc08eaa366389439f"/>
+    <p:sldMasterId xmlns:r="http://schemas.openxmlformats.org/officeDocument/2006/relationships" id="2147483648" r:id="R63263e4c6c8a4fd6"/>
   </p:sldMasterIdLst>
   <p:notesMasterIdLst>
-    <p:notesMasterId xmlns:r="http://schemas.openxmlformats.org/officeDocument/2006/relationships" r:id="Rc7c678d595574e36"/>
+    <p:notesMasterId xmlns:r="http://schemas.openxmlformats.org/officeDocument/2006/relationships" r:id="Re19ebc27b4d94fbd"/>
   </p:notesMasterIdLst>
   <p:sldIdLst>
-    <p:sldId xmlns:r="http://schemas.openxmlformats.org/officeDocument/2006/relationships" id="256" r:id="R29c45b542be74431"/>
-    <p:sldId xmlns:r="http://schemas.openxmlformats.org/officeDocument/2006/relationships" id="257" r:id="R3f8aa4fc99a44574"/>
-    <p:sldId xmlns:r="http://schemas.openxmlformats.org/officeDocument/2006/relationships" id="258" r:id="R13e6082692f340fe"/>
-    <p:sldId xmlns:r="http://schemas.openxmlformats.org/officeDocument/2006/relationships" id="259" r:id="R51accfe8acd64e41"/>
-    <p:sldId xmlns:r="http://schemas.openxmlformats.org/officeDocument/2006/relationships" id="260" r:id="R0fea6886a03747e1"/>
-    <p:sldId xmlns:r="http://schemas.openxmlformats.org/officeDocument/2006/relationships" id="261" r:id="R5736ee430f4347b6"/>
-    <p:sldId xmlns:r="http://schemas.openxmlformats.org/officeDocument/2006/relationships" id="262" r:id="R5f0b993b133c45eb"/>
-    <p:sldId xmlns:r="http://schemas.openxmlformats.org/officeDocument/2006/relationships" id="263" r:id="R5401b358cf884618"/>
+    <p:sldId xmlns:r="http://schemas.openxmlformats.org/officeDocument/2006/relationships" id="256" r:id="Rdba9fcdbec234591"/>
+    <p:sldId xmlns:r="http://schemas.openxmlformats.org/officeDocument/2006/relationships" id="257" r:id="Ra4e53f8d2b474187"/>
+    <p:sldId xmlns:r="http://schemas.openxmlformats.org/officeDocument/2006/relationships" id="258" r:id="Rd98b3f19a85f422f"/>
+    <p:sldId xmlns:r="http://schemas.openxmlformats.org/officeDocument/2006/relationships" id="259" r:id="R66d7e3d6e24541bb"/>
+    <p:sldId xmlns:r="http://schemas.openxmlformats.org/officeDocument/2006/relationships" id="260" r:id="R6ffb25c87c474426"/>
+    <p:sldId xmlns:r="http://schemas.openxmlformats.org/officeDocument/2006/relationships" id="261" r:id="Raedf1ebe7b234e2d"/>
+    <p:sldId xmlns:r="http://schemas.openxmlformats.org/officeDocument/2006/relationships" id="262" r:id="R21d1a66781c14a83"/>
+    <p:sldId xmlns:r="http://schemas.openxmlformats.org/officeDocument/2006/relationships" id="263" r:id="Rb8e91ce65bee4eed"/>
   </p:sldIdLst>
   <p:sldSz cx="12192000" cy="6858000"/>
   <p:notesSz cx="6858000" cy="9144000"/>
@@ -1147,7 +1147,7 @@
   </p:cSld>
   <p:clrMap bg1="lt1" tx1="dk1" bg2="lt2" tx2="dk2" accent1="accent1" accent2="accent2" accent3="accent3" accent4="accent4" accent5="accent5" accent6="accent6" hlink="hlink" folHlink="folHlink"/>
   <p:sldLayoutIdLst>
-    <p:sldLayoutId xmlns:r="http://schemas.openxmlformats.org/officeDocument/2006/relationships" id="2147483649" r:id="R864299d6d7f0452f"/>
+    <p:sldLayoutId xmlns:r="http://schemas.openxmlformats.org/officeDocument/2006/relationships" id="2147483649" r:id="R283e423a1c3c430b"/>
   </p:sldLayoutIdLst>
   <p:txStyles>
     <p:titleStyle>
@@ -1695,10 +1695,10 @@
       </p:grpSpPr>
       <p:sp>
         <p:nvSpPr>
-          <p:cNvPr id="10" name="">
-            <a:extLst xmlns:a="http://schemas.openxmlformats.org/drawingml/2006/main">
-              <a:ext uri="{FF2B5EF4-FFF2-40B4-BE49-F238E27FC236}">
-                <a16:creationId xmlns:a16="http://schemas.microsoft.com/office/drawing/2014/main" id="{652F6633-0F08-40EE-9C46-11E4646324AB}"/>
+          <p:cNvPr id="9" name="">
+            <a:extLst xmlns:a="http://schemas.openxmlformats.org/drawingml/2006/main">
+              <a:ext uri="{FF2B5EF4-FFF2-40B4-BE49-F238E27FC236}">
+                <a16:creationId xmlns:a16="http://schemas.microsoft.com/office/drawing/2014/main" id="{1AA2030C-E467-4611-A488-7CA18E167098}"/>
               </a:ext>
             </a:extLst>
           </p:cNvPr>
@@ -1723,101 +1723,34 @@
           </a:ln>
         </p:spPr>
       </p:sp>
-      <p:sp>
-        <p:nvSpPr>
-          <p:cNvPr id="2" name="">
-            <a:extLst xmlns:a="http://schemas.openxmlformats.org/drawingml/2006/main">
-              <a:ext uri="{FF2B5EF4-FFF2-40B4-BE49-F238E27FC236}">
-                <a16:creationId xmlns:a16="http://schemas.microsoft.com/office/drawing/2014/main" id="{A2B8A4B0-559F-40D2-9C5B-D4033FE387AC}"/>
-              </a:ext>
-            </a:extLst>
-          </p:cNvPr>
-          <p:cNvSpPr>
-            <a:spLocks xmlns:a="http://schemas.openxmlformats.org/drawingml/2006/main" noGrp="1"/>
-          </p:cNvSpPr>
-          <p:nvPr/>
-        </p:nvSpPr>
+      <p:pic>
+        <p:nvPicPr>
+          <p:cNvPr id="10" name=""/>
+          <p:cNvPicPr>
+            <a:picLocks xmlns:a="http://schemas.openxmlformats.org/drawingml/2006/main" noChangeAspect="1"/>
+          </p:cNvPicPr>
+          <p:nvPr/>
+        </p:nvPicPr>
+        <p:blipFill>
+          <a:blip xmlns:r="http://schemas.openxmlformats.org/officeDocument/2006/relationships" xmlns:a="http://schemas.openxmlformats.org/drawingml/2006/main" r:embed="R45aca1739b3d40b9"/>
+          <a:stretch xmlns:a="http://schemas.openxmlformats.org/drawingml/2006/main"/>
+        </p:blipFill>
         <p:spPr>
           <a:xfrm xmlns:a="http://schemas.openxmlformats.org/drawingml/2006/main">
             <a:off x="666750" y="876300"/>
             <a:ext cx="590550" cy="590550"/>
           </a:xfrm>
-          <a:prstGeom xmlns:a="http://schemas.openxmlformats.org/drawingml/2006/main" prst="roundRect">
-            <a:avLst>
-              <a:gd name="adj" fmla="val 25806"/>
-            </a:avLst>
-          </a:prstGeom>
-          <a:solidFill xmlns:a="http://schemas.openxmlformats.org/drawingml/2006/main">
-            <a:srgbClr val="D8FE60"/>
-          </a:solidFill>
-          <a:ln xmlns:a="http://schemas.openxmlformats.org/drawingml/2006/main" w="0">
-            <a:noFill/>
-          </a:ln>
-        </p:spPr>
-      </p:sp>
+          <a:prstGeom xmlns:a="http://schemas.openxmlformats.org/drawingml/2006/main" prst="rect">
+            <a:avLst/>
+          </a:prstGeom>
+        </p:spPr>
+      </p:pic>
       <p:sp>
         <p:nvSpPr>
           <p:cNvPr id="3" name="">
             <a:extLst xmlns:a="http://schemas.openxmlformats.org/drawingml/2006/main">
               <a:ext uri="{FF2B5EF4-FFF2-40B4-BE49-F238E27FC236}">
-                <a16:creationId xmlns:a16="http://schemas.microsoft.com/office/drawing/2014/main" id="{0146ED6F-D51A-4DBC-B7B9-48188D87A92D}"/>
-              </a:ext>
-            </a:extLst>
-          </p:cNvPr>
-          <p:cNvSpPr>
-            <a:spLocks xmlns:a="http://schemas.openxmlformats.org/drawingml/2006/main" noGrp="1"/>
-          </p:cNvSpPr>
-          <p:nvPr/>
-        </p:nvSpPr>
-        <p:spPr>
-          <a:xfrm xmlns:a="http://schemas.openxmlformats.org/drawingml/2006/main">
-            <a:off x="866775" y="1000125"/>
-            <a:ext cx="247650" cy="323850"/>
-          </a:xfrm>
-          <a:prstGeom xmlns:a="http://schemas.openxmlformats.org/drawingml/2006/main" prst="rect">
-            <a:avLst/>
-          </a:prstGeom>
-          <a:noFill xmlns:a="http://schemas.openxmlformats.org/drawingml/2006/main"/>
-          <a:ln xmlns:a="http://schemas.openxmlformats.org/drawingml/2006/main" w="0">
-            <a:noFill/>
-          </a:ln>
-        </p:spPr>
-        <p:txBody>
-          <a:bodyPr xmlns:a="http://schemas.openxmlformats.org/drawingml/2006/main">
-            <a:normAutofit fontScale="42233"/>
-          </a:bodyPr>
-          <a:lstStyle xmlns:a="http://schemas.openxmlformats.org/drawingml/2006/main"/>
-          <a:p xmlns:a="http://schemas.openxmlformats.org/drawingml/2006/main">
-            <a:pPr>
-              <a:defRPr sz="1950" b="1">
-                <a:solidFill>
-                  <a:srgbClr val="10241E"/>
-                </a:solidFill>
-                <a:latin typeface="Segoe UI"/>
-                <a:ea typeface="Segoe UI"/>
-                <a:cs typeface="Segoe UI"/>
-              </a:defRPr>
-            </a:pPr>
-            <a:r>
-              <a:rPr sz="1950" b="1">
-                <a:solidFill>
-                  <a:srgbClr val="10241E"/>
-                </a:solidFill>
-                <a:latin typeface="Segoe UI"/>
-                <a:ea typeface="Segoe UI"/>
-                <a:cs typeface="Segoe UI"/>
-              </a:rPr>
-              <a:t>P</a:t>
-            </a:r>
-          </a:p>
-        </p:txBody>
-      </p:sp>
-      <p:sp>
-        <p:nvSpPr>
-          <p:cNvPr id="4" name="">
-            <a:extLst xmlns:a="http://schemas.openxmlformats.org/drawingml/2006/main">
-              <a:ext uri="{FF2B5EF4-FFF2-40B4-BE49-F238E27FC236}">
-                <a16:creationId xmlns:a16="http://schemas.microsoft.com/office/drawing/2014/main" id="{6A69917D-840D-48CE-BF22-B6615F45962C}"/>
+                <a16:creationId xmlns:a16="http://schemas.microsoft.com/office/drawing/2014/main" id="{FF1A0D73-D623-459D-A2AA-BC043694E5E1}"/>
               </a:ext>
             </a:extLst>
           </p:cNvPr>
@@ -1871,10 +1804,10 @@
       </p:sp>
       <p:sp>
         <p:nvSpPr>
-          <p:cNvPr id="5" name="">
-            <a:extLst xmlns:a="http://schemas.openxmlformats.org/drawingml/2006/main">
-              <a:ext uri="{FF2B5EF4-FFF2-40B4-BE49-F238E27FC236}">
-                <a16:creationId xmlns:a16="http://schemas.microsoft.com/office/drawing/2014/main" id="{8AF7B95A-8F60-4BC4-A0BD-8993AE64D7B1}"/>
+          <p:cNvPr id="4" name="">
+            <a:extLst xmlns:a="http://schemas.openxmlformats.org/drawingml/2006/main">
+              <a:ext uri="{FF2B5EF4-FFF2-40B4-BE49-F238E27FC236}">
+                <a16:creationId xmlns:a16="http://schemas.microsoft.com/office/drawing/2014/main" id="{15E22459-F465-4CCE-85E4-17F16F8F6AF2}"/>
               </a:ext>
             </a:extLst>
           </p:cNvPr>
@@ -1928,10 +1861,10 @@
       </p:sp>
       <p:sp>
         <p:nvSpPr>
-          <p:cNvPr id="6" name="">
-            <a:extLst xmlns:a="http://schemas.openxmlformats.org/drawingml/2006/main">
-              <a:ext uri="{FF2B5EF4-FFF2-40B4-BE49-F238E27FC236}">
-                <a16:creationId xmlns:a16="http://schemas.microsoft.com/office/drawing/2014/main" id="{5E78393F-50C6-45F9-9AC3-409BD58B9431}"/>
+          <p:cNvPr id="5" name="">
+            <a:extLst xmlns:a="http://schemas.openxmlformats.org/drawingml/2006/main">
+              <a:ext uri="{FF2B5EF4-FFF2-40B4-BE49-F238E27FC236}">
+                <a16:creationId xmlns:a16="http://schemas.microsoft.com/office/drawing/2014/main" id="{06DF41F6-8B97-4B29-9133-F3E7EA27FDB6}"/>
               </a:ext>
             </a:extLst>
           </p:cNvPr>
@@ -1958,10 +1891,10 @@
       </p:sp>
       <p:sp>
         <p:nvSpPr>
-          <p:cNvPr id="7" name="">
-            <a:extLst xmlns:a="http://schemas.openxmlformats.org/drawingml/2006/main">
-              <a:ext uri="{FF2B5EF4-FFF2-40B4-BE49-F238E27FC236}">
-                <a16:creationId xmlns:a16="http://schemas.microsoft.com/office/drawing/2014/main" id="{6ECA9CDA-7957-4D30-A83F-9E0EDAA804C5}"/>
+          <p:cNvPr id="6" name="">
+            <a:extLst xmlns:a="http://schemas.openxmlformats.org/drawingml/2006/main">
+              <a:ext uri="{FF2B5EF4-FFF2-40B4-BE49-F238E27FC236}">
+                <a16:creationId xmlns:a16="http://schemas.microsoft.com/office/drawing/2014/main" id="{67EC0D68-2F2D-43E0-9237-F6166547CED3}"/>
               </a:ext>
             </a:extLst>
           </p:cNvPr>
@@ -2015,10 +1948,10 @@
       </p:sp>
       <p:sp>
         <p:nvSpPr>
-          <p:cNvPr id="8" name="">
-            <a:extLst xmlns:a="http://schemas.openxmlformats.org/drawingml/2006/main">
-              <a:ext uri="{FF2B5EF4-FFF2-40B4-BE49-F238E27FC236}">
-                <a16:creationId xmlns:a16="http://schemas.microsoft.com/office/drawing/2014/main" id="{8881D0C6-1D81-452B-B2B2-102A0436A56C}"/>
+          <p:cNvPr id="7" name="">
+            <a:extLst xmlns:a="http://schemas.openxmlformats.org/drawingml/2006/main">
+              <a:ext uri="{FF2B5EF4-FFF2-40B4-BE49-F238E27FC236}">
+                <a16:creationId xmlns:a16="http://schemas.microsoft.com/office/drawing/2014/main" id="{B6E8F265-C36E-4153-A1F1-17D87197A86E}"/>
               </a:ext>
             </a:extLst>
           </p:cNvPr>
@@ -2072,10 +2005,10 @@
       </p:sp>
       <p:sp>
         <p:nvSpPr>
-          <p:cNvPr id="9" name="">
-            <a:extLst xmlns:a="http://schemas.openxmlformats.org/drawingml/2006/main">
-              <a:ext uri="{FF2B5EF4-FFF2-40B4-BE49-F238E27FC236}">
-                <a16:creationId xmlns:a16="http://schemas.microsoft.com/office/drawing/2014/main" id="{584BB79D-1E31-42B1-A6E0-C1D501104C97}"/>
+          <p:cNvPr id="8" name="">
+            <a:extLst xmlns:a="http://schemas.openxmlformats.org/drawingml/2006/main">
+              <a:ext uri="{FF2B5EF4-FFF2-40B4-BE49-F238E27FC236}">
+                <a16:creationId xmlns:a16="http://schemas.microsoft.com/office/drawing/2014/main" id="{66302412-59E0-4384-856A-BCE47FB9527C}"/>
               </a:ext>
             </a:extLst>
           </p:cNvPr>
@@ -2130,7 +2063,7 @@
     </p:spTree>
     <p:extLst>
       <p:ext uri="{BB962C8B-B14F-4D97-AF65-F5344CB8AC3E}">
-        <p14:creationId xmlns:p14="http://schemas.microsoft.com/office/powerpoint/2010/main" val="1151535639"/>
+        <p14:creationId xmlns:p14="http://schemas.microsoft.com/office/powerpoint/2010/main" val="1333567519"/>
       </p:ext>
     </p:extLst>
   </p:cSld>
@@ -2161,7 +2094,7 @@
           <p:cNvPr id="14" name="">
             <a:extLst xmlns:a="http://schemas.openxmlformats.org/drawingml/2006/main">
               <a:ext uri="{FF2B5EF4-FFF2-40B4-BE49-F238E27FC236}">
-                <a16:creationId xmlns:a16="http://schemas.microsoft.com/office/drawing/2014/main" id="{D4BD1695-F438-4979-9944-672DAD9B536F}"/>
+                <a16:creationId xmlns:a16="http://schemas.microsoft.com/office/drawing/2014/main" id="{5FDA3E90-47C2-4DC0-B633-A9AE9DF4FA5A}"/>
               </a:ext>
             </a:extLst>
           </p:cNvPr>
@@ -2191,7 +2124,7 @@
           <p:cNvPr id="2" name="">
             <a:extLst xmlns:a="http://schemas.openxmlformats.org/drawingml/2006/main">
               <a:ext uri="{FF2B5EF4-FFF2-40B4-BE49-F238E27FC236}">
-                <a16:creationId xmlns:a16="http://schemas.microsoft.com/office/drawing/2014/main" id="{927830D3-D931-4C05-88F5-5F0C492F3120}"/>
+                <a16:creationId xmlns:a16="http://schemas.microsoft.com/office/drawing/2014/main" id="{FFE9D182-848E-4ACA-BECB-24815C5BB15C}"/>
               </a:ext>
             </a:extLst>
           </p:cNvPr>
@@ -2248,7 +2181,7 @@
           <p:cNvPr id="3" name="">
             <a:extLst xmlns:a="http://schemas.openxmlformats.org/drawingml/2006/main">
               <a:ext uri="{FF2B5EF4-FFF2-40B4-BE49-F238E27FC236}">
-                <a16:creationId xmlns:a16="http://schemas.microsoft.com/office/drawing/2014/main" id="{1E5C9E5C-1482-47FE-9EE5-09100EF33664}"/>
+                <a16:creationId xmlns:a16="http://schemas.microsoft.com/office/drawing/2014/main" id="{FFA4CB6E-7A5C-4D43-B0E3-C6E9E4E47059}"/>
               </a:ext>
             </a:extLst>
           </p:cNvPr>
@@ -2305,7 +2238,7 @@
           <p:cNvPr id="4" name="">
             <a:extLst xmlns:a="http://schemas.openxmlformats.org/drawingml/2006/main">
               <a:ext uri="{FF2B5EF4-FFF2-40B4-BE49-F238E27FC236}">
-                <a16:creationId xmlns:a16="http://schemas.microsoft.com/office/drawing/2014/main" id="{B15F74E3-D022-47C0-BFA1-42D25778D441}"/>
+                <a16:creationId xmlns:a16="http://schemas.microsoft.com/office/drawing/2014/main" id="{CFABABAB-8A0A-489E-9686-02ED0EC4796F}"/>
               </a:ext>
             </a:extLst>
           </p:cNvPr>
@@ -2362,7 +2295,7 @@
           <p:cNvPr id="5" name="">
             <a:extLst xmlns:a="http://schemas.openxmlformats.org/drawingml/2006/main">
               <a:ext uri="{FF2B5EF4-FFF2-40B4-BE49-F238E27FC236}">
-                <a16:creationId xmlns:a16="http://schemas.microsoft.com/office/drawing/2014/main" id="{9FA57895-7CC0-41B8-839E-2C6EFDD867A0}"/>
+                <a16:creationId xmlns:a16="http://schemas.microsoft.com/office/drawing/2014/main" id="{D19A794A-E2A7-4C6D-B4BC-51C67584CB21}"/>
               </a:ext>
             </a:extLst>
           </p:cNvPr>
@@ -2419,7 +2352,7 @@
           <p:cNvPr id="6" name="">
             <a:extLst xmlns:a="http://schemas.openxmlformats.org/drawingml/2006/main">
               <a:ext uri="{FF2B5EF4-FFF2-40B4-BE49-F238E27FC236}">
-                <a16:creationId xmlns:a16="http://schemas.microsoft.com/office/drawing/2014/main" id="{7222CCCA-EDF5-45D7-8C46-9C9F81EF6F2E}"/>
+                <a16:creationId xmlns:a16="http://schemas.microsoft.com/office/drawing/2014/main" id="{921C3934-FFEA-497E-879B-237988A28B42}"/>
               </a:ext>
             </a:extLst>
           </p:cNvPr>
@@ -2454,7 +2387,7 @@
           <p:cNvPr id="7" name="">
             <a:extLst xmlns:a="http://schemas.openxmlformats.org/drawingml/2006/main">
               <a:ext uri="{FF2B5EF4-FFF2-40B4-BE49-F238E27FC236}">
-                <a16:creationId xmlns:a16="http://schemas.microsoft.com/office/drawing/2014/main" id="{BACD46DC-BF1B-4110-A5C9-334212D31D10}"/>
+                <a16:creationId xmlns:a16="http://schemas.microsoft.com/office/drawing/2014/main" id="{5DB600BF-79A2-40F3-B5DD-3CB2A6BCA424}"/>
               </a:ext>
             </a:extLst>
           </p:cNvPr>
@@ -2511,7 +2444,7 @@
           <p:cNvPr id="8" name="">
             <a:extLst xmlns:a="http://schemas.openxmlformats.org/drawingml/2006/main">
               <a:ext uri="{FF2B5EF4-FFF2-40B4-BE49-F238E27FC236}">
-                <a16:creationId xmlns:a16="http://schemas.microsoft.com/office/drawing/2014/main" id="{43FC82B7-DBCE-4FAE-A1C3-1F779963315B}"/>
+                <a16:creationId xmlns:a16="http://schemas.microsoft.com/office/drawing/2014/main" id="{2D0352FD-6904-4BED-8C33-07C7FEBFF990}"/>
               </a:ext>
             </a:extLst>
           </p:cNvPr>
@@ -2568,7 +2501,7 @@
           <p:cNvPr id="9" name="">
             <a:extLst xmlns:a="http://schemas.openxmlformats.org/drawingml/2006/main">
               <a:ext uri="{FF2B5EF4-FFF2-40B4-BE49-F238E27FC236}">
-                <a16:creationId xmlns:a16="http://schemas.microsoft.com/office/drawing/2014/main" id="{6AC430A7-68CC-49E3-AEFD-B2AC54726B0A}"/>
+                <a16:creationId xmlns:a16="http://schemas.microsoft.com/office/drawing/2014/main" id="{4569D770-E60F-4203-962A-C1A01C53E150}"/>
               </a:ext>
             </a:extLst>
           </p:cNvPr>
@@ -2625,7 +2558,7 @@
           <p:cNvPr id="10" name="">
             <a:extLst xmlns:a="http://schemas.openxmlformats.org/drawingml/2006/main">
               <a:ext uri="{FF2B5EF4-FFF2-40B4-BE49-F238E27FC236}">
-                <a16:creationId xmlns:a16="http://schemas.microsoft.com/office/drawing/2014/main" id="{B10C89BB-D937-46D9-97FE-EBCD44ED8D00}"/>
+                <a16:creationId xmlns:a16="http://schemas.microsoft.com/office/drawing/2014/main" id="{BDD29442-87D7-4A3E-ACD9-172E58AD4477}"/>
               </a:ext>
             </a:extLst>
           </p:cNvPr>
@@ -2660,7 +2593,7 @@
           <p:cNvPr id="11" name="">
             <a:extLst xmlns:a="http://schemas.openxmlformats.org/drawingml/2006/main">
               <a:ext uri="{FF2B5EF4-FFF2-40B4-BE49-F238E27FC236}">
-                <a16:creationId xmlns:a16="http://schemas.microsoft.com/office/drawing/2014/main" id="{F0638F0A-1B05-4D26-A7B1-AD17543AEAA3}"/>
+                <a16:creationId xmlns:a16="http://schemas.microsoft.com/office/drawing/2014/main" id="{19FE1DEB-4CB0-49F5-8C41-478DBE64D269}"/>
               </a:ext>
             </a:extLst>
           </p:cNvPr>
@@ -2717,7 +2650,7 @@
           <p:cNvPr id="12" name="">
             <a:extLst xmlns:a="http://schemas.openxmlformats.org/drawingml/2006/main">
               <a:ext uri="{FF2B5EF4-FFF2-40B4-BE49-F238E27FC236}">
-                <a16:creationId xmlns:a16="http://schemas.microsoft.com/office/drawing/2014/main" id="{F31053C0-347C-45C5-938F-9BCE571643EA}"/>
+                <a16:creationId xmlns:a16="http://schemas.microsoft.com/office/drawing/2014/main" id="{96ADF5D9-AF26-46B9-8AE4-6516FB5D1F0F}"/>
               </a:ext>
             </a:extLst>
           </p:cNvPr>
@@ -2774,7 +2707,7 @@
           <p:cNvPr id="13" name="">
             <a:extLst xmlns:a="http://schemas.openxmlformats.org/drawingml/2006/main">
               <a:ext uri="{FF2B5EF4-FFF2-40B4-BE49-F238E27FC236}">
-                <a16:creationId xmlns:a16="http://schemas.microsoft.com/office/drawing/2014/main" id="{ABEF105C-D07B-45DF-AADF-6FA923954E73}"/>
+                <a16:creationId xmlns:a16="http://schemas.microsoft.com/office/drawing/2014/main" id="{4D7F0B58-A1EE-4BF9-B591-CD84FF32CAF9}"/>
               </a:ext>
             </a:extLst>
           </p:cNvPr>
@@ -2829,7 +2762,7 @@
     </p:spTree>
     <p:extLst>
       <p:ext uri="{BB962C8B-B14F-4D97-AF65-F5344CB8AC3E}">
-        <p14:creationId xmlns:p14="http://schemas.microsoft.com/office/powerpoint/2010/main" val="707251013"/>
+        <p14:creationId xmlns:p14="http://schemas.microsoft.com/office/powerpoint/2010/main" val="210608071"/>
       </p:ext>
     </p:extLst>
   </p:cSld>
@@ -2860,7 +2793,7 @@
           <p:cNvPr id="17" name="">
             <a:extLst xmlns:a="http://schemas.openxmlformats.org/drawingml/2006/main">
               <a:ext uri="{FF2B5EF4-FFF2-40B4-BE49-F238E27FC236}">
-                <a16:creationId xmlns:a16="http://schemas.microsoft.com/office/drawing/2014/main" id="{624C79D0-B9DB-45F1-B91B-84C918C393D6}"/>
+                <a16:creationId xmlns:a16="http://schemas.microsoft.com/office/drawing/2014/main" id="{3951B51A-9BDF-4680-9F37-F269DED6BDA4}"/>
               </a:ext>
             </a:extLst>
           </p:cNvPr>
@@ -2890,7 +2823,7 @@
           <p:cNvPr id="2" name="">
             <a:extLst xmlns:a="http://schemas.openxmlformats.org/drawingml/2006/main">
               <a:ext uri="{FF2B5EF4-FFF2-40B4-BE49-F238E27FC236}">
-                <a16:creationId xmlns:a16="http://schemas.microsoft.com/office/drawing/2014/main" id="{54637137-8C0D-44C1-A705-6EDDB6FC56AE}"/>
+                <a16:creationId xmlns:a16="http://schemas.microsoft.com/office/drawing/2014/main" id="{40081D88-86C2-42BD-A4DA-6E497E688FE4}"/>
               </a:ext>
             </a:extLst>
           </p:cNvPr>
@@ -2947,7 +2880,7 @@
           <p:cNvPr id="3" name="">
             <a:extLst xmlns:a="http://schemas.openxmlformats.org/drawingml/2006/main">
               <a:ext uri="{FF2B5EF4-FFF2-40B4-BE49-F238E27FC236}">
-                <a16:creationId xmlns:a16="http://schemas.microsoft.com/office/drawing/2014/main" id="{A216648B-F7F8-4A97-847E-50F27617090B}"/>
+                <a16:creationId xmlns:a16="http://schemas.microsoft.com/office/drawing/2014/main" id="{BB21AF2D-DDD4-4D70-8CA3-C813D1E8EAAE}"/>
               </a:ext>
             </a:extLst>
           </p:cNvPr>
@@ -3004,7 +2937,7 @@
           <p:cNvPr id="4" name="">
             <a:extLst xmlns:a="http://schemas.openxmlformats.org/drawingml/2006/main">
               <a:ext uri="{FF2B5EF4-FFF2-40B4-BE49-F238E27FC236}">
-                <a16:creationId xmlns:a16="http://schemas.microsoft.com/office/drawing/2014/main" id="{789C4A39-60B0-4889-818B-029A1F83352C}"/>
+                <a16:creationId xmlns:a16="http://schemas.microsoft.com/office/drawing/2014/main" id="{343346F2-77D3-4DE2-B3A2-0D4FA988B35F}"/>
               </a:ext>
             </a:extLst>
           </p:cNvPr>
@@ -3061,7 +2994,7 @@
           <p:cNvPr id="5" name="">
             <a:extLst xmlns:a="http://schemas.openxmlformats.org/drawingml/2006/main">
               <a:ext uri="{FF2B5EF4-FFF2-40B4-BE49-F238E27FC236}">
-                <a16:creationId xmlns:a16="http://schemas.microsoft.com/office/drawing/2014/main" id="{07BD8F85-DDB4-4DE7-859C-C68E8F3F8FC8}"/>
+                <a16:creationId xmlns:a16="http://schemas.microsoft.com/office/drawing/2014/main" id="{536CFE1E-6111-4D5D-8F64-60F1CC995F7A}"/>
               </a:ext>
             </a:extLst>
           </p:cNvPr>
@@ -3100,7 +3033,7 @@
           <p:nvPr/>
         </p:nvPicPr>
         <p:blipFill>
-          <a:blip xmlns:r="http://schemas.openxmlformats.org/officeDocument/2006/relationships" xmlns:a="http://schemas.openxmlformats.org/drawingml/2006/main" r:embed="Rd7334f00865149f7"/>
+          <a:blip xmlns:r="http://schemas.openxmlformats.org/officeDocument/2006/relationships" xmlns:a="http://schemas.openxmlformats.org/drawingml/2006/main" r:embed="R32d7f5f388c141db"/>
           <a:srcRect xmlns:a="http://schemas.openxmlformats.org/drawingml/2006/main" l="0" t="18027" r="0" b="18027"/>
           <a:stretch xmlns:a="http://schemas.openxmlformats.org/drawingml/2006/main">
             <a:fillRect l="0" t="0" r="0" b="0"/>
@@ -3123,7 +3056,7 @@
           <p:cNvPr id="7" name="">
             <a:extLst xmlns:a="http://schemas.openxmlformats.org/drawingml/2006/main">
               <a:ext uri="{FF2B5EF4-FFF2-40B4-BE49-F238E27FC236}">
-                <a16:creationId xmlns:a16="http://schemas.microsoft.com/office/drawing/2014/main" id="{0A424F1E-BFE4-423A-88CF-C63ED0F05708}"/>
+                <a16:creationId xmlns:a16="http://schemas.microsoft.com/office/drawing/2014/main" id="{E4B282D1-2E5F-4D07-B5AE-2B2135BBF851}"/>
               </a:ext>
             </a:extLst>
           </p:cNvPr>
@@ -3180,7 +3113,7 @@
           <p:cNvPr id="8" name="">
             <a:extLst xmlns:a="http://schemas.openxmlformats.org/drawingml/2006/main">
               <a:ext uri="{FF2B5EF4-FFF2-40B4-BE49-F238E27FC236}">
-                <a16:creationId xmlns:a16="http://schemas.microsoft.com/office/drawing/2014/main" id="{D109E68E-C061-4B12-917C-704FDDA36FBC}"/>
+                <a16:creationId xmlns:a16="http://schemas.microsoft.com/office/drawing/2014/main" id="{4AB6F316-595E-439E-90CE-9FA6D56253FE}"/>
               </a:ext>
             </a:extLst>
           </p:cNvPr>
@@ -3237,7 +3170,7 @@
           <p:cNvPr id="9" name="">
             <a:extLst xmlns:a="http://schemas.openxmlformats.org/drawingml/2006/main">
               <a:ext uri="{FF2B5EF4-FFF2-40B4-BE49-F238E27FC236}">
-                <a16:creationId xmlns:a16="http://schemas.microsoft.com/office/drawing/2014/main" id="{6A942598-1FE5-414C-9BD7-D0EA7E513B60}"/>
+                <a16:creationId xmlns:a16="http://schemas.microsoft.com/office/drawing/2014/main" id="{DC26FD7B-81DB-4EC0-BDAB-59406B92EAE5}"/>
               </a:ext>
             </a:extLst>
           </p:cNvPr>
@@ -3294,7 +3227,7 @@
           <p:cNvPr id="10" name="">
             <a:extLst xmlns:a="http://schemas.openxmlformats.org/drawingml/2006/main">
               <a:ext uri="{FF2B5EF4-FFF2-40B4-BE49-F238E27FC236}">
-                <a16:creationId xmlns:a16="http://schemas.microsoft.com/office/drawing/2014/main" id="{42366604-B305-4BEC-ADC7-A05B05E642C4}"/>
+                <a16:creationId xmlns:a16="http://schemas.microsoft.com/office/drawing/2014/main" id="{688EAF51-632F-4632-86D1-D60BC97017FB}"/>
               </a:ext>
             </a:extLst>
           </p:cNvPr>
@@ -3351,7 +3284,7 @@
           <p:cNvPr id="11" name="">
             <a:extLst xmlns:a="http://schemas.openxmlformats.org/drawingml/2006/main">
               <a:ext uri="{FF2B5EF4-FFF2-40B4-BE49-F238E27FC236}">
-                <a16:creationId xmlns:a16="http://schemas.microsoft.com/office/drawing/2014/main" id="{54091C48-5AD9-4492-96C8-4576D780E00B}"/>
+                <a16:creationId xmlns:a16="http://schemas.microsoft.com/office/drawing/2014/main" id="{11ACADAB-DD97-4636-94E7-0FD11E29CBC5}"/>
               </a:ext>
             </a:extLst>
           </p:cNvPr>
@@ -3408,7 +3341,7 @@
           <p:cNvPr id="12" name="">
             <a:extLst xmlns:a="http://schemas.openxmlformats.org/drawingml/2006/main">
               <a:ext uri="{FF2B5EF4-FFF2-40B4-BE49-F238E27FC236}">
-                <a16:creationId xmlns:a16="http://schemas.microsoft.com/office/drawing/2014/main" id="{08D955DE-4A03-4108-9390-D4BAAAD44791}"/>
+                <a16:creationId xmlns:a16="http://schemas.microsoft.com/office/drawing/2014/main" id="{9BE56A8B-BDF6-4720-85D6-B27C7441409B}"/>
               </a:ext>
             </a:extLst>
           </p:cNvPr>
@@ -3465,7 +3398,7 @@
           <p:cNvPr id="13" name="">
             <a:extLst xmlns:a="http://schemas.openxmlformats.org/drawingml/2006/main">
               <a:ext uri="{FF2B5EF4-FFF2-40B4-BE49-F238E27FC236}">
-                <a16:creationId xmlns:a16="http://schemas.microsoft.com/office/drawing/2014/main" id="{DE5BEBC8-C25F-4F08-9B56-E59A9B676D0A}"/>
+                <a16:creationId xmlns:a16="http://schemas.microsoft.com/office/drawing/2014/main" id="{E3518093-09BB-4813-B3AD-F9FCF96337AC}"/>
               </a:ext>
             </a:extLst>
           </p:cNvPr>
@@ -3522,7 +3455,7 @@
           <p:cNvPr id="14" name="">
             <a:extLst xmlns:a="http://schemas.openxmlformats.org/drawingml/2006/main">
               <a:ext uri="{FF2B5EF4-FFF2-40B4-BE49-F238E27FC236}">
-                <a16:creationId xmlns:a16="http://schemas.microsoft.com/office/drawing/2014/main" id="{511DEC40-D21E-4741-A36F-1587E98C5F00}"/>
+                <a16:creationId xmlns:a16="http://schemas.microsoft.com/office/drawing/2014/main" id="{4158B652-58CF-4536-BC4F-BEEC5F460746}"/>
               </a:ext>
             </a:extLst>
           </p:cNvPr>
@@ -3579,7 +3512,7 @@
           <p:cNvPr id="15" name="">
             <a:extLst xmlns:a="http://schemas.openxmlformats.org/drawingml/2006/main">
               <a:ext uri="{FF2B5EF4-FFF2-40B4-BE49-F238E27FC236}">
-                <a16:creationId xmlns:a16="http://schemas.microsoft.com/office/drawing/2014/main" id="{F939FBC7-47F4-4A0F-AABF-4F31D49BD703}"/>
+                <a16:creationId xmlns:a16="http://schemas.microsoft.com/office/drawing/2014/main" id="{E3E518E1-8E84-4A56-92F4-70641A4F0602}"/>
               </a:ext>
             </a:extLst>
           </p:cNvPr>
@@ -3636,7 +3569,7 @@
           <p:cNvPr id="16" name="">
             <a:extLst xmlns:a="http://schemas.openxmlformats.org/drawingml/2006/main">
               <a:ext uri="{FF2B5EF4-FFF2-40B4-BE49-F238E27FC236}">
-                <a16:creationId xmlns:a16="http://schemas.microsoft.com/office/drawing/2014/main" id="{DB2F0947-5B4D-4C1B-9DB8-C1444C4CBC59}"/>
+                <a16:creationId xmlns:a16="http://schemas.microsoft.com/office/drawing/2014/main" id="{5858696C-B8CA-41A4-BA33-EFB583A6DDD5}"/>
               </a:ext>
             </a:extLst>
           </p:cNvPr>
@@ -3691,7 +3624,7 @@
     </p:spTree>
     <p:extLst>
       <p:ext uri="{BB962C8B-B14F-4D97-AF65-F5344CB8AC3E}">
-        <p14:creationId xmlns:p14="http://schemas.microsoft.com/office/powerpoint/2010/main" val="669813906"/>
+        <p14:creationId xmlns:p14="http://schemas.microsoft.com/office/powerpoint/2010/main" val="799336920"/>
       </p:ext>
     </p:extLst>
   </p:cSld>
@@ -3722,7 +3655,7 @@
           <p:cNvPr id="32" name="">
             <a:extLst xmlns:a="http://schemas.openxmlformats.org/drawingml/2006/main">
               <a:ext uri="{FF2B5EF4-FFF2-40B4-BE49-F238E27FC236}">
-                <a16:creationId xmlns:a16="http://schemas.microsoft.com/office/drawing/2014/main" id="{638EF0CD-8730-451A-B05B-AA634AFB3E16}"/>
+                <a16:creationId xmlns:a16="http://schemas.microsoft.com/office/drawing/2014/main" id="{FE2402BC-AFBE-4F1E-8088-DE9ECD101368}"/>
               </a:ext>
             </a:extLst>
           </p:cNvPr>
@@ -3752,7 +3685,7 @@
           <p:cNvPr id="2" name="">
             <a:extLst xmlns:a="http://schemas.openxmlformats.org/drawingml/2006/main">
               <a:ext uri="{FF2B5EF4-FFF2-40B4-BE49-F238E27FC236}">
-                <a16:creationId xmlns:a16="http://schemas.microsoft.com/office/drawing/2014/main" id="{0423213A-8756-4E21-8C9F-7E4382FDEE13}"/>
+                <a16:creationId xmlns:a16="http://schemas.microsoft.com/office/drawing/2014/main" id="{233CA25A-2C9D-4952-BE2F-C85FA1D963DA}"/>
               </a:ext>
             </a:extLst>
           </p:cNvPr>
@@ -3809,7 +3742,7 @@
           <p:cNvPr id="3" name="">
             <a:extLst xmlns:a="http://schemas.openxmlformats.org/drawingml/2006/main">
               <a:ext uri="{FF2B5EF4-FFF2-40B4-BE49-F238E27FC236}">
-                <a16:creationId xmlns:a16="http://schemas.microsoft.com/office/drawing/2014/main" id="{84F50D7E-7A74-429F-9748-8F121F896913}"/>
+                <a16:creationId xmlns:a16="http://schemas.microsoft.com/office/drawing/2014/main" id="{A41E9D5C-E8B9-4705-AAD4-929ABF4E956B}"/>
               </a:ext>
             </a:extLst>
           </p:cNvPr>
@@ -3866,7 +3799,7 @@
           <p:cNvPr id="4" name="">
             <a:extLst xmlns:a="http://schemas.openxmlformats.org/drawingml/2006/main">
               <a:ext uri="{FF2B5EF4-FFF2-40B4-BE49-F238E27FC236}">
-                <a16:creationId xmlns:a16="http://schemas.microsoft.com/office/drawing/2014/main" id="{BC6224D0-BC8D-4DD3-95F4-D457D72DBD76}"/>
+                <a16:creationId xmlns:a16="http://schemas.microsoft.com/office/drawing/2014/main" id="{C77E6691-E6D6-401F-ADB3-E4EAD3E76D33}"/>
               </a:ext>
             </a:extLst>
           </p:cNvPr>
@@ -3923,7 +3856,7 @@
           <p:cNvPr id="5" name="">
             <a:extLst xmlns:a="http://schemas.openxmlformats.org/drawingml/2006/main">
               <a:ext uri="{FF2B5EF4-FFF2-40B4-BE49-F238E27FC236}">
-                <a16:creationId xmlns:a16="http://schemas.microsoft.com/office/drawing/2014/main" id="{C5F494FC-F287-42B9-A384-A592190BFCF3}"/>
+                <a16:creationId xmlns:a16="http://schemas.microsoft.com/office/drawing/2014/main" id="{35822A1F-B5B2-4196-8F10-92FE94D29C4A}"/>
               </a:ext>
             </a:extLst>
           </p:cNvPr>
@@ -3958,7 +3891,7 @@
           <p:cNvPr id="6" name="">
             <a:extLst xmlns:a="http://schemas.openxmlformats.org/drawingml/2006/main">
               <a:ext uri="{FF2B5EF4-FFF2-40B4-BE49-F238E27FC236}">
-                <a16:creationId xmlns:a16="http://schemas.microsoft.com/office/drawing/2014/main" id="{B1125396-49DC-4284-ADC6-0A8E54A1CAAD}"/>
+                <a16:creationId xmlns:a16="http://schemas.microsoft.com/office/drawing/2014/main" id="{08056DBF-849A-4755-B99C-B34133247EBE}"/>
               </a:ext>
             </a:extLst>
           </p:cNvPr>
@@ -4015,7 +3948,7 @@
           <p:cNvPr id="7" name="">
             <a:extLst xmlns:a="http://schemas.openxmlformats.org/drawingml/2006/main">
               <a:ext uri="{FF2B5EF4-FFF2-40B4-BE49-F238E27FC236}">
-                <a16:creationId xmlns:a16="http://schemas.microsoft.com/office/drawing/2014/main" id="{D963FD29-3C46-4606-9AF2-9BC1B403AB1B}"/>
+                <a16:creationId xmlns:a16="http://schemas.microsoft.com/office/drawing/2014/main" id="{A028AD4E-1838-4FCD-95A2-B903454AB4E3}"/>
               </a:ext>
             </a:extLst>
           </p:cNvPr>
@@ -4072,7 +4005,7 @@
           <p:cNvPr id="8" name="">
             <a:extLst xmlns:a="http://schemas.openxmlformats.org/drawingml/2006/main">
               <a:ext uri="{FF2B5EF4-FFF2-40B4-BE49-F238E27FC236}">
-                <a16:creationId xmlns:a16="http://schemas.microsoft.com/office/drawing/2014/main" id="{FAC1F1CC-0733-414E-8A7C-CD9754FF482C}"/>
+                <a16:creationId xmlns:a16="http://schemas.microsoft.com/office/drawing/2014/main" id="{196134A7-CAD6-4975-B1E8-153351ED2455}"/>
               </a:ext>
             </a:extLst>
           </p:cNvPr>
@@ -4107,7 +4040,7 @@
           <p:cNvPr id="9" name="">
             <a:extLst xmlns:a="http://schemas.openxmlformats.org/drawingml/2006/main">
               <a:ext uri="{FF2B5EF4-FFF2-40B4-BE49-F238E27FC236}">
-                <a16:creationId xmlns:a16="http://schemas.microsoft.com/office/drawing/2014/main" id="{950981D7-0A78-455E-A241-AB71FBEC7417}"/>
+                <a16:creationId xmlns:a16="http://schemas.microsoft.com/office/drawing/2014/main" id="{33460A2F-A8D0-4857-8C19-E36246B1EE22}"/>
               </a:ext>
             </a:extLst>
           </p:cNvPr>
@@ -4164,7 +4097,7 @@
           <p:cNvPr id="10" name="">
             <a:extLst xmlns:a="http://schemas.openxmlformats.org/drawingml/2006/main">
               <a:ext uri="{FF2B5EF4-FFF2-40B4-BE49-F238E27FC236}">
-                <a16:creationId xmlns:a16="http://schemas.microsoft.com/office/drawing/2014/main" id="{9AC16169-73D8-483E-80DB-7160988CD635}"/>
+                <a16:creationId xmlns:a16="http://schemas.microsoft.com/office/drawing/2014/main" id="{4CFA3DDB-7C65-4B6D-8F27-BFD108D8C1CD}"/>
               </a:ext>
             </a:extLst>
           </p:cNvPr>
@@ -4221,7 +4154,7 @@
           <p:cNvPr id="11" name="">
             <a:extLst xmlns:a="http://schemas.openxmlformats.org/drawingml/2006/main">
               <a:ext uri="{FF2B5EF4-FFF2-40B4-BE49-F238E27FC236}">
-                <a16:creationId xmlns:a16="http://schemas.microsoft.com/office/drawing/2014/main" id="{8615C670-3207-4DE2-9543-2532593DEAD3}"/>
+                <a16:creationId xmlns:a16="http://schemas.microsoft.com/office/drawing/2014/main" id="{23794B59-B826-4BEE-BE66-849CB124861E}"/>
               </a:ext>
             </a:extLst>
           </p:cNvPr>
@@ -4256,7 +4189,7 @@
           <p:cNvPr id="12" name="">
             <a:extLst xmlns:a="http://schemas.openxmlformats.org/drawingml/2006/main">
               <a:ext uri="{FF2B5EF4-FFF2-40B4-BE49-F238E27FC236}">
-                <a16:creationId xmlns:a16="http://schemas.microsoft.com/office/drawing/2014/main" id="{FA3003AF-A9BE-4157-8177-50C20284D2BF}"/>
+                <a16:creationId xmlns:a16="http://schemas.microsoft.com/office/drawing/2014/main" id="{2CD5EEF7-79BC-437D-960A-040B84F896AF}"/>
               </a:ext>
             </a:extLst>
           </p:cNvPr>
@@ -4313,7 +4246,7 @@
           <p:cNvPr id="13" name="">
             <a:extLst xmlns:a="http://schemas.openxmlformats.org/drawingml/2006/main">
               <a:ext uri="{FF2B5EF4-FFF2-40B4-BE49-F238E27FC236}">
-                <a16:creationId xmlns:a16="http://schemas.microsoft.com/office/drawing/2014/main" id="{F62DC4C0-51F3-4CCC-86A4-AC31DF6E60D9}"/>
+                <a16:creationId xmlns:a16="http://schemas.microsoft.com/office/drawing/2014/main" id="{CFFF5713-717C-40CD-A55E-0B47A75266A1}"/>
               </a:ext>
             </a:extLst>
           </p:cNvPr>
@@ -4393,7 +4326,7 @@
           <p:cNvPr id="14" name="">
             <a:extLst xmlns:a="http://schemas.openxmlformats.org/drawingml/2006/main">
               <a:ext uri="{FF2B5EF4-FFF2-40B4-BE49-F238E27FC236}">
-                <a16:creationId xmlns:a16="http://schemas.microsoft.com/office/drawing/2014/main" id="{D74C6B74-5810-4989-92BC-7EB568C09E02}"/>
+                <a16:creationId xmlns:a16="http://schemas.microsoft.com/office/drawing/2014/main" id="{919586C1-3851-40AC-98F4-22AB44CEB69D}"/>
               </a:ext>
             </a:extLst>
           </p:cNvPr>
@@ -4428,7 +4361,7 @@
           <p:cNvPr id="15" name="">
             <a:extLst xmlns:a="http://schemas.openxmlformats.org/drawingml/2006/main">
               <a:ext uri="{FF2B5EF4-FFF2-40B4-BE49-F238E27FC236}">
-                <a16:creationId xmlns:a16="http://schemas.microsoft.com/office/drawing/2014/main" id="{6865C078-7239-4E16-BC83-DE906BF595D6}"/>
+                <a16:creationId xmlns:a16="http://schemas.microsoft.com/office/drawing/2014/main" id="{D782C08E-B587-4C38-9B73-4F74D942E474}"/>
               </a:ext>
             </a:extLst>
           </p:cNvPr>
@@ -4485,7 +4418,7 @@
           <p:cNvPr id="16" name="">
             <a:extLst xmlns:a="http://schemas.openxmlformats.org/drawingml/2006/main">
               <a:ext uri="{FF2B5EF4-FFF2-40B4-BE49-F238E27FC236}">
-                <a16:creationId xmlns:a16="http://schemas.microsoft.com/office/drawing/2014/main" id="{6ABEE1A3-5B14-4233-A20A-F207B5F2ABDA}"/>
+                <a16:creationId xmlns:a16="http://schemas.microsoft.com/office/drawing/2014/main" id="{45E08C51-3F0B-4200-BF4C-F7B8A720B612}"/>
               </a:ext>
             </a:extLst>
           </p:cNvPr>
@@ -4620,7 +4553,7 @@
           <p:cNvPr id="20" name="">
             <a:extLst xmlns:a="http://schemas.openxmlformats.org/drawingml/2006/main">
               <a:ext uri="{FF2B5EF4-FFF2-40B4-BE49-F238E27FC236}">
-                <a16:creationId xmlns:a16="http://schemas.microsoft.com/office/drawing/2014/main" id="{9E9CA0D5-53CB-4106-9994-E96313963587}"/>
+                <a16:creationId xmlns:a16="http://schemas.microsoft.com/office/drawing/2014/main" id="{A91835E4-C3B7-4DCD-A1A4-F39554308A3C}"/>
               </a:ext>
             </a:extLst>
           </p:cNvPr>
@@ -4655,7 +4588,7 @@
           <p:cNvPr id="21" name="">
             <a:extLst xmlns:a="http://schemas.openxmlformats.org/drawingml/2006/main">
               <a:ext uri="{FF2B5EF4-FFF2-40B4-BE49-F238E27FC236}">
-                <a16:creationId xmlns:a16="http://schemas.microsoft.com/office/drawing/2014/main" id="{8CEB9AD3-8674-4FA4-9BF8-66B2B16F2B53}"/>
+                <a16:creationId xmlns:a16="http://schemas.microsoft.com/office/drawing/2014/main" id="{ACD2520A-813B-4381-BDA8-826EDBF6167A}"/>
               </a:ext>
             </a:extLst>
           </p:cNvPr>
@@ -4712,7 +4645,7 @@
           <p:cNvPr id="22" name="">
             <a:extLst xmlns:a="http://schemas.openxmlformats.org/drawingml/2006/main">
               <a:ext uri="{FF2B5EF4-FFF2-40B4-BE49-F238E27FC236}">
-                <a16:creationId xmlns:a16="http://schemas.microsoft.com/office/drawing/2014/main" id="{0E191595-CEA6-449B-B7BC-FB78AC4610A1}"/>
+                <a16:creationId xmlns:a16="http://schemas.microsoft.com/office/drawing/2014/main" id="{A9A33CFC-1DFF-4762-9266-16798A76A54C}"/>
               </a:ext>
             </a:extLst>
           </p:cNvPr>
@@ -4769,7 +4702,7 @@
           <p:cNvPr id="23" name="">
             <a:extLst xmlns:a="http://schemas.openxmlformats.org/drawingml/2006/main">
               <a:ext uri="{FF2B5EF4-FFF2-40B4-BE49-F238E27FC236}">
-                <a16:creationId xmlns:a16="http://schemas.microsoft.com/office/drawing/2014/main" id="{789FD189-A425-4D34-9895-A25232789590}"/>
+                <a16:creationId xmlns:a16="http://schemas.microsoft.com/office/drawing/2014/main" id="{F7C2E845-B1F2-4AD5-BE2D-6591285BB33D}"/>
               </a:ext>
             </a:extLst>
           </p:cNvPr>
@@ -4804,7 +4737,7 @@
           <p:cNvPr id="24" name="">
             <a:extLst xmlns:a="http://schemas.openxmlformats.org/drawingml/2006/main">
               <a:ext uri="{FF2B5EF4-FFF2-40B4-BE49-F238E27FC236}">
-                <a16:creationId xmlns:a16="http://schemas.microsoft.com/office/drawing/2014/main" id="{11C1EDD1-D3C5-4C41-BAE7-2F3BD5AB8439}"/>
+                <a16:creationId xmlns:a16="http://schemas.microsoft.com/office/drawing/2014/main" id="{55889E3F-55AE-411C-BE8B-8B527556F74B}"/>
               </a:ext>
             </a:extLst>
           </p:cNvPr>
@@ -4861,7 +4794,7 @@
           <p:cNvPr id="25" name="">
             <a:extLst xmlns:a="http://schemas.openxmlformats.org/drawingml/2006/main">
               <a:ext uri="{FF2B5EF4-FFF2-40B4-BE49-F238E27FC236}">
-                <a16:creationId xmlns:a16="http://schemas.microsoft.com/office/drawing/2014/main" id="{545AA748-3E26-4403-9120-5FD5010E34BF}"/>
+                <a16:creationId xmlns:a16="http://schemas.microsoft.com/office/drawing/2014/main" id="{888A349E-984D-4FF0-97BF-7AA415B633D1}"/>
               </a:ext>
             </a:extLst>
           </p:cNvPr>
@@ -4964,7 +4897,7 @@
           <p:cNvPr id="26" name="">
             <a:extLst xmlns:a="http://schemas.openxmlformats.org/drawingml/2006/main">
               <a:ext uri="{FF2B5EF4-FFF2-40B4-BE49-F238E27FC236}">
-                <a16:creationId xmlns:a16="http://schemas.microsoft.com/office/drawing/2014/main" id="{CDB9B77D-1A5E-4349-AA28-F8EB02362352}"/>
+                <a16:creationId xmlns:a16="http://schemas.microsoft.com/office/drawing/2014/main" id="{4D6C0BF4-543D-4C1B-98F0-274F5688389F}"/>
               </a:ext>
             </a:extLst>
           </p:cNvPr>
@@ -4999,7 +4932,7 @@
           <p:cNvPr id="27" name="">
             <a:extLst xmlns:a="http://schemas.openxmlformats.org/drawingml/2006/main">
               <a:ext uri="{FF2B5EF4-FFF2-40B4-BE49-F238E27FC236}">
-                <a16:creationId xmlns:a16="http://schemas.microsoft.com/office/drawing/2014/main" id="{22DEA5A4-2547-4DEB-98A4-518075DAFAD6}"/>
+                <a16:creationId xmlns:a16="http://schemas.microsoft.com/office/drawing/2014/main" id="{C289EA76-C4F1-4013-987E-CBDB5E5B2A3B}"/>
               </a:ext>
             </a:extLst>
           </p:cNvPr>
@@ -5056,7 +4989,7 @@
           <p:cNvPr id="28" name="">
             <a:extLst xmlns:a="http://schemas.openxmlformats.org/drawingml/2006/main">
               <a:ext uri="{FF2B5EF4-FFF2-40B4-BE49-F238E27FC236}">
-                <a16:creationId xmlns:a16="http://schemas.microsoft.com/office/drawing/2014/main" id="{D1CD9CE6-BF8C-4410-A3B8-7A15FDF21F81}"/>
+                <a16:creationId xmlns:a16="http://schemas.microsoft.com/office/drawing/2014/main" id="{63D64BE2-89AB-436A-9161-726404BE406B}"/>
               </a:ext>
             </a:extLst>
           </p:cNvPr>
@@ -5211,7 +5144,7 @@
           <p:cNvPr id="31" name="">
             <a:extLst xmlns:a="http://schemas.openxmlformats.org/drawingml/2006/main">
               <a:ext uri="{FF2B5EF4-FFF2-40B4-BE49-F238E27FC236}">
-                <a16:creationId xmlns:a16="http://schemas.microsoft.com/office/drawing/2014/main" id="{EFE0CF0B-1A06-47A8-A698-E3F8C1B7C859}"/>
+                <a16:creationId xmlns:a16="http://schemas.microsoft.com/office/drawing/2014/main" id="{39C4C26B-2BC9-4359-9690-C85EACDE1779}"/>
               </a:ext>
             </a:extLst>
           </p:cNvPr>
@@ -5266,7 +5199,7 @@
     </p:spTree>
     <p:extLst>
       <p:ext uri="{BB962C8B-B14F-4D97-AF65-F5344CB8AC3E}">
-        <p14:creationId xmlns:p14="http://schemas.microsoft.com/office/powerpoint/2010/main" val="1907257591"/>
+        <p14:creationId xmlns:p14="http://schemas.microsoft.com/office/powerpoint/2010/main" val="394963305"/>
       </p:ext>
     </p:extLst>
   </p:cSld>
@@ -5297,7 +5230,7 @@
           <p:cNvPr id="21" name="">
             <a:extLst xmlns:a="http://schemas.openxmlformats.org/drawingml/2006/main">
               <a:ext uri="{FF2B5EF4-FFF2-40B4-BE49-F238E27FC236}">
-                <a16:creationId xmlns:a16="http://schemas.microsoft.com/office/drawing/2014/main" id="{60D87F64-6E74-4A91-8253-AD4A9CBF0C85}"/>
+                <a16:creationId xmlns:a16="http://schemas.microsoft.com/office/drawing/2014/main" id="{714628D4-207B-463F-B4F0-55BBA6E54B16}"/>
               </a:ext>
             </a:extLst>
           </p:cNvPr>
@@ -5327,7 +5260,7 @@
           <p:cNvPr id="2" name="">
             <a:extLst xmlns:a="http://schemas.openxmlformats.org/drawingml/2006/main">
               <a:ext uri="{FF2B5EF4-FFF2-40B4-BE49-F238E27FC236}">
-                <a16:creationId xmlns:a16="http://schemas.microsoft.com/office/drawing/2014/main" id="{8FC6F4BB-D08D-4EB8-BECB-BADD336E35F7}"/>
+                <a16:creationId xmlns:a16="http://schemas.microsoft.com/office/drawing/2014/main" id="{C79A70D1-B483-4A15-87D7-DAA9B02AB4AE}"/>
               </a:ext>
             </a:extLst>
           </p:cNvPr>
@@ -5384,7 +5317,7 @@
           <p:cNvPr id="3" name="">
             <a:extLst xmlns:a="http://schemas.openxmlformats.org/drawingml/2006/main">
               <a:ext uri="{FF2B5EF4-FFF2-40B4-BE49-F238E27FC236}">
-                <a16:creationId xmlns:a16="http://schemas.microsoft.com/office/drawing/2014/main" id="{B8DE3B9D-DAA8-4DB7-8A4B-C1DCBA505DC3}"/>
+                <a16:creationId xmlns:a16="http://schemas.microsoft.com/office/drawing/2014/main" id="{2A2508CD-4129-4146-815D-FA33A3252294}"/>
               </a:ext>
             </a:extLst>
           </p:cNvPr>
@@ -5441,7 +5374,7 @@
           <p:cNvPr id="4" name="">
             <a:extLst xmlns:a="http://schemas.openxmlformats.org/drawingml/2006/main">
               <a:ext uri="{FF2B5EF4-FFF2-40B4-BE49-F238E27FC236}">
-                <a16:creationId xmlns:a16="http://schemas.microsoft.com/office/drawing/2014/main" id="{E84F22C7-6C7A-46A1-BC64-D7AECA7951DA}"/>
+                <a16:creationId xmlns:a16="http://schemas.microsoft.com/office/drawing/2014/main" id="{902957E1-D840-42CF-B7B9-0316F40E7133}"/>
               </a:ext>
             </a:extLst>
           </p:cNvPr>
@@ -5498,7 +5431,7 @@
           <p:cNvPr id="5" name="">
             <a:extLst xmlns:a="http://schemas.openxmlformats.org/drawingml/2006/main">
               <a:ext uri="{FF2B5EF4-FFF2-40B4-BE49-F238E27FC236}">
-                <a16:creationId xmlns:a16="http://schemas.microsoft.com/office/drawing/2014/main" id="{57F26525-FF85-4DFD-BD3B-F58F684588C7}"/>
+                <a16:creationId xmlns:a16="http://schemas.microsoft.com/office/drawing/2014/main" id="{42092534-1384-41C2-8240-68F4F9283BC0}"/>
               </a:ext>
             </a:extLst>
           </p:cNvPr>
@@ -5555,7 +5488,7 @@
           <p:cNvPr id="6" name="">
             <a:extLst xmlns:a="http://schemas.openxmlformats.org/drawingml/2006/main">
               <a:ext uri="{FF2B5EF4-FFF2-40B4-BE49-F238E27FC236}">
-                <a16:creationId xmlns:a16="http://schemas.microsoft.com/office/drawing/2014/main" id="{CC4ACF00-8470-426C-83E4-B77A1E007509}"/>
+                <a16:creationId xmlns:a16="http://schemas.microsoft.com/office/drawing/2014/main" id="{4F6BAFAA-093C-4FC9-A874-82CAEE5F9100}"/>
               </a:ext>
             </a:extLst>
           </p:cNvPr>
@@ -5612,7 +5545,7 @@
           <p:cNvPr id="7" name="">
             <a:extLst xmlns:a="http://schemas.openxmlformats.org/drawingml/2006/main">
               <a:ext uri="{FF2B5EF4-FFF2-40B4-BE49-F238E27FC236}">
-                <a16:creationId xmlns:a16="http://schemas.microsoft.com/office/drawing/2014/main" id="{B05B5A7F-9200-42D2-A50D-D1466624003D}"/>
+                <a16:creationId xmlns:a16="http://schemas.microsoft.com/office/drawing/2014/main" id="{75D279F9-794C-4885-8D45-B385E96A6258}"/>
               </a:ext>
             </a:extLst>
           </p:cNvPr>
@@ -5669,7 +5602,7 @@
           <p:cNvPr id="8" name="">
             <a:extLst xmlns:a="http://schemas.openxmlformats.org/drawingml/2006/main">
               <a:ext uri="{FF2B5EF4-FFF2-40B4-BE49-F238E27FC236}">
-                <a16:creationId xmlns:a16="http://schemas.microsoft.com/office/drawing/2014/main" id="{F5D34FF3-40B3-4BAA-BF62-400C8C5380B9}"/>
+                <a16:creationId xmlns:a16="http://schemas.microsoft.com/office/drawing/2014/main" id="{8ABC4E9E-4B25-4A22-980D-EF73CB74A95B}"/>
               </a:ext>
             </a:extLst>
           </p:cNvPr>
@@ -5699,7 +5632,7 @@
           <p:cNvPr id="9" name="">
             <a:extLst xmlns:a="http://schemas.openxmlformats.org/drawingml/2006/main">
               <a:ext uri="{FF2B5EF4-FFF2-40B4-BE49-F238E27FC236}">
-                <a16:creationId xmlns:a16="http://schemas.microsoft.com/office/drawing/2014/main" id="{7D126DB3-B249-4799-82AB-7EBFECD66C86}"/>
+                <a16:creationId xmlns:a16="http://schemas.microsoft.com/office/drawing/2014/main" id="{5CF3DE79-0431-484F-8811-D18EB54D63CD}"/>
               </a:ext>
             </a:extLst>
           </p:cNvPr>
@@ -5756,7 +5689,7 @@
           <p:cNvPr id="10" name="">
             <a:extLst xmlns:a="http://schemas.openxmlformats.org/drawingml/2006/main">
               <a:ext uri="{FF2B5EF4-FFF2-40B4-BE49-F238E27FC236}">
-                <a16:creationId xmlns:a16="http://schemas.microsoft.com/office/drawing/2014/main" id="{C46531FA-7BCA-4240-8029-6836F84C7341}"/>
+                <a16:creationId xmlns:a16="http://schemas.microsoft.com/office/drawing/2014/main" id="{9F81AA1C-74BE-4340-ADD3-A5AFE98A298F}"/>
               </a:ext>
             </a:extLst>
           </p:cNvPr>
@@ -5813,7 +5746,7 @@
           <p:cNvPr id="11" name="">
             <a:extLst xmlns:a="http://schemas.openxmlformats.org/drawingml/2006/main">
               <a:ext uri="{FF2B5EF4-FFF2-40B4-BE49-F238E27FC236}">
-                <a16:creationId xmlns:a16="http://schemas.microsoft.com/office/drawing/2014/main" id="{FCB3623D-2C84-47E7-A6A8-F97B08349DC0}"/>
+                <a16:creationId xmlns:a16="http://schemas.microsoft.com/office/drawing/2014/main" id="{CBB69DE1-E9C0-4998-840B-E5FCAF0806EB}"/>
               </a:ext>
             </a:extLst>
           </p:cNvPr>
@@ -5870,7 +5803,7 @@
           <p:cNvPr id="12" name="">
             <a:extLst xmlns:a="http://schemas.openxmlformats.org/drawingml/2006/main">
               <a:ext uri="{FF2B5EF4-FFF2-40B4-BE49-F238E27FC236}">
-                <a16:creationId xmlns:a16="http://schemas.microsoft.com/office/drawing/2014/main" id="{BF069862-F7FE-4D37-B09C-B625D92200CE}"/>
+                <a16:creationId xmlns:a16="http://schemas.microsoft.com/office/drawing/2014/main" id="{F8790D38-B5F8-4FE7-B9D5-B6E47717B174}"/>
               </a:ext>
             </a:extLst>
           </p:cNvPr>
@@ -5900,7 +5833,7 @@
           <p:cNvPr id="13" name="">
             <a:extLst xmlns:a="http://schemas.openxmlformats.org/drawingml/2006/main">
               <a:ext uri="{FF2B5EF4-FFF2-40B4-BE49-F238E27FC236}">
-                <a16:creationId xmlns:a16="http://schemas.microsoft.com/office/drawing/2014/main" id="{5029519A-E9ED-4A90-BE16-6B23DA1CF943}"/>
+                <a16:creationId xmlns:a16="http://schemas.microsoft.com/office/drawing/2014/main" id="{4C1B8ECA-B6EA-409E-BD26-06552755C98A}"/>
               </a:ext>
             </a:extLst>
           </p:cNvPr>
@@ -5957,7 +5890,7 @@
           <p:cNvPr id="14" name="">
             <a:extLst xmlns:a="http://schemas.openxmlformats.org/drawingml/2006/main">
               <a:ext uri="{FF2B5EF4-FFF2-40B4-BE49-F238E27FC236}">
-                <a16:creationId xmlns:a16="http://schemas.microsoft.com/office/drawing/2014/main" id="{7BF95BEA-5931-4868-BEFB-13CC161FB5C9}"/>
+                <a16:creationId xmlns:a16="http://schemas.microsoft.com/office/drawing/2014/main" id="{22F0C3B3-FE27-4404-A8FD-BA81BEB8ED5B}"/>
               </a:ext>
             </a:extLst>
           </p:cNvPr>
@@ -6014,7 +5947,7 @@
           <p:cNvPr id="15" name="">
             <a:extLst xmlns:a="http://schemas.openxmlformats.org/drawingml/2006/main">
               <a:ext uri="{FF2B5EF4-FFF2-40B4-BE49-F238E27FC236}">
-                <a16:creationId xmlns:a16="http://schemas.microsoft.com/office/drawing/2014/main" id="{203D7A9C-8234-431D-A514-F7D110628E26}"/>
+                <a16:creationId xmlns:a16="http://schemas.microsoft.com/office/drawing/2014/main" id="{657FBA56-1137-46D0-B77E-58DBC5944A6D}"/>
               </a:ext>
             </a:extLst>
           </p:cNvPr>
@@ -6071,7 +6004,7 @@
           <p:cNvPr id="16" name="">
             <a:extLst xmlns:a="http://schemas.openxmlformats.org/drawingml/2006/main">
               <a:ext uri="{FF2B5EF4-FFF2-40B4-BE49-F238E27FC236}">
-                <a16:creationId xmlns:a16="http://schemas.microsoft.com/office/drawing/2014/main" id="{AD2926AC-85D9-45B7-8420-2F240E7053CA}"/>
+                <a16:creationId xmlns:a16="http://schemas.microsoft.com/office/drawing/2014/main" id="{37899A06-9B1B-4A03-A7E2-976AA99B918D}"/>
               </a:ext>
             </a:extLst>
           </p:cNvPr>
@@ -6128,7 +6061,7 @@
           <p:cNvPr id="17" name="">
             <a:extLst xmlns:a="http://schemas.openxmlformats.org/drawingml/2006/main">
               <a:ext uri="{FF2B5EF4-FFF2-40B4-BE49-F238E27FC236}">
-                <a16:creationId xmlns:a16="http://schemas.microsoft.com/office/drawing/2014/main" id="{F9B74465-AA6B-45C1-A73E-C2B8CDBD3628}"/>
+                <a16:creationId xmlns:a16="http://schemas.microsoft.com/office/drawing/2014/main" id="{B12C6877-603A-405E-9C4B-39233D7B1545}"/>
               </a:ext>
             </a:extLst>
           </p:cNvPr>
@@ -6185,7 +6118,7 @@
           <p:cNvPr id="18" name="">
             <a:extLst xmlns:a="http://schemas.openxmlformats.org/drawingml/2006/main">
               <a:ext uri="{FF2B5EF4-FFF2-40B4-BE49-F238E27FC236}">
-                <a16:creationId xmlns:a16="http://schemas.microsoft.com/office/drawing/2014/main" id="{6A321EE4-E9C8-49BD-AAAD-107DA5798D97}"/>
+                <a16:creationId xmlns:a16="http://schemas.microsoft.com/office/drawing/2014/main" id="{CCDAFC3D-4E25-427F-A470-5A9D7EF6DEDD}"/>
               </a:ext>
             </a:extLst>
           </p:cNvPr>
@@ -6242,7 +6175,7 @@
           <p:cNvPr id="19" name="">
             <a:extLst xmlns:a="http://schemas.openxmlformats.org/drawingml/2006/main">
               <a:ext uri="{FF2B5EF4-FFF2-40B4-BE49-F238E27FC236}">
-                <a16:creationId xmlns:a16="http://schemas.microsoft.com/office/drawing/2014/main" id="{A1639CB6-F38C-4475-A150-7B4B9ECDA632}"/>
+                <a16:creationId xmlns:a16="http://schemas.microsoft.com/office/drawing/2014/main" id="{2EBC3343-7EA4-4BEE-9BA6-9840BE32DDF2}"/>
               </a:ext>
             </a:extLst>
           </p:cNvPr>
@@ -6274,7 +6207,7 @@
           <p:cNvPr id="20" name="">
             <a:extLst xmlns:a="http://schemas.openxmlformats.org/drawingml/2006/main">
               <a:ext uri="{FF2B5EF4-FFF2-40B4-BE49-F238E27FC236}">
-                <a16:creationId xmlns:a16="http://schemas.microsoft.com/office/drawing/2014/main" id="{EB3F7DCD-50C5-43C4-AE65-6891539B2E16}"/>
+                <a16:creationId xmlns:a16="http://schemas.microsoft.com/office/drawing/2014/main" id="{562E9416-818B-4C0C-AC8E-A5970CD61BC3}"/>
               </a:ext>
             </a:extLst>
           </p:cNvPr>
@@ -6329,7 +6262,7 @@
     </p:spTree>
     <p:extLst>
       <p:ext uri="{BB962C8B-B14F-4D97-AF65-F5344CB8AC3E}">
-        <p14:creationId xmlns:p14="http://schemas.microsoft.com/office/powerpoint/2010/main" val="889006021"/>
+        <p14:creationId xmlns:p14="http://schemas.microsoft.com/office/powerpoint/2010/main" val="228776042"/>
       </p:ext>
     </p:extLst>
   </p:cSld>
@@ -6360,7 +6293,7 @@
           <p:cNvPr id="20" name="">
             <a:extLst xmlns:a="http://schemas.openxmlformats.org/drawingml/2006/main">
               <a:ext uri="{FF2B5EF4-FFF2-40B4-BE49-F238E27FC236}">
-                <a16:creationId xmlns:a16="http://schemas.microsoft.com/office/drawing/2014/main" id="{E738E019-AE3B-42F9-9784-552E067A9031}"/>
+                <a16:creationId xmlns:a16="http://schemas.microsoft.com/office/drawing/2014/main" id="{3742F7FB-76C3-4F56-9940-4EAB2EA552B6}"/>
               </a:ext>
             </a:extLst>
           </p:cNvPr>
@@ -6390,7 +6323,7 @@
           <p:cNvPr id="2" name="">
             <a:extLst xmlns:a="http://schemas.openxmlformats.org/drawingml/2006/main">
               <a:ext uri="{FF2B5EF4-FFF2-40B4-BE49-F238E27FC236}">
-                <a16:creationId xmlns:a16="http://schemas.microsoft.com/office/drawing/2014/main" id="{9494F1B6-BE77-4A32-88FF-90D0D2BBE402}"/>
+                <a16:creationId xmlns:a16="http://schemas.microsoft.com/office/drawing/2014/main" id="{553ECBB4-3F8B-445B-9FC6-FEA40826FF82}"/>
               </a:ext>
             </a:extLst>
           </p:cNvPr>
@@ -6447,7 +6380,7 @@
           <p:cNvPr id="3" name="">
             <a:extLst xmlns:a="http://schemas.openxmlformats.org/drawingml/2006/main">
               <a:ext uri="{FF2B5EF4-FFF2-40B4-BE49-F238E27FC236}">
-                <a16:creationId xmlns:a16="http://schemas.microsoft.com/office/drawing/2014/main" id="{3F1CDD6E-AADD-439D-8FCA-FDF316931709}"/>
+                <a16:creationId xmlns:a16="http://schemas.microsoft.com/office/drawing/2014/main" id="{5AFF637D-1971-4769-87A0-C866EAA1EC5F}"/>
               </a:ext>
             </a:extLst>
           </p:cNvPr>
@@ -6504,7 +6437,7 @@
           <p:cNvPr id="4" name="">
             <a:extLst xmlns:a="http://schemas.openxmlformats.org/drawingml/2006/main">
               <a:ext uri="{FF2B5EF4-FFF2-40B4-BE49-F238E27FC236}">
-                <a16:creationId xmlns:a16="http://schemas.microsoft.com/office/drawing/2014/main" id="{018FD736-A414-47ED-8F71-E36ACF3EB2A4}"/>
+                <a16:creationId xmlns:a16="http://schemas.microsoft.com/office/drawing/2014/main" id="{0761ED2C-E2CC-42B7-94B6-7F5B25D68E94}"/>
               </a:ext>
             </a:extLst>
           </p:cNvPr>
@@ -6561,7 +6494,7 @@
           <p:cNvPr id="5" name="">
             <a:extLst xmlns:a="http://schemas.openxmlformats.org/drawingml/2006/main">
               <a:ext uri="{FF2B5EF4-FFF2-40B4-BE49-F238E27FC236}">
-                <a16:creationId xmlns:a16="http://schemas.microsoft.com/office/drawing/2014/main" id="{E5E50B5F-7324-4DB9-8F82-0F7C6FA52915}"/>
+                <a16:creationId xmlns:a16="http://schemas.microsoft.com/office/drawing/2014/main" id="{499CE4AA-267E-45AD-A369-0867B3A9EDA8}"/>
               </a:ext>
             </a:extLst>
           </p:cNvPr>
@@ -6618,7 +6551,7 @@
           <p:cNvPr id="6" name="">
             <a:extLst xmlns:a="http://schemas.openxmlformats.org/drawingml/2006/main">
               <a:ext uri="{FF2B5EF4-FFF2-40B4-BE49-F238E27FC236}">
-                <a16:creationId xmlns:a16="http://schemas.microsoft.com/office/drawing/2014/main" id="{21519BAC-5848-43DB-AF53-F6BBE326A2A1}"/>
+                <a16:creationId xmlns:a16="http://schemas.microsoft.com/office/drawing/2014/main" id="{5131F2B2-482B-44F8-B3E5-6EAECA139A89}"/>
               </a:ext>
             </a:extLst>
           </p:cNvPr>
@@ -6675,7 +6608,7 @@
           <p:cNvPr id="7" name="">
             <a:extLst xmlns:a="http://schemas.openxmlformats.org/drawingml/2006/main">
               <a:ext uri="{FF2B5EF4-FFF2-40B4-BE49-F238E27FC236}">
-                <a16:creationId xmlns:a16="http://schemas.microsoft.com/office/drawing/2014/main" id="{1D8B6AE7-498A-44F9-943A-E980568B5EF4}"/>
+                <a16:creationId xmlns:a16="http://schemas.microsoft.com/office/drawing/2014/main" id="{2AE3BC2A-602F-4114-AB43-E92380FD3959}"/>
               </a:ext>
             </a:extLst>
           </p:cNvPr>
@@ -6732,7 +6665,7 @@
           <p:cNvPr id="8" name="">
             <a:extLst xmlns:a="http://schemas.openxmlformats.org/drawingml/2006/main">
               <a:ext uri="{FF2B5EF4-FFF2-40B4-BE49-F238E27FC236}">
-                <a16:creationId xmlns:a16="http://schemas.microsoft.com/office/drawing/2014/main" id="{5C500DCE-2633-45C1-9946-ECA7BF1932D5}"/>
+                <a16:creationId xmlns:a16="http://schemas.microsoft.com/office/drawing/2014/main" id="{0945BE8D-0451-4CE9-918D-D6119A07C3FE}"/>
               </a:ext>
             </a:extLst>
           </p:cNvPr>
@@ -6789,7 +6722,7 @@
           <p:cNvPr id="9" name="">
             <a:extLst xmlns:a="http://schemas.openxmlformats.org/drawingml/2006/main">
               <a:ext uri="{FF2B5EF4-FFF2-40B4-BE49-F238E27FC236}">
-                <a16:creationId xmlns:a16="http://schemas.microsoft.com/office/drawing/2014/main" id="{14446606-7997-486E-B82F-54F108A95924}"/>
+                <a16:creationId xmlns:a16="http://schemas.microsoft.com/office/drawing/2014/main" id="{38FAE898-1DBF-4202-8068-451AEC7040F9}"/>
               </a:ext>
             </a:extLst>
           </p:cNvPr>
@@ -6819,7 +6752,7 @@
           <p:cNvPr id="10" name="">
             <a:extLst xmlns:a="http://schemas.openxmlformats.org/drawingml/2006/main">
               <a:ext uri="{FF2B5EF4-FFF2-40B4-BE49-F238E27FC236}">
-                <a16:creationId xmlns:a16="http://schemas.microsoft.com/office/drawing/2014/main" id="{2F3B2701-1C89-45F0-A1C9-1DE38C231F1E}"/>
+                <a16:creationId xmlns:a16="http://schemas.microsoft.com/office/drawing/2014/main" id="{A41A61F6-FF1E-454B-8D65-8B2646AC3C33}"/>
               </a:ext>
             </a:extLst>
           </p:cNvPr>
@@ -6876,7 +6809,7 @@
           <p:cNvPr id="11" name="">
             <a:extLst xmlns:a="http://schemas.openxmlformats.org/drawingml/2006/main">
               <a:ext uri="{FF2B5EF4-FFF2-40B4-BE49-F238E27FC236}">
-                <a16:creationId xmlns:a16="http://schemas.microsoft.com/office/drawing/2014/main" id="{9C00D20B-F9D9-44F1-960E-A54991CC9B94}"/>
+                <a16:creationId xmlns:a16="http://schemas.microsoft.com/office/drawing/2014/main" id="{DB101A68-8C29-4145-9D12-D7F95715E013}"/>
               </a:ext>
             </a:extLst>
           </p:cNvPr>
@@ -6933,7 +6866,7 @@
           <p:cNvPr id="12" name="">
             <a:extLst xmlns:a="http://schemas.openxmlformats.org/drawingml/2006/main">
               <a:ext uri="{FF2B5EF4-FFF2-40B4-BE49-F238E27FC236}">
-                <a16:creationId xmlns:a16="http://schemas.microsoft.com/office/drawing/2014/main" id="{CF65F267-5F1D-4771-9D5E-31B87D0875FD}"/>
+                <a16:creationId xmlns:a16="http://schemas.microsoft.com/office/drawing/2014/main" id="{A5EAE80C-6E6A-48D3-A159-B6202DEDAD46}"/>
               </a:ext>
             </a:extLst>
           </p:cNvPr>
@@ -6990,7 +6923,7 @@
           <p:cNvPr id="13" name="">
             <a:extLst xmlns:a="http://schemas.openxmlformats.org/drawingml/2006/main">
               <a:ext uri="{FF2B5EF4-FFF2-40B4-BE49-F238E27FC236}">
-                <a16:creationId xmlns:a16="http://schemas.microsoft.com/office/drawing/2014/main" id="{1AD7228B-7484-45AA-B6B1-A6030344ED73}"/>
+                <a16:creationId xmlns:a16="http://schemas.microsoft.com/office/drawing/2014/main" id="{4F1F3E3F-560B-49C1-AB2D-4BC8FF6F2A57}"/>
               </a:ext>
             </a:extLst>
           </p:cNvPr>
@@ -7047,7 +6980,7 @@
           <p:cNvPr id="14" name="">
             <a:extLst xmlns:a="http://schemas.openxmlformats.org/drawingml/2006/main">
               <a:ext uri="{FF2B5EF4-FFF2-40B4-BE49-F238E27FC236}">
-                <a16:creationId xmlns:a16="http://schemas.microsoft.com/office/drawing/2014/main" id="{6127A754-A418-43A0-8F77-758F1B57F85D}"/>
+                <a16:creationId xmlns:a16="http://schemas.microsoft.com/office/drawing/2014/main" id="{F19CFB97-1B87-490D-9EFA-98E542B5645D}"/>
               </a:ext>
             </a:extLst>
           </p:cNvPr>
@@ -7077,7 +7010,7 @@
           <p:cNvPr id="15" name="">
             <a:extLst xmlns:a="http://schemas.openxmlformats.org/drawingml/2006/main">
               <a:ext uri="{FF2B5EF4-FFF2-40B4-BE49-F238E27FC236}">
-                <a16:creationId xmlns:a16="http://schemas.microsoft.com/office/drawing/2014/main" id="{4B692AAD-42A2-421F-80BD-448563792F40}"/>
+                <a16:creationId xmlns:a16="http://schemas.microsoft.com/office/drawing/2014/main" id="{C4178653-8136-4877-A464-E9E8552CDE7E}"/>
               </a:ext>
             </a:extLst>
           </p:cNvPr>
@@ -7134,7 +7067,7 @@
           <p:cNvPr id="16" name="">
             <a:extLst xmlns:a="http://schemas.openxmlformats.org/drawingml/2006/main">
               <a:ext uri="{FF2B5EF4-FFF2-40B4-BE49-F238E27FC236}">
-                <a16:creationId xmlns:a16="http://schemas.microsoft.com/office/drawing/2014/main" id="{773A3E70-3A94-46A7-BFCB-7C864E673BAF}"/>
+                <a16:creationId xmlns:a16="http://schemas.microsoft.com/office/drawing/2014/main" id="{D3034DBE-BC3F-4246-B83D-6A0959D7E2D0}"/>
               </a:ext>
             </a:extLst>
           </p:cNvPr>
@@ -7191,7 +7124,7 @@
           <p:cNvPr id="17" name="">
             <a:extLst xmlns:a="http://schemas.openxmlformats.org/drawingml/2006/main">
               <a:ext uri="{FF2B5EF4-FFF2-40B4-BE49-F238E27FC236}">
-                <a16:creationId xmlns:a16="http://schemas.microsoft.com/office/drawing/2014/main" id="{9168CF68-40B8-4068-821A-A98B0E17C5DA}"/>
+                <a16:creationId xmlns:a16="http://schemas.microsoft.com/office/drawing/2014/main" id="{A9DD3D83-705A-427E-88B5-4139370904DA}"/>
               </a:ext>
             </a:extLst>
           </p:cNvPr>
@@ -7248,7 +7181,7 @@
           <p:cNvPr id="18" name="">
             <a:extLst xmlns:a="http://schemas.openxmlformats.org/drawingml/2006/main">
               <a:ext uri="{FF2B5EF4-FFF2-40B4-BE49-F238E27FC236}">
-                <a16:creationId xmlns:a16="http://schemas.microsoft.com/office/drawing/2014/main" id="{68F1CE99-E92F-43D8-8B0A-E14D9E403069}"/>
+                <a16:creationId xmlns:a16="http://schemas.microsoft.com/office/drawing/2014/main" id="{E3087D82-0F56-4BCD-ACA4-2FC4B235BC2D}"/>
               </a:ext>
             </a:extLst>
           </p:cNvPr>
@@ -7305,7 +7238,7 @@
           <p:cNvPr id="19" name="">
             <a:extLst xmlns:a="http://schemas.openxmlformats.org/drawingml/2006/main">
               <a:ext uri="{FF2B5EF4-FFF2-40B4-BE49-F238E27FC236}">
-                <a16:creationId xmlns:a16="http://schemas.microsoft.com/office/drawing/2014/main" id="{A0E59CB0-141C-471A-A95E-9032A3AD75F0}"/>
+                <a16:creationId xmlns:a16="http://schemas.microsoft.com/office/drawing/2014/main" id="{B2A02E50-D01A-4E54-AD4B-627652DAC095}"/>
               </a:ext>
             </a:extLst>
           </p:cNvPr>
@@ -7360,7 +7293,7 @@
     </p:spTree>
     <p:extLst>
       <p:ext uri="{BB962C8B-B14F-4D97-AF65-F5344CB8AC3E}">
-        <p14:creationId xmlns:p14="http://schemas.microsoft.com/office/powerpoint/2010/main" val="2067658363"/>
+        <p14:creationId xmlns:p14="http://schemas.microsoft.com/office/powerpoint/2010/main" val="663177339"/>
       </p:ext>
     </p:extLst>
   </p:cSld>
@@ -7391,7 +7324,7 @@
           <p:cNvPr id="20" name="">
             <a:extLst xmlns:a="http://schemas.openxmlformats.org/drawingml/2006/main">
               <a:ext uri="{FF2B5EF4-FFF2-40B4-BE49-F238E27FC236}">
-                <a16:creationId xmlns:a16="http://schemas.microsoft.com/office/drawing/2014/main" id="{09086328-118F-4666-A743-73E0A49E2AE9}"/>
+                <a16:creationId xmlns:a16="http://schemas.microsoft.com/office/drawing/2014/main" id="{0ED0E0D8-8069-4DB5-BCBB-7D7F7EB7D3A1}"/>
               </a:ext>
             </a:extLst>
           </p:cNvPr>
@@ -7421,7 +7354,7 @@
           <p:cNvPr id="2" name="">
             <a:extLst xmlns:a="http://schemas.openxmlformats.org/drawingml/2006/main">
               <a:ext uri="{FF2B5EF4-FFF2-40B4-BE49-F238E27FC236}">
-                <a16:creationId xmlns:a16="http://schemas.microsoft.com/office/drawing/2014/main" id="{8F3DF1DB-BD77-49BE-991E-89AE958751F1}"/>
+                <a16:creationId xmlns:a16="http://schemas.microsoft.com/office/drawing/2014/main" id="{EE2EAA6A-CA27-4228-BFAD-4106A1579DB0}"/>
               </a:ext>
             </a:extLst>
           </p:cNvPr>
@@ -7478,7 +7411,7 @@
           <p:cNvPr id="3" name="">
             <a:extLst xmlns:a="http://schemas.openxmlformats.org/drawingml/2006/main">
               <a:ext uri="{FF2B5EF4-FFF2-40B4-BE49-F238E27FC236}">
-                <a16:creationId xmlns:a16="http://schemas.microsoft.com/office/drawing/2014/main" id="{E39F8A3A-6D2E-42F6-89DE-87805AA6FA4C}"/>
+                <a16:creationId xmlns:a16="http://schemas.microsoft.com/office/drawing/2014/main" id="{8599E9D1-5E48-4CB0-922C-6231924510FC}"/>
               </a:ext>
             </a:extLst>
           </p:cNvPr>
@@ -7535,7 +7468,7 @@
           <p:cNvPr id="4" name="">
             <a:extLst xmlns:a="http://schemas.openxmlformats.org/drawingml/2006/main">
               <a:ext uri="{FF2B5EF4-FFF2-40B4-BE49-F238E27FC236}">
-                <a16:creationId xmlns:a16="http://schemas.microsoft.com/office/drawing/2014/main" id="{E53716B9-5A15-493C-8EBD-942CDCF3E4D0}"/>
+                <a16:creationId xmlns:a16="http://schemas.microsoft.com/office/drawing/2014/main" id="{8561007A-BF7C-4B61-843B-9C311184E262}"/>
               </a:ext>
             </a:extLst>
           </p:cNvPr>
@@ -7592,7 +7525,7 @@
           <p:cNvPr id="5" name="">
             <a:extLst xmlns:a="http://schemas.openxmlformats.org/drawingml/2006/main">
               <a:ext uri="{FF2B5EF4-FFF2-40B4-BE49-F238E27FC236}">
-                <a16:creationId xmlns:a16="http://schemas.microsoft.com/office/drawing/2014/main" id="{2402CC0E-245C-42AA-B970-05F72254F617}"/>
+                <a16:creationId xmlns:a16="http://schemas.microsoft.com/office/drawing/2014/main" id="{5D3F97B0-D88C-4296-AFEB-5D21BE8222CD}"/>
               </a:ext>
             </a:extLst>
           </p:cNvPr>
@@ -7627,7 +7560,7 @@
           <p:cNvPr id="6" name="">
             <a:extLst xmlns:a="http://schemas.openxmlformats.org/drawingml/2006/main">
               <a:ext uri="{FF2B5EF4-FFF2-40B4-BE49-F238E27FC236}">
-                <a16:creationId xmlns:a16="http://schemas.microsoft.com/office/drawing/2014/main" id="{82BF96F3-6150-4655-8A3C-193BFA3EEF73}"/>
+                <a16:creationId xmlns:a16="http://schemas.microsoft.com/office/drawing/2014/main" id="{CEEF3E14-6BDD-4267-8083-0FA409303055}"/>
               </a:ext>
             </a:extLst>
           </p:cNvPr>
@@ -7684,7 +7617,7 @@
           <p:cNvPr id="7" name="">
             <a:extLst xmlns:a="http://schemas.openxmlformats.org/drawingml/2006/main">
               <a:ext uri="{FF2B5EF4-FFF2-40B4-BE49-F238E27FC236}">
-                <a16:creationId xmlns:a16="http://schemas.microsoft.com/office/drawing/2014/main" id="{28A35523-3312-47A8-8560-CED72154947F}"/>
+                <a16:creationId xmlns:a16="http://schemas.microsoft.com/office/drawing/2014/main" id="{A18BDF05-BF87-4578-88B1-428906AC6EFD}"/>
               </a:ext>
             </a:extLst>
           </p:cNvPr>
@@ -7741,7 +7674,7 @@
           <p:cNvPr id="8" name="">
             <a:extLst xmlns:a="http://schemas.openxmlformats.org/drawingml/2006/main">
               <a:ext uri="{FF2B5EF4-FFF2-40B4-BE49-F238E27FC236}">
-                <a16:creationId xmlns:a16="http://schemas.microsoft.com/office/drawing/2014/main" id="{32A86890-EEF9-4DD7-83FA-3F82AC1458FC}"/>
+                <a16:creationId xmlns:a16="http://schemas.microsoft.com/office/drawing/2014/main" id="{644742E3-266B-48DD-8391-33B6E45EC383}"/>
               </a:ext>
             </a:extLst>
           </p:cNvPr>
@@ -7776,7 +7709,7 @@
           <p:cNvPr id="9" name="">
             <a:extLst xmlns:a="http://schemas.openxmlformats.org/drawingml/2006/main">
               <a:ext uri="{FF2B5EF4-FFF2-40B4-BE49-F238E27FC236}">
-                <a16:creationId xmlns:a16="http://schemas.microsoft.com/office/drawing/2014/main" id="{7EF9D6C8-4771-4F26-957A-3D16E6CB9812}"/>
+                <a16:creationId xmlns:a16="http://schemas.microsoft.com/office/drawing/2014/main" id="{F822CAD6-DF66-4A3A-8E18-A62B6844D1B2}"/>
               </a:ext>
             </a:extLst>
           </p:cNvPr>
@@ -7833,7 +7766,7 @@
           <p:cNvPr id="10" name="">
             <a:extLst xmlns:a="http://schemas.openxmlformats.org/drawingml/2006/main">
               <a:ext uri="{FF2B5EF4-FFF2-40B4-BE49-F238E27FC236}">
-                <a16:creationId xmlns:a16="http://schemas.microsoft.com/office/drawing/2014/main" id="{48E501CC-ED76-4166-8D14-857B068E589F}"/>
+                <a16:creationId xmlns:a16="http://schemas.microsoft.com/office/drawing/2014/main" id="{C5EA4FF9-6BBA-4E95-8B5A-332FA66477B5}"/>
               </a:ext>
             </a:extLst>
           </p:cNvPr>
@@ -7890,7 +7823,7 @@
           <p:cNvPr id="11" name="">
             <a:extLst xmlns:a="http://schemas.openxmlformats.org/drawingml/2006/main">
               <a:ext uri="{FF2B5EF4-FFF2-40B4-BE49-F238E27FC236}">
-                <a16:creationId xmlns:a16="http://schemas.microsoft.com/office/drawing/2014/main" id="{FDF1E421-EC95-4EFC-BA5D-7376FD4DD972}"/>
+                <a16:creationId xmlns:a16="http://schemas.microsoft.com/office/drawing/2014/main" id="{DB4229D8-EC43-4B54-B3A7-181E1187DF91}"/>
               </a:ext>
             </a:extLst>
           </p:cNvPr>
@@ -7925,7 +7858,7 @@
           <p:cNvPr id="12" name="">
             <a:extLst xmlns:a="http://schemas.openxmlformats.org/drawingml/2006/main">
               <a:ext uri="{FF2B5EF4-FFF2-40B4-BE49-F238E27FC236}">
-                <a16:creationId xmlns:a16="http://schemas.microsoft.com/office/drawing/2014/main" id="{A15C7559-7A8E-4C6C-932A-9A930DCBBAC8}"/>
+                <a16:creationId xmlns:a16="http://schemas.microsoft.com/office/drawing/2014/main" id="{7CC790A5-6E5D-41A0-BEB5-CC2F68CDAA02}"/>
               </a:ext>
             </a:extLst>
           </p:cNvPr>
@@ -7982,7 +7915,7 @@
           <p:cNvPr id="13" name="">
             <a:extLst xmlns:a="http://schemas.openxmlformats.org/drawingml/2006/main">
               <a:ext uri="{FF2B5EF4-FFF2-40B4-BE49-F238E27FC236}">
-                <a16:creationId xmlns:a16="http://schemas.microsoft.com/office/drawing/2014/main" id="{27751E47-D241-4A86-AA94-FF1DA3ED1DEF}"/>
+                <a16:creationId xmlns:a16="http://schemas.microsoft.com/office/drawing/2014/main" id="{488B0A35-D436-47FB-8C0F-AFE2978A5789}"/>
               </a:ext>
             </a:extLst>
           </p:cNvPr>
@@ -8039,7 +7972,7 @@
           <p:cNvPr id="14" name="">
             <a:extLst xmlns:a="http://schemas.openxmlformats.org/drawingml/2006/main">
               <a:ext uri="{FF2B5EF4-FFF2-40B4-BE49-F238E27FC236}">
-                <a16:creationId xmlns:a16="http://schemas.microsoft.com/office/drawing/2014/main" id="{0D3510C7-8355-4EE6-B404-3CE34E0253B4}"/>
+                <a16:creationId xmlns:a16="http://schemas.microsoft.com/office/drawing/2014/main" id="{F23D0D6F-8D21-435C-BC58-0E1A6B01FF08}"/>
               </a:ext>
             </a:extLst>
           </p:cNvPr>
@@ -8074,7 +8007,7 @@
           <p:cNvPr id="15" name="">
             <a:extLst xmlns:a="http://schemas.openxmlformats.org/drawingml/2006/main">
               <a:ext uri="{FF2B5EF4-FFF2-40B4-BE49-F238E27FC236}">
-                <a16:creationId xmlns:a16="http://schemas.microsoft.com/office/drawing/2014/main" id="{5F853561-5715-4076-B0BC-2FC55D29F2F6}"/>
+                <a16:creationId xmlns:a16="http://schemas.microsoft.com/office/drawing/2014/main" id="{4F5257C5-E7B3-4767-A9D6-363D66CDD5BF}"/>
               </a:ext>
             </a:extLst>
           </p:cNvPr>
@@ -8131,7 +8064,7 @@
           <p:cNvPr id="16" name="">
             <a:extLst xmlns:a="http://schemas.openxmlformats.org/drawingml/2006/main">
               <a:ext uri="{FF2B5EF4-FFF2-40B4-BE49-F238E27FC236}">
-                <a16:creationId xmlns:a16="http://schemas.microsoft.com/office/drawing/2014/main" id="{08244D26-7E89-479F-BF72-706AE72AAF30}"/>
+                <a16:creationId xmlns:a16="http://schemas.microsoft.com/office/drawing/2014/main" id="{94A27714-0D3C-4183-89D0-7C96E951623C}"/>
               </a:ext>
             </a:extLst>
           </p:cNvPr>
@@ -8188,7 +8121,7 @@
           <p:cNvPr id="17" name="">
             <a:extLst xmlns:a="http://schemas.openxmlformats.org/drawingml/2006/main">
               <a:ext uri="{FF2B5EF4-FFF2-40B4-BE49-F238E27FC236}">
-                <a16:creationId xmlns:a16="http://schemas.microsoft.com/office/drawing/2014/main" id="{03493D11-091E-4C34-A814-58543E94C08C}"/>
+                <a16:creationId xmlns:a16="http://schemas.microsoft.com/office/drawing/2014/main" id="{01C2FA3D-799C-4B44-8D9D-2469DBB4C14E}"/>
               </a:ext>
             </a:extLst>
           </p:cNvPr>
@@ -8245,7 +8178,7 @@
           <p:cNvPr id="18" name="">
             <a:extLst xmlns:a="http://schemas.openxmlformats.org/drawingml/2006/main">
               <a:ext uri="{FF2B5EF4-FFF2-40B4-BE49-F238E27FC236}">
-                <a16:creationId xmlns:a16="http://schemas.microsoft.com/office/drawing/2014/main" id="{2596E5FB-65B5-4021-BBC1-88AC1FD56283}"/>
+                <a16:creationId xmlns:a16="http://schemas.microsoft.com/office/drawing/2014/main" id="{466A6CE2-186C-4AA4-BE27-E333553DD76C}"/>
               </a:ext>
             </a:extLst>
           </p:cNvPr>
@@ -8302,7 +8235,7 @@
           <p:cNvPr id="19" name="">
             <a:extLst xmlns:a="http://schemas.openxmlformats.org/drawingml/2006/main">
               <a:ext uri="{FF2B5EF4-FFF2-40B4-BE49-F238E27FC236}">
-                <a16:creationId xmlns:a16="http://schemas.microsoft.com/office/drawing/2014/main" id="{AD07ECC7-28C6-44D9-A886-7CEBF1EC5E37}"/>
+                <a16:creationId xmlns:a16="http://schemas.microsoft.com/office/drawing/2014/main" id="{23DC799D-28BC-46A2-88DA-21F91C90FB44}"/>
               </a:ext>
             </a:extLst>
           </p:cNvPr>
@@ -8357,7 +8290,7 @@
     </p:spTree>
     <p:extLst>
       <p:ext uri="{BB962C8B-B14F-4D97-AF65-F5344CB8AC3E}">
-        <p14:creationId xmlns:p14="http://schemas.microsoft.com/office/powerpoint/2010/main" val="1385515578"/>
+        <p14:creationId xmlns:p14="http://schemas.microsoft.com/office/powerpoint/2010/main" val="395533947"/>
       </p:ext>
     </p:extLst>
   </p:cSld>
@@ -8388,7 +8321,7 @@
           <p:cNvPr id="20" name="">
             <a:extLst xmlns:a="http://schemas.openxmlformats.org/drawingml/2006/main">
               <a:ext uri="{FF2B5EF4-FFF2-40B4-BE49-F238E27FC236}">
-                <a16:creationId xmlns:a16="http://schemas.microsoft.com/office/drawing/2014/main" id="{48C5FB6D-FB65-4184-8E70-A6735A1B6912}"/>
+                <a16:creationId xmlns:a16="http://schemas.microsoft.com/office/drawing/2014/main" id="{540840AD-831D-4D00-BAB2-9994CC1375B1}"/>
               </a:ext>
             </a:extLst>
           </p:cNvPr>
@@ -8418,7 +8351,7 @@
           <p:cNvPr id="2" name="">
             <a:extLst xmlns:a="http://schemas.openxmlformats.org/drawingml/2006/main">
               <a:ext uri="{FF2B5EF4-FFF2-40B4-BE49-F238E27FC236}">
-                <a16:creationId xmlns:a16="http://schemas.microsoft.com/office/drawing/2014/main" id="{A0AA7E21-FBA8-40FE-9D59-58C9F3300FC5}"/>
+                <a16:creationId xmlns:a16="http://schemas.microsoft.com/office/drawing/2014/main" id="{432752A4-10E8-49AF-9555-54A18772BBFA}"/>
               </a:ext>
             </a:extLst>
           </p:cNvPr>
@@ -8475,7 +8408,7 @@
           <p:cNvPr id="3" name="">
             <a:extLst xmlns:a="http://schemas.openxmlformats.org/drawingml/2006/main">
               <a:ext uri="{FF2B5EF4-FFF2-40B4-BE49-F238E27FC236}">
-                <a16:creationId xmlns:a16="http://schemas.microsoft.com/office/drawing/2014/main" id="{B2BE4AB2-5612-45F1-B0DB-E9A50D966833}"/>
+                <a16:creationId xmlns:a16="http://schemas.microsoft.com/office/drawing/2014/main" id="{C690EF3C-6533-4423-81AF-5D7AF267869F}"/>
               </a:ext>
             </a:extLst>
           </p:cNvPr>
@@ -8532,7 +8465,7 @@
           <p:cNvPr id="4" name="">
             <a:extLst xmlns:a="http://schemas.openxmlformats.org/drawingml/2006/main">
               <a:ext uri="{FF2B5EF4-FFF2-40B4-BE49-F238E27FC236}">
-                <a16:creationId xmlns:a16="http://schemas.microsoft.com/office/drawing/2014/main" id="{B01CCA20-EC9C-4B27-A6E6-013F252BCD64}"/>
+                <a16:creationId xmlns:a16="http://schemas.microsoft.com/office/drawing/2014/main" id="{7D5BD479-5C8D-48C0-83E2-4B9A66762222}"/>
               </a:ext>
             </a:extLst>
           </p:cNvPr>
@@ -8589,7 +8522,7 @@
           <p:cNvPr id="5" name="">
             <a:extLst xmlns:a="http://schemas.openxmlformats.org/drawingml/2006/main">
               <a:ext uri="{FF2B5EF4-FFF2-40B4-BE49-F238E27FC236}">
-                <a16:creationId xmlns:a16="http://schemas.microsoft.com/office/drawing/2014/main" id="{27C4A56F-0185-45FD-A9F9-F68725B14415}"/>
+                <a16:creationId xmlns:a16="http://schemas.microsoft.com/office/drawing/2014/main" id="{19192A08-9E72-498A-9ADD-B5CD024FCAB4}"/>
               </a:ext>
             </a:extLst>
           </p:cNvPr>
@@ -8646,7 +8579,7 @@
           <p:cNvPr id="6" name="">
             <a:extLst xmlns:a="http://schemas.openxmlformats.org/drawingml/2006/main">
               <a:ext uri="{FF2B5EF4-FFF2-40B4-BE49-F238E27FC236}">
-                <a16:creationId xmlns:a16="http://schemas.microsoft.com/office/drawing/2014/main" id="{F26EFAD5-2196-451F-81EB-C4474A459B1E}"/>
+                <a16:creationId xmlns:a16="http://schemas.microsoft.com/office/drawing/2014/main" id="{CCE66D69-2324-4D55-9666-1EA8170799C6}"/>
               </a:ext>
             </a:extLst>
           </p:cNvPr>
@@ -8703,7 +8636,7 @@
           <p:cNvPr id="7" name="">
             <a:extLst xmlns:a="http://schemas.openxmlformats.org/drawingml/2006/main">
               <a:ext uri="{FF2B5EF4-FFF2-40B4-BE49-F238E27FC236}">
-                <a16:creationId xmlns:a16="http://schemas.microsoft.com/office/drawing/2014/main" id="{109BA3C1-A37E-466A-BBD7-E547266EBD7F}"/>
+                <a16:creationId xmlns:a16="http://schemas.microsoft.com/office/drawing/2014/main" id="{7C241A2D-73E4-4282-AC90-DB6D66625C46}"/>
               </a:ext>
             </a:extLst>
           </p:cNvPr>
@@ -8760,7 +8693,7 @@
           <p:cNvPr id="8" name="">
             <a:extLst xmlns:a="http://schemas.openxmlformats.org/drawingml/2006/main">
               <a:ext uri="{FF2B5EF4-FFF2-40B4-BE49-F238E27FC236}">
-                <a16:creationId xmlns:a16="http://schemas.microsoft.com/office/drawing/2014/main" id="{DFD26F2F-E6C5-42B1-AE17-8FFE988C760A}"/>
+                <a16:creationId xmlns:a16="http://schemas.microsoft.com/office/drawing/2014/main" id="{9CD33B20-DF1B-4115-98F6-CCEA296DF8C5}"/>
               </a:ext>
             </a:extLst>
           </p:cNvPr>
@@ -8817,7 +8750,7 @@
           <p:cNvPr id="9" name="">
             <a:extLst xmlns:a="http://schemas.openxmlformats.org/drawingml/2006/main">
               <a:ext uri="{FF2B5EF4-FFF2-40B4-BE49-F238E27FC236}">
-                <a16:creationId xmlns:a16="http://schemas.microsoft.com/office/drawing/2014/main" id="{D9A63C16-6FDE-4AC3-A327-6B82537A062F}"/>
+                <a16:creationId xmlns:a16="http://schemas.microsoft.com/office/drawing/2014/main" id="{46125940-E015-41F7-AF22-F0B309A56E51}"/>
               </a:ext>
             </a:extLst>
           </p:cNvPr>
@@ -8874,7 +8807,7 @@
           <p:cNvPr id="10" name="">
             <a:extLst xmlns:a="http://schemas.openxmlformats.org/drawingml/2006/main">
               <a:ext uri="{FF2B5EF4-FFF2-40B4-BE49-F238E27FC236}">
-                <a16:creationId xmlns:a16="http://schemas.microsoft.com/office/drawing/2014/main" id="{16C396BF-8228-4B8F-A3F7-1F0CC7B59982}"/>
+                <a16:creationId xmlns:a16="http://schemas.microsoft.com/office/drawing/2014/main" id="{4396DF23-609B-4F98-B602-669C488DA022}"/>
               </a:ext>
             </a:extLst>
           </p:cNvPr>
@@ -8931,7 +8864,7 @@
           <p:cNvPr id="11" name="">
             <a:extLst xmlns:a="http://schemas.openxmlformats.org/drawingml/2006/main">
               <a:ext uri="{FF2B5EF4-FFF2-40B4-BE49-F238E27FC236}">
-                <a16:creationId xmlns:a16="http://schemas.microsoft.com/office/drawing/2014/main" id="{720A616D-F0A7-4BF7-B1E3-5172A0CAEEC3}"/>
+                <a16:creationId xmlns:a16="http://schemas.microsoft.com/office/drawing/2014/main" id="{2077FB88-10CD-4ADD-88F0-265786952BE0}"/>
               </a:ext>
             </a:extLst>
           </p:cNvPr>
@@ -8988,7 +8921,7 @@
           <p:cNvPr id="12" name="">
             <a:extLst xmlns:a="http://schemas.openxmlformats.org/drawingml/2006/main">
               <a:ext uri="{FF2B5EF4-FFF2-40B4-BE49-F238E27FC236}">
-                <a16:creationId xmlns:a16="http://schemas.microsoft.com/office/drawing/2014/main" id="{EB209D46-53A5-422F-902D-086BDA3CE798}"/>
+                <a16:creationId xmlns:a16="http://schemas.microsoft.com/office/drawing/2014/main" id="{8B804D9C-1D52-4A1E-9226-35F3FBA3E0FE}"/>
               </a:ext>
             </a:extLst>
           </p:cNvPr>
@@ -9045,7 +8978,7 @@
           <p:cNvPr id="13" name="">
             <a:extLst xmlns:a="http://schemas.openxmlformats.org/drawingml/2006/main">
               <a:ext uri="{FF2B5EF4-FFF2-40B4-BE49-F238E27FC236}">
-                <a16:creationId xmlns:a16="http://schemas.microsoft.com/office/drawing/2014/main" id="{44EAF3EB-5260-4B70-B72B-A3F968F18AF1}"/>
+                <a16:creationId xmlns:a16="http://schemas.microsoft.com/office/drawing/2014/main" id="{BF82BD87-05DF-413C-8FD1-C9032D804662}"/>
               </a:ext>
             </a:extLst>
           </p:cNvPr>
@@ -9102,7 +9035,7 @@
           <p:cNvPr id="14" name="">
             <a:extLst xmlns:a="http://schemas.openxmlformats.org/drawingml/2006/main">
               <a:ext uri="{FF2B5EF4-FFF2-40B4-BE49-F238E27FC236}">
-                <a16:creationId xmlns:a16="http://schemas.microsoft.com/office/drawing/2014/main" id="{CA0C5640-154F-4BAF-A956-E3DEA41FA872}"/>
+                <a16:creationId xmlns:a16="http://schemas.microsoft.com/office/drawing/2014/main" id="{A8EE12D6-DFB3-4CC2-885C-8244E7408C84}"/>
               </a:ext>
             </a:extLst>
           </p:cNvPr>
@@ -9132,7 +9065,7 @@
           <p:cNvPr id="15" name="">
             <a:extLst xmlns:a="http://schemas.openxmlformats.org/drawingml/2006/main">
               <a:ext uri="{FF2B5EF4-FFF2-40B4-BE49-F238E27FC236}">
-                <a16:creationId xmlns:a16="http://schemas.microsoft.com/office/drawing/2014/main" id="{491946EE-51DE-4F68-B221-A9B2D98B923E}"/>
+                <a16:creationId xmlns:a16="http://schemas.microsoft.com/office/drawing/2014/main" id="{BE431B92-A68B-4AAF-989A-989853286B85}"/>
               </a:ext>
             </a:extLst>
           </p:cNvPr>
@@ -9189,7 +9122,7 @@
           <p:cNvPr id="16" name="">
             <a:extLst xmlns:a="http://schemas.openxmlformats.org/drawingml/2006/main">
               <a:ext uri="{FF2B5EF4-FFF2-40B4-BE49-F238E27FC236}">
-                <a16:creationId xmlns:a16="http://schemas.microsoft.com/office/drawing/2014/main" id="{AB9D4037-1938-46E5-8F50-80632CC457FE}"/>
+                <a16:creationId xmlns:a16="http://schemas.microsoft.com/office/drawing/2014/main" id="{EC6FE49A-A76E-419D-B873-395A0A150512}"/>
               </a:ext>
             </a:extLst>
           </p:cNvPr>
@@ -9246,7 +9179,7 @@
           <p:cNvPr id="17" name="">
             <a:extLst xmlns:a="http://schemas.openxmlformats.org/drawingml/2006/main">
               <a:ext uri="{FF2B5EF4-FFF2-40B4-BE49-F238E27FC236}">
-                <a16:creationId xmlns:a16="http://schemas.microsoft.com/office/drawing/2014/main" id="{F38344E5-CB47-4368-A001-4F1B423CDE06}"/>
+                <a16:creationId xmlns:a16="http://schemas.microsoft.com/office/drawing/2014/main" id="{5B2A2A2B-C1B7-4648-B23E-FD89E1FC823A}"/>
               </a:ext>
             </a:extLst>
           </p:cNvPr>
@@ -9303,7 +9236,7 @@
           <p:cNvPr id="18" name="">
             <a:extLst xmlns:a="http://schemas.openxmlformats.org/drawingml/2006/main">
               <a:ext uri="{FF2B5EF4-FFF2-40B4-BE49-F238E27FC236}">
-                <a16:creationId xmlns:a16="http://schemas.microsoft.com/office/drawing/2014/main" id="{210DAB69-1739-4CAB-8B64-1A7B78A7FFA5}"/>
+                <a16:creationId xmlns:a16="http://schemas.microsoft.com/office/drawing/2014/main" id="{CF9BBD71-FC1F-4B35-8F73-7056A2CA5A5E}"/>
               </a:ext>
             </a:extLst>
           </p:cNvPr>
@@ -9360,7 +9293,7 @@
           <p:cNvPr id="19" name="">
             <a:extLst xmlns:a="http://schemas.openxmlformats.org/drawingml/2006/main">
               <a:ext uri="{FF2B5EF4-FFF2-40B4-BE49-F238E27FC236}">
-                <a16:creationId xmlns:a16="http://schemas.microsoft.com/office/drawing/2014/main" id="{988642B8-CA66-4E01-ADD9-AE605A1038B5}"/>
+                <a16:creationId xmlns:a16="http://schemas.microsoft.com/office/drawing/2014/main" id="{6F076C64-8D1A-45D9-AE43-DB0700F69611}"/>
               </a:ext>
             </a:extLst>
           </p:cNvPr>
@@ -9415,7 +9348,7 @@
     </p:spTree>
     <p:extLst>
       <p:ext uri="{BB962C8B-B14F-4D97-AF65-F5344CB8AC3E}">
-        <p14:creationId xmlns:p14="http://schemas.microsoft.com/office/powerpoint/2010/main" val="1434722295"/>
+        <p14:creationId xmlns:p14="http://schemas.microsoft.com/office/powerpoint/2010/main" val="627370282"/>
       </p:ext>
     </p:extLst>
   </p:cSld>

</xml_diff>

<commit_message>
brand: refine linked-chain logo geometry
</commit_message>
<xml_diff>
--- a/submission/ProofLend_Hackathon_Deck.pptx
+++ b/submission/ProofLend_Hackathon_Deck.pptx
@@ -2,20 +2,20 @@
 <file path=ppt/presentation.xml><?xml version="1.0" encoding="utf-8"?>
 <p:presentation xmlns:p="http://schemas.openxmlformats.org/presentationml/2006/main">
   <p:sldMasterIdLst>
-    <p:sldMasterId xmlns:r="http://schemas.openxmlformats.org/officeDocument/2006/relationships" id="2147483648" r:id="R63263e4c6c8a4fd6"/>
+    <p:sldMasterId xmlns:r="http://schemas.openxmlformats.org/officeDocument/2006/relationships" id="2147483648" r:id="R01e5dd25454f4c4a"/>
   </p:sldMasterIdLst>
   <p:notesMasterIdLst>
-    <p:notesMasterId xmlns:r="http://schemas.openxmlformats.org/officeDocument/2006/relationships" r:id="Re19ebc27b4d94fbd"/>
+    <p:notesMasterId xmlns:r="http://schemas.openxmlformats.org/officeDocument/2006/relationships" r:id="R0e1914e1d87249f5"/>
   </p:notesMasterIdLst>
   <p:sldIdLst>
-    <p:sldId xmlns:r="http://schemas.openxmlformats.org/officeDocument/2006/relationships" id="256" r:id="Rdba9fcdbec234591"/>
-    <p:sldId xmlns:r="http://schemas.openxmlformats.org/officeDocument/2006/relationships" id="257" r:id="Ra4e53f8d2b474187"/>
-    <p:sldId xmlns:r="http://schemas.openxmlformats.org/officeDocument/2006/relationships" id="258" r:id="Rd98b3f19a85f422f"/>
-    <p:sldId xmlns:r="http://schemas.openxmlformats.org/officeDocument/2006/relationships" id="259" r:id="R66d7e3d6e24541bb"/>
-    <p:sldId xmlns:r="http://schemas.openxmlformats.org/officeDocument/2006/relationships" id="260" r:id="R6ffb25c87c474426"/>
-    <p:sldId xmlns:r="http://schemas.openxmlformats.org/officeDocument/2006/relationships" id="261" r:id="Raedf1ebe7b234e2d"/>
-    <p:sldId xmlns:r="http://schemas.openxmlformats.org/officeDocument/2006/relationships" id="262" r:id="R21d1a66781c14a83"/>
-    <p:sldId xmlns:r="http://schemas.openxmlformats.org/officeDocument/2006/relationships" id="263" r:id="Rb8e91ce65bee4eed"/>
+    <p:sldId xmlns:r="http://schemas.openxmlformats.org/officeDocument/2006/relationships" id="256" r:id="R97cfb32fcb2c446d"/>
+    <p:sldId xmlns:r="http://schemas.openxmlformats.org/officeDocument/2006/relationships" id="257" r:id="R8c9a5b0c20c84e4c"/>
+    <p:sldId xmlns:r="http://schemas.openxmlformats.org/officeDocument/2006/relationships" id="258" r:id="Re0f1652207c8473f"/>
+    <p:sldId xmlns:r="http://schemas.openxmlformats.org/officeDocument/2006/relationships" id="259" r:id="R76a1e97e73744a20"/>
+    <p:sldId xmlns:r="http://schemas.openxmlformats.org/officeDocument/2006/relationships" id="260" r:id="Re23095db94864a7e"/>
+    <p:sldId xmlns:r="http://schemas.openxmlformats.org/officeDocument/2006/relationships" id="261" r:id="R0de5d302de5a4db1"/>
+    <p:sldId xmlns:r="http://schemas.openxmlformats.org/officeDocument/2006/relationships" id="262" r:id="Rccc452a5a2234a68"/>
+    <p:sldId xmlns:r="http://schemas.openxmlformats.org/officeDocument/2006/relationships" id="263" r:id="Ra4cac417885c4ebc"/>
   </p:sldIdLst>
   <p:sldSz cx="12192000" cy="6858000"/>
   <p:notesSz cx="6858000" cy="9144000"/>
@@ -1147,7 +1147,7 @@
   </p:cSld>
   <p:clrMap bg1="lt1" tx1="dk1" bg2="lt2" tx2="dk2" accent1="accent1" accent2="accent2" accent3="accent3" accent4="accent4" accent5="accent5" accent6="accent6" hlink="hlink" folHlink="folHlink"/>
   <p:sldLayoutIdLst>
-    <p:sldLayoutId xmlns:r="http://schemas.openxmlformats.org/officeDocument/2006/relationships" id="2147483649" r:id="R283e423a1c3c430b"/>
+    <p:sldLayoutId xmlns:r="http://schemas.openxmlformats.org/officeDocument/2006/relationships" id="2147483649" r:id="R17146ac6b6444597"/>
   </p:sldLayoutIdLst>
   <p:txStyles>
     <p:titleStyle>
@@ -1698,7 +1698,7 @@
           <p:cNvPr id="9" name="">
             <a:extLst xmlns:a="http://schemas.openxmlformats.org/drawingml/2006/main">
               <a:ext uri="{FF2B5EF4-FFF2-40B4-BE49-F238E27FC236}">
-                <a16:creationId xmlns:a16="http://schemas.microsoft.com/office/drawing/2014/main" id="{1AA2030C-E467-4611-A488-7CA18E167098}"/>
+                <a16:creationId xmlns:a16="http://schemas.microsoft.com/office/drawing/2014/main" id="{F2200CCB-E7DD-443C-B648-43AF1E48BFEE}"/>
               </a:ext>
             </a:extLst>
           </p:cNvPr>
@@ -1732,7 +1732,7 @@
           <p:nvPr/>
         </p:nvPicPr>
         <p:blipFill>
-          <a:blip xmlns:r="http://schemas.openxmlformats.org/officeDocument/2006/relationships" xmlns:a="http://schemas.openxmlformats.org/drawingml/2006/main" r:embed="R45aca1739b3d40b9"/>
+          <a:blip xmlns:r="http://schemas.openxmlformats.org/officeDocument/2006/relationships" xmlns:a="http://schemas.openxmlformats.org/drawingml/2006/main" r:embed="Rbcba652af2d543af"/>
           <a:stretch xmlns:a="http://schemas.openxmlformats.org/drawingml/2006/main"/>
         </p:blipFill>
         <p:spPr>
@@ -1750,7 +1750,7 @@
           <p:cNvPr id="3" name="">
             <a:extLst xmlns:a="http://schemas.openxmlformats.org/drawingml/2006/main">
               <a:ext uri="{FF2B5EF4-FFF2-40B4-BE49-F238E27FC236}">
-                <a16:creationId xmlns:a16="http://schemas.microsoft.com/office/drawing/2014/main" id="{FF1A0D73-D623-459D-A2AA-BC043694E5E1}"/>
+                <a16:creationId xmlns:a16="http://schemas.microsoft.com/office/drawing/2014/main" id="{F2CC314D-D0A1-481D-B8E6-8B2F6858E671}"/>
               </a:ext>
             </a:extLst>
           </p:cNvPr>
@@ -1807,7 +1807,7 @@
           <p:cNvPr id="4" name="">
             <a:extLst xmlns:a="http://schemas.openxmlformats.org/drawingml/2006/main">
               <a:ext uri="{FF2B5EF4-FFF2-40B4-BE49-F238E27FC236}">
-                <a16:creationId xmlns:a16="http://schemas.microsoft.com/office/drawing/2014/main" id="{15E22459-F465-4CCE-85E4-17F16F8F6AF2}"/>
+                <a16:creationId xmlns:a16="http://schemas.microsoft.com/office/drawing/2014/main" id="{E221612D-7E1A-41E2-A24E-E764D987D4FE}"/>
               </a:ext>
             </a:extLst>
           </p:cNvPr>
@@ -1864,7 +1864,7 @@
           <p:cNvPr id="5" name="">
             <a:extLst xmlns:a="http://schemas.openxmlformats.org/drawingml/2006/main">
               <a:ext uri="{FF2B5EF4-FFF2-40B4-BE49-F238E27FC236}">
-                <a16:creationId xmlns:a16="http://schemas.microsoft.com/office/drawing/2014/main" id="{06DF41F6-8B97-4B29-9133-F3E7EA27FDB6}"/>
+                <a16:creationId xmlns:a16="http://schemas.microsoft.com/office/drawing/2014/main" id="{05DF4B65-1463-43F5-82CF-D2BB6DE5835A}"/>
               </a:ext>
             </a:extLst>
           </p:cNvPr>
@@ -1894,7 +1894,7 @@
           <p:cNvPr id="6" name="">
             <a:extLst xmlns:a="http://schemas.openxmlformats.org/drawingml/2006/main">
               <a:ext uri="{FF2B5EF4-FFF2-40B4-BE49-F238E27FC236}">
-                <a16:creationId xmlns:a16="http://schemas.microsoft.com/office/drawing/2014/main" id="{67EC0D68-2F2D-43E0-9237-F6166547CED3}"/>
+                <a16:creationId xmlns:a16="http://schemas.microsoft.com/office/drawing/2014/main" id="{0D8A42B2-9A30-466D-8269-933CF9B7F78B}"/>
               </a:ext>
             </a:extLst>
           </p:cNvPr>
@@ -1951,7 +1951,7 @@
           <p:cNvPr id="7" name="">
             <a:extLst xmlns:a="http://schemas.openxmlformats.org/drawingml/2006/main">
               <a:ext uri="{FF2B5EF4-FFF2-40B4-BE49-F238E27FC236}">
-                <a16:creationId xmlns:a16="http://schemas.microsoft.com/office/drawing/2014/main" id="{B6E8F265-C36E-4153-A1F1-17D87197A86E}"/>
+                <a16:creationId xmlns:a16="http://schemas.microsoft.com/office/drawing/2014/main" id="{ABA443F7-B983-47EF-9130-8132551221A8}"/>
               </a:ext>
             </a:extLst>
           </p:cNvPr>
@@ -2008,7 +2008,7 @@
           <p:cNvPr id="8" name="">
             <a:extLst xmlns:a="http://schemas.openxmlformats.org/drawingml/2006/main">
               <a:ext uri="{FF2B5EF4-FFF2-40B4-BE49-F238E27FC236}">
-                <a16:creationId xmlns:a16="http://schemas.microsoft.com/office/drawing/2014/main" id="{66302412-59E0-4384-856A-BCE47FB9527C}"/>
+                <a16:creationId xmlns:a16="http://schemas.microsoft.com/office/drawing/2014/main" id="{D678AE84-8267-459F-9B5C-A99CA5F68D9B}"/>
               </a:ext>
             </a:extLst>
           </p:cNvPr>
@@ -2063,7 +2063,7 @@
     </p:spTree>
     <p:extLst>
       <p:ext uri="{BB962C8B-B14F-4D97-AF65-F5344CB8AC3E}">
-        <p14:creationId xmlns:p14="http://schemas.microsoft.com/office/powerpoint/2010/main" val="1333567519"/>
+        <p14:creationId xmlns:p14="http://schemas.microsoft.com/office/powerpoint/2010/main" val="1103289619"/>
       </p:ext>
     </p:extLst>
   </p:cSld>
@@ -2094,7 +2094,7 @@
           <p:cNvPr id="14" name="">
             <a:extLst xmlns:a="http://schemas.openxmlformats.org/drawingml/2006/main">
               <a:ext uri="{FF2B5EF4-FFF2-40B4-BE49-F238E27FC236}">
-                <a16:creationId xmlns:a16="http://schemas.microsoft.com/office/drawing/2014/main" id="{5FDA3E90-47C2-4DC0-B633-A9AE9DF4FA5A}"/>
+                <a16:creationId xmlns:a16="http://schemas.microsoft.com/office/drawing/2014/main" id="{6D5ADB83-95FA-4301-A21D-2F96BCC4CE43}"/>
               </a:ext>
             </a:extLst>
           </p:cNvPr>
@@ -2124,7 +2124,7 @@
           <p:cNvPr id="2" name="">
             <a:extLst xmlns:a="http://schemas.openxmlformats.org/drawingml/2006/main">
               <a:ext uri="{FF2B5EF4-FFF2-40B4-BE49-F238E27FC236}">
-                <a16:creationId xmlns:a16="http://schemas.microsoft.com/office/drawing/2014/main" id="{FFE9D182-848E-4ACA-BECB-24815C5BB15C}"/>
+                <a16:creationId xmlns:a16="http://schemas.microsoft.com/office/drawing/2014/main" id="{D9048C2C-8C72-4905-B577-AEE30CAF3820}"/>
               </a:ext>
             </a:extLst>
           </p:cNvPr>
@@ -2181,7 +2181,7 @@
           <p:cNvPr id="3" name="">
             <a:extLst xmlns:a="http://schemas.openxmlformats.org/drawingml/2006/main">
               <a:ext uri="{FF2B5EF4-FFF2-40B4-BE49-F238E27FC236}">
-                <a16:creationId xmlns:a16="http://schemas.microsoft.com/office/drawing/2014/main" id="{FFA4CB6E-7A5C-4D43-B0E3-C6E9E4E47059}"/>
+                <a16:creationId xmlns:a16="http://schemas.microsoft.com/office/drawing/2014/main" id="{ADF45C40-A763-412C-A30C-DEDE5D9F35CD}"/>
               </a:ext>
             </a:extLst>
           </p:cNvPr>
@@ -2238,7 +2238,7 @@
           <p:cNvPr id="4" name="">
             <a:extLst xmlns:a="http://schemas.openxmlformats.org/drawingml/2006/main">
               <a:ext uri="{FF2B5EF4-FFF2-40B4-BE49-F238E27FC236}">
-                <a16:creationId xmlns:a16="http://schemas.microsoft.com/office/drawing/2014/main" id="{CFABABAB-8A0A-489E-9686-02ED0EC4796F}"/>
+                <a16:creationId xmlns:a16="http://schemas.microsoft.com/office/drawing/2014/main" id="{6D407953-DDC6-4BEF-9195-34F06C7CBA8D}"/>
               </a:ext>
             </a:extLst>
           </p:cNvPr>
@@ -2295,7 +2295,7 @@
           <p:cNvPr id="5" name="">
             <a:extLst xmlns:a="http://schemas.openxmlformats.org/drawingml/2006/main">
               <a:ext uri="{FF2B5EF4-FFF2-40B4-BE49-F238E27FC236}">
-                <a16:creationId xmlns:a16="http://schemas.microsoft.com/office/drawing/2014/main" id="{D19A794A-E2A7-4C6D-B4BC-51C67584CB21}"/>
+                <a16:creationId xmlns:a16="http://schemas.microsoft.com/office/drawing/2014/main" id="{988F2121-3266-43F0-8F42-1B389A8BC76C}"/>
               </a:ext>
             </a:extLst>
           </p:cNvPr>
@@ -2352,7 +2352,7 @@
           <p:cNvPr id="6" name="">
             <a:extLst xmlns:a="http://schemas.openxmlformats.org/drawingml/2006/main">
               <a:ext uri="{FF2B5EF4-FFF2-40B4-BE49-F238E27FC236}">
-                <a16:creationId xmlns:a16="http://schemas.microsoft.com/office/drawing/2014/main" id="{921C3934-FFEA-497E-879B-237988A28B42}"/>
+                <a16:creationId xmlns:a16="http://schemas.microsoft.com/office/drawing/2014/main" id="{6E1CE1E2-ABE4-4EFA-8549-FAECE6C2A57D}"/>
               </a:ext>
             </a:extLst>
           </p:cNvPr>
@@ -2387,7 +2387,7 @@
           <p:cNvPr id="7" name="">
             <a:extLst xmlns:a="http://schemas.openxmlformats.org/drawingml/2006/main">
               <a:ext uri="{FF2B5EF4-FFF2-40B4-BE49-F238E27FC236}">
-                <a16:creationId xmlns:a16="http://schemas.microsoft.com/office/drawing/2014/main" id="{5DB600BF-79A2-40F3-B5DD-3CB2A6BCA424}"/>
+                <a16:creationId xmlns:a16="http://schemas.microsoft.com/office/drawing/2014/main" id="{5E2260CE-BB42-404B-8E56-9279AEC6BFC5}"/>
               </a:ext>
             </a:extLst>
           </p:cNvPr>
@@ -2444,7 +2444,7 @@
           <p:cNvPr id="8" name="">
             <a:extLst xmlns:a="http://schemas.openxmlformats.org/drawingml/2006/main">
               <a:ext uri="{FF2B5EF4-FFF2-40B4-BE49-F238E27FC236}">
-                <a16:creationId xmlns:a16="http://schemas.microsoft.com/office/drawing/2014/main" id="{2D0352FD-6904-4BED-8C33-07C7FEBFF990}"/>
+                <a16:creationId xmlns:a16="http://schemas.microsoft.com/office/drawing/2014/main" id="{4B9F6285-E35A-47BF-89AD-FB4857FFD5FF}"/>
               </a:ext>
             </a:extLst>
           </p:cNvPr>
@@ -2501,7 +2501,7 @@
           <p:cNvPr id="9" name="">
             <a:extLst xmlns:a="http://schemas.openxmlformats.org/drawingml/2006/main">
               <a:ext uri="{FF2B5EF4-FFF2-40B4-BE49-F238E27FC236}">
-                <a16:creationId xmlns:a16="http://schemas.microsoft.com/office/drawing/2014/main" id="{4569D770-E60F-4203-962A-C1A01C53E150}"/>
+                <a16:creationId xmlns:a16="http://schemas.microsoft.com/office/drawing/2014/main" id="{698C294F-086D-470E-A9F1-511B500C8A26}"/>
               </a:ext>
             </a:extLst>
           </p:cNvPr>
@@ -2558,7 +2558,7 @@
           <p:cNvPr id="10" name="">
             <a:extLst xmlns:a="http://schemas.openxmlformats.org/drawingml/2006/main">
               <a:ext uri="{FF2B5EF4-FFF2-40B4-BE49-F238E27FC236}">
-                <a16:creationId xmlns:a16="http://schemas.microsoft.com/office/drawing/2014/main" id="{BDD29442-87D7-4A3E-ACD9-172E58AD4477}"/>
+                <a16:creationId xmlns:a16="http://schemas.microsoft.com/office/drawing/2014/main" id="{764133CE-870E-42B4-AC54-56362B342E9B}"/>
               </a:ext>
             </a:extLst>
           </p:cNvPr>
@@ -2593,7 +2593,7 @@
           <p:cNvPr id="11" name="">
             <a:extLst xmlns:a="http://schemas.openxmlformats.org/drawingml/2006/main">
               <a:ext uri="{FF2B5EF4-FFF2-40B4-BE49-F238E27FC236}">
-                <a16:creationId xmlns:a16="http://schemas.microsoft.com/office/drawing/2014/main" id="{19FE1DEB-4CB0-49F5-8C41-478DBE64D269}"/>
+                <a16:creationId xmlns:a16="http://schemas.microsoft.com/office/drawing/2014/main" id="{570DC1C9-2541-4A31-B7DE-9374F3BC11EC}"/>
               </a:ext>
             </a:extLst>
           </p:cNvPr>
@@ -2650,7 +2650,7 @@
           <p:cNvPr id="12" name="">
             <a:extLst xmlns:a="http://schemas.openxmlformats.org/drawingml/2006/main">
               <a:ext uri="{FF2B5EF4-FFF2-40B4-BE49-F238E27FC236}">
-                <a16:creationId xmlns:a16="http://schemas.microsoft.com/office/drawing/2014/main" id="{96ADF5D9-AF26-46B9-8AE4-6516FB5D1F0F}"/>
+                <a16:creationId xmlns:a16="http://schemas.microsoft.com/office/drawing/2014/main" id="{B6FD6909-E98D-4339-A507-D6EA6FF07210}"/>
               </a:ext>
             </a:extLst>
           </p:cNvPr>
@@ -2707,7 +2707,7 @@
           <p:cNvPr id="13" name="">
             <a:extLst xmlns:a="http://schemas.openxmlformats.org/drawingml/2006/main">
               <a:ext uri="{FF2B5EF4-FFF2-40B4-BE49-F238E27FC236}">
-                <a16:creationId xmlns:a16="http://schemas.microsoft.com/office/drawing/2014/main" id="{4D7F0B58-A1EE-4BF9-B591-CD84FF32CAF9}"/>
+                <a16:creationId xmlns:a16="http://schemas.microsoft.com/office/drawing/2014/main" id="{BE080295-5D07-4895-9B4E-F4E4B3B7F88D}"/>
               </a:ext>
             </a:extLst>
           </p:cNvPr>
@@ -2762,7 +2762,7 @@
     </p:spTree>
     <p:extLst>
       <p:ext uri="{BB962C8B-B14F-4D97-AF65-F5344CB8AC3E}">
-        <p14:creationId xmlns:p14="http://schemas.microsoft.com/office/powerpoint/2010/main" val="210608071"/>
+        <p14:creationId xmlns:p14="http://schemas.microsoft.com/office/powerpoint/2010/main" val="723333205"/>
       </p:ext>
     </p:extLst>
   </p:cSld>
@@ -2793,7 +2793,7 @@
           <p:cNvPr id="17" name="">
             <a:extLst xmlns:a="http://schemas.openxmlformats.org/drawingml/2006/main">
               <a:ext uri="{FF2B5EF4-FFF2-40B4-BE49-F238E27FC236}">
-                <a16:creationId xmlns:a16="http://schemas.microsoft.com/office/drawing/2014/main" id="{3951B51A-9BDF-4680-9F37-F269DED6BDA4}"/>
+                <a16:creationId xmlns:a16="http://schemas.microsoft.com/office/drawing/2014/main" id="{547D8B80-49EE-456A-9648-B64824178DA9}"/>
               </a:ext>
             </a:extLst>
           </p:cNvPr>
@@ -2823,7 +2823,7 @@
           <p:cNvPr id="2" name="">
             <a:extLst xmlns:a="http://schemas.openxmlformats.org/drawingml/2006/main">
               <a:ext uri="{FF2B5EF4-FFF2-40B4-BE49-F238E27FC236}">
-                <a16:creationId xmlns:a16="http://schemas.microsoft.com/office/drawing/2014/main" id="{40081D88-86C2-42BD-A4DA-6E497E688FE4}"/>
+                <a16:creationId xmlns:a16="http://schemas.microsoft.com/office/drawing/2014/main" id="{58C532B3-4CB8-40DF-8C3E-C17936939DC6}"/>
               </a:ext>
             </a:extLst>
           </p:cNvPr>
@@ -2880,7 +2880,7 @@
           <p:cNvPr id="3" name="">
             <a:extLst xmlns:a="http://schemas.openxmlformats.org/drawingml/2006/main">
               <a:ext uri="{FF2B5EF4-FFF2-40B4-BE49-F238E27FC236}">
-                <a16:creationId xmlns:a16="http://schemas.microsoft.com/office/drawing/2014/main" id="{BB21AF2D-DDD4-4D70-8CA3-C813D1E8EAAE}"/>
+                <a16:creationId xmlns:a16="http://schemas.microsoft.com/office/drawing/2014/main" id="{567E5912-5345-4EC9-889C-7FC961A8F24C}"/>
               </a:ext>
             </a:extLst>
           </p:cNvPr>
@@ -2937,7 +2937,7 @@
           <p:cNvPr id="4" name="">
             <a:extLst xmlns:a="http://schemas.openxmlformats.org/drawingml/2006/main">
               <a:ext uri="{FF2B5EF4-FFF2-40B4-BE49-F238E27FC236}">
-                <a16:creationId xmlns:a16="http://schemas.microsoft.com/office/drawing/2014/main" id="{343346F2-77D3-4DE2-B3A2-0D4FA988B35F}"/>
+                <a16:creationId xmlns:a16="http://schemas.microsoft.com/office/drawing/2014/main" id="{0E68C3E1-9754-4390-9DCE-4AE90FF50DA4}"/>
               </a:ext>
             </a:extLst>
           </p:cNvPr>
@@ -2994,7 +2994,7 @@
           <p:cNvPr id="5" name="">
             <a:extLst xmlns:a="http://schemas.openxmlformats.org/drawingml/2006/main">
               <a:ext uri="{FF2B5EF4-FFF2-40B4-BE49-F238E27FC236}">
-                <a16:creationId xmlns:a16="http://schemas.microsoft.com/office/drawing/2014/main" id="{536CFE1E-6111-4D5D-8F64-60F1CC995F7A}"/>
+                <a16:creationId xmlns:a16="http://schemas.microsoft.com/office/drawing/2014/main" id="{08C2C766-C8B8-43C6-AD70-F153AB76F2DE}"/>
               </a:ext>
             </a:extLst>
           </p:cNvPr>
@@ -3033,7 +3033,7 @@
           <p:nvPr/>
         </p:nvPicPr>
         <p:blipFill>
-          <a:blip xmlns:r="http://schemas.openxmlformats.org/officeDocument/2006/relationships" xmlns:a="http://schemas.openxmlformats.org/drawingml/2006/main" r:embed="R32d7f5f388c141db"/>
+          <a:blip xmlns:r="http://schemas.openxmlformats.org/officeDocument/2006/relationships" xmlns:a="http://schemas.openxmlformats.org/drawingml/2006/main" r:embed="R59d9bd2eed52440e"/>
           <a:srcRect xmlns:a="http://schemas.openxmlformats.org/drawingml/2006/main" l="0" t="18027" r="0" b="18027"/>
           <a:stretch xmlns:a="http://schemas.openxmlformats.org/drawingml/2006/main">
             <a:fillRect l="0" t="0" r="0" b="0"/>
@@ -3056,7 +3056,7 @@
           <p:cNvPr id="7" name="">
             <a:extLst xmlns:a="http://schemas.openxmlformats.org/drawingml/2006/main">
               <a:ext uri="{FF2B5EF4-FFF2-40B4-BE49-F238E27FC236}">
-                <a16:creationId xmlns:a16="http://schemas.microsoft.com/office/drawing/2014/main" id="{E4B282D1-2E5F-4D07-B5AE-2B2135BBF851}"/>
+                <a16:creationId xmlns:a16="http://schemas.microsoft.com/office/drawing/2014/main" id="{0093DA1A-5C47-43C4-A0A6-72EC7534A970}"/>
               </a:ext>
             </a:extLst>
           </p:cNvPr>
@@ -3113,7 +3113,7 @@
           <p:cNvPr id="8" name="">
             <a:extLst xmlns:a="http://schemas.openxmlformats.org/drawingml/2006/main">
               <a:ext uri="{FF2B5EF4-FFF2-40B4-BE49-F238E27FC236}">
-                <a16:creationId xmlns:a16="http://schemas.microsoft.com/office/drawing/2014/main" id="{4AB6F316-595E-439E-90CE-9FA6D56253FE}"/>
+                <a16:creationId xmlns:a16="http://schemas.microsoft.com/office/drawing/2014/main" id="{7476BB07-7DF8-4AFE-9287-1CCE1BDB7440}"/>
               </a:ext>
             </a:extLst>
           </p:cNvPr>
@@ -3170,7 +3170,7 @@
           <p:cNvPr id="9" name="">
             <a:extLst xmlns:a="http://schemas.openxmlformats.org/drawingml/2006/main">
               <a:ext uri="{FF2B5EF4-FFF2-40B4-BE49-F238E27FC236}">
-                <a16:creationId xmlns:a16="http://schemas.microsoft.com/office/drawing/2014/main" id="{DC26FD7B-81DB-4EC0-BDAB-59406B92EAE5}"/>
+                <a16:creationId xmlns:a16="http://schemas.microsoft.com/office/drawing/2014/main" id="{60F5F742-9454-43DC-BA87-DBA7C5B6DF82}"/>
               </a:ext>
             </a:extLst>
           </p:cNvPr>
@@ -3227,7 +3227,7 @@
           <p:cNvPr id="10" name="">
             <a:extLst xmlns:a="http://schemas.openxmlformats.org/drawingml/2006/main">
               <a:ext uri="{FF2B5EF4-FFF2-40B4-BE49-F238E27FC236}">
-                <a16:creationId xmlns:a16="http://schemas.microsoft.com/office/drawing/2014/main" id="{688EAF51-632F-4632-86D1-D60BC97017FB}"/>
+                <a16:creationId xmlns:a16="http://schemas.microsoft.com/office/drawing/2014/main" id="{732EF85A-8A78-4CB5-90A8-7F5A2478A039}"/>
               </a:ext>
             </a:extLst>
           </p:cNvPr>
@@ -3284,7 +3284,7 @@
           <p:cNvPr id="11" name="">
             <a:extLst xmlns:a="http://schemas.openxmlformats.org/drawingml/2006/main">
               <a:ext uri="{FF2B5EF4-FFF2-40B4-BE49-F238E27FC236}">
-                <a16:creationId xmlns:a16="http://schemas.microsoft.com/office/drawing/2014/main" id="{11ACADAB-DD97-4636-94E7-0FD11E29CBC5}"/>
+                <a16:creationId xmlns:a16="http://schemas.microsoft.com/office/drawing/2014/main" id="{55C4E02C-F6EE-4C28-9DB0-B94306A5A49F}"/>
               </a:ext>
             </a:extLst>
           </p:cNvPr>
@@ -3341,7 +3341,7 @@
           <p:cNvPr id="12" name="">
             <a:extLst xmlns:a="http://schemas.openxmlformats.org/drawingml/2006/main">
               <a:ext uri="{FF2B5EF4-FFF2-40B4-BE49-F238E27FC236}">
-                <a16:creationId xmlns:a16="http://schemas.microsoft.com/office/drawing/2014/main" id="{9BE56A8B-BDF6-4720-85D6-B27C7441409B}"/>
+                <a16:creationId xmlns:a16="http://schemas.microsoft.com/office/drawing/2014/main" id="{DC7B45B4-BD57-4E34-ACC9-9DE2DBCA883F}"/>
               </a:ext>
             </a:extLst>
           </p:cNvPr>
@@ -3398,7 +3398,7 @@
           <p:cNvPr id="13" name="">
             <a:extLst xmlns:a="http://schemas.openxmlformats.org/drawingml/2006/main">
               <a:ext uri="{FF2B5EF4-FFF2-40B4-BE49-F238E27FC236}">
-                <a16:creationId xmlns:a16="http://schemas.microsoft.com/office/drawing/2014/main" id="{E3518093-09BB-4813-B3AD-F9FCF96337AC}"/>
+                <a16:creationId xmlns:a16="http://schemas.microsoft.com/office/drawing/2014/main" id="{72F623A1-F444-4411-821D-71ACB430CAE1}"/>
               </a:ext>
             </a:extLst>
           </p:cNvPr>
@@ -3455,7 +3455,7 @@
           <p:cNvPr id="14" name="">
             <a:extLst xmlns:a="http://schemas.openxmlformats.org/drawingml/2006/main">
               <a:ext uri="{FF2B5EF4-FFF2-40B4-BE49-F238E27FC236}">
-                <a16:creationId xmlns:a16="http://schemas.microsoft.com/office/drawing/2014/main" id="{4158B652-58CF-4536-BC4F-BEEC5F460746}"/>
+                <a16:creationId xmlns:a16="http://schemas.microsoft.com/office/drawing/2014/main" id="{1B750013-64AC-4533-BB5E-5BA100ED3DF9}"/>
               </a:ext>
             </a:extLst>
           </p:cNvPr>
@@ -3512,7 +3512,7 @@
           <p:cNvPr id="15" name="">
             <a:extLst xmlns:a="http://schemas.openxmlformats.org/drawingml/2006/main">
               <a:ext uri="{FF2B5EF4-FFF2-40B4-BE49-F238E27FC236}">
-                <a16:creationId xmlns:a16="http://schemas.microsoft.com/office/drawing/2014/main" id="{E3E518E1-8E84-4A56-92F4-70641A4F0602}"/>
+                <a16:creationId xmlns:a16="http://schemas.microsoft.com/office/drawing/2014/main" id="{30D068D1-2947-4FF4-8D18-44364C533A76}"/>
               </a:ext>
             </a:extLst>
           </p:cNvPr>
@@ -3569,7 +3569,7 @@
           <p:cNvPr id="16" name="">
             <a:extLst xmlns:a="http://schemas.openxmlformats.org/drawingml/2006/main">
               <a:ext uri="{FF2B5EF4-FFF2-40B4-BE49-F238E27FC236}">
-                <a16:creationId xmlns:a16="http://schemas.microsoft.com/office/drawing/2014/main" id="{5858696C-B8CA-41A4-BA33-EFB583A6DDD5}"/>
+                <a16:creationId xmlns:a16="http://schemas.microsoft.com/office/drawing/2014/main" id="{F59AE1F3-F354-4947-A737-3D8F306C085D}"/>
               </a:ext>
             </a:extLst>
           </p:cNvPr>
@@ -3624,7 +3624,7 @@
     </p:spTree>
     <p:extLst>
       <p:ext uri="{BB962C8B-B14F-4D97-AF65-F5344CB8AC3E}">
-        <p14:creationId xmlns:p14="http://schemas.microsoft.com/office/powerpoint/2010/main" val="799336920"/>
+        <p14:creationId xmlns:p14="http://schemas.microsoft.com/office/powerpoint/2010/main" val="1467849850"/>
       </p:ext>
     </p:extLst>
   </p:cSld>
@@ -3655,7 +3655,7 @@
           <p:cNvPr id="32" name="">
             <a:extLst xmlns:a="http://schemas.openxmlformats.org/drawingml/2006/main">
               <a:ext uri="{FF2B5EF4-FFF2-40B4-BE49-F238E27FC236}">
-                <a16:creationId xmlns:a16="http://schemas.microsoft.com/office/drawing/2014/main" id="{FE2402BC-AFBE-4F1E-8088-DE9ECD101368}"/>
+                <a16:creationId xmlns:a16="http://schemas.microsoft.com/office/drawing/2014/main" id="{4D1D1F1C-816D-4770-A3D6-390199E9088B}"/>
               </a:ext>
             </a:extLst>
           </p:cNvPr>
@@ -3685,7 +3685,7 @@
           <p:cNvPr id="2" name="">
             <a:extLst xmlns:a="http://schemas.openxmlformats.org/drawingml/2006/main">
               <a:ext uri="{FF2B5EF4-FFF2-40B4-BE49-F238E27FC236}">
-                <a16:creationId xmlns:a16="http://schemas.microsoft.com/office/drawing/2014/main" id="{233CA25A-2C9D-4952-BE2F-C85FA1D963DA}"/>
+                <a16:creationId xmlns:a16="http://schemas.microsoft.com/office/drawing/2014/main" id="{BFCCB984-0C80-4074-9805-673054494FF6}"/>
               </a:ext>
             </a:extLst>
           </p:cNvPr>
@@ -3742,7 +3742,7 @@
           <p:cNvPr id="3" name="">
             <a:extLst xmlns:a="http://schemas.openxmlformats.org/drawingml/2006/main">
               <a:ext uri="{FF2B5EF4-FFF2-40B4-BE49-F238E27FC236}">
-                <a16:creationId xmlns:a16="http://schemas.microsoft.com/office/drawing/2014/main" id="{A41E9D5C-E8B9-4705-AAD4-929ABF4E956B}"/>
+                <a16:creationId xmlns:a16="http://schemas.microsoft.com/office/drawing/2014/main" id="{CB95589C-90BE-4499-95FF-9B9DC5C84B10}"/>
               </a:ext>
             </a:extLst>
           </p:cNvPr>
@@ -3799,7 +3799,7 @@
           <p:cNvPr id="4" name="">
             <a:extLst xmlns:a="http://schemas.openxmlformats.org/drawingml/2006/main">
               <a:ext uri="{FF2B5EF4-FFF2-40B4-BE49-F238E27FC236}">
-                <a16:creationId xmlns:a16="http://schemas.microsoft.com/office/drawing/2014/main" id="{C77E6691-E6D6-401F-ADB3-E4EAD3E76D33}"/>
+                <a16:creationId xmlns:a16="http://schemas.microsoft.com/office/drawing/2014/main" id="{71A87614-BCEE-4921-8797-37B163A46265}"/>
               </a:ext>
             </a:extLst>
           </p:cNvPr>
@@ -3856,7 +3856,7 @@
           <p:cNvPr id="5" name="">
             <a:extLst xmlns:a="http://schemas.openxmlformats.org/drawingml/2006/main">
               <a:ext uri="{FF2B5EF4-FFF2-40B4-BE49-F238E27FC236}">
-                <a16:creationId xmlns:a16="http://schemas.microsoft.com/office/drawing/2014/main" id="{35822A1F-B5B2-4196-8F10-92FE94D29C4A}"/>
+                <a16:creationId xmlns:a16="http://schemas.microsoft.com/office/drawing/2014/main" id="{59A76829-16B4-4847-B114-0F31E34A88B6}"/>
               </a:ext>
             </a:extLst>
           </p:cNvPr>
@@ -3891,7 +3891,7 @@
           <p:cNvPr id="6" name="">
             <a:extLst xmlns:a="http://schemas.openxmlformats.org/drawingml/2006/main">
               <a:ext uri="{FF2B5EF4-FFF2-40B4-BE49-F238E27FC236}">
-                <a16:creationId xmlns:a16="http://schemas.microsoft.com/office/drawing/2014/main" id="{08056DBF-849A-4755-B99C-B34133247EBE}"/>
+                <a16:creationId xmlns:a16="http://schemas.microsoft.com/office/drawing/2014/main" id="{86D8589F-CAC6-46C4-B056-9BC87D671E44}"/>
               </a:ext>
             </a:extLst>
           </p:cNvPr>
@@ -3948,7 +3948,7 @@
           <p:cNvPr id="7" name="">
             <a:extLst xmlns:a="http://schemas.openxmlformats.org/drawingml/2006/main">
               <a:ext uri="{FF2B5EF4-FFF2-40B4-BE49-F238E27FC236}">
-                <a16:creationId xmlns:a16="http://schemas.microsoft.com/office/drawing/2014/main" id="{A028AD4E-1838-4FCD-95A2-B903454AB4E3}"/>
+                <a16:creationId xmlns:a16="http://schemas.microsoft.com/office/drawing/2014/main" id="{6BE7F70D-D31B-48D6-AE96-E9942B3EBEC4}"/>
               </a:ext>
             </a:extLst>
           </p:cNvPr>
@@ -4005,7 +4005,7 @@
           <p:cNvPr id="8" name="">
             <a:extLst xmlns:a="http://schemas.openxmlformats.org/drawingml/2006/main">
               <a:ext uri="{FF2B5EF4-FFF2-40B4-BE49-F238E27FC236}">
-                <a16:creationId xmlns:a16="http://schemas.microsoft.com/office/drawing/2014/main" id="{196134A7-CAD6-4975-B1E8-153351ED2455}"/>
+                <a16:creationId xmlns:a16="http://schemas.microsoft.com/office/drawing/2014/main" id="{A609AB96-6F8C-488B-A917-5E1B9BB7BBD4}"/>
               </a:ext>
             </a:extLst>
           </p:cNvPr>
@@ -4040,7 +4040,7 @@
           <p:cNvPr id="9" name="">
             <a:extLst xmlns:a="http://schemas.openxmlformats.org/drawingml/2006/main">
               <a:ext uri="{FF2B5EF4-FFF2-40B4-BE49-F238E27FC236}">
-                <a16:creationId xmlns:a16="http://schemas.microsoft.com/office/drawing/2014/main" id="{33460A2F-A8D0-4857-8C19-E36246B1EE22}"/>
+                <a16:creationId xmlns:a16="http://schemas.microsoft.com/office/drawing/2014/main" id="{ACBE0212-5081-46DB-B955-ECBDF5F1464A}"/>
               </a:ext>
             </a:extLst>
           </p:cNvPr>
@@ -4097,7 +4097,7 @@
           <p:cNvPr id="10" name="">
             <a:extLst xmlns:a="http://schemas.openxmlformats.org/drawingml/2006/main">
               <a:ext uri="{FF2B5EF4-FFF2-40B4-BE49-F238E27FC236}">
-                <a16:creationId xmlns:a16="http://schemas.microsoft.com/office/drawing/2014/main" id="{4CFA3DDB-7C65-4B6D-8F27-BFD108D8C1CD}"/>
+                <a16:creationId xmlns:a16="http://schemas.microsoft.com/office/drawing/2014/main" id="{0A3724C6-37FC-4A9D-87F5-667F97F6FDE6}"/>
               </a:ext>
             </a:extLst>
           </p:cNvPr>
@@ -4154,7 +4154,7 @@
           <p:cNvPr id="11" name="">
             <a:extLst xmlns:a="http://schemas.openxmlformats.org/drawingml/2006/main">
               <a:ext uri="{FF2B5EF4-FFF2-40B4-BE49-F238E27FC236}">
-                <a16:creationId xmlns:a16="http://schemas.microsoft.com/office/drawing/2014/main" id="{23794B59-B826-4BEE-BE66-849CB124861E}"/>
+                <a16:creationId xmlns:a16="http://schemas.microsoft.com/office/drawing/2014/main" id="{A551E78E-C655-4E43-B162-CEEC1D588EAE}"/>
               </a:ext>
             </a:extLst>
           </p:cNvPr>
@@ -4189,7 +4189,7 @@
           <p:cNvPr id="12" name="">
             <a:extLst xmlns:a="http://schemas.openxmlformats.org/drawingml/2006/main">
               <a:ext uri="{FF2B5EF4-FFF2-40B4-BE49-F238E27FC236}">
-                <a16:creationId xmlns:a16="http://schemas.microsoft.com/office/drawing/2014/main" id="{2CD5EEF7-79BC-437D-960A-040B84F896AF}"/>
+                <a16:creationId xmlns:a16="http://schemas.microsoft.com/office/drawing/2014/main" id="{250403D6-E1C0-4AD3-9FAF-73D1F9C84596}"/>
               </a:ext>
             </a:extLst>
           </p:cNvPr>
@@ -4246,7 +4246,7 @@
           <p:cNvPr id="13" name="">
             <a:extLst xmlns:a="http://schemas.openxmlformats.org/drawingml/2006/main">
               <a:ext uri="{FF2B5EF4-FFF2-40B4-BE49-F238E27FC236}">
-                <a16:creationId xmlns:a16="http://schemas.microsoft.com/office/drawing/2014/main" id="{CFFF5713-717C-40CD-A55E-0B47A75266A1}"/>
+                <a16:creationId xmlns:a16="http://schemas.microsoft.com/office/drawing/2014/main" id="{602740E8-0BC6-46D5-B13E-8A1E3911016B}"/>
               </a:ext>
             </a:extLst>
           </p:cNvPr>
@@ -4326,7 +4326,7 @@
           <p:cNvPr id="14" name="">
             <a:extLst xmlns:a="http://schemas.openxmlformats.org/drawingml/2006/main">
               <a:ext uri="{FF2B5EF4-FFF2-40B4-BE49-F238E27FC236}">
-                <a16:creationId xmlns:a16="http://schemas.microsoft.com/office/drawing/2014/main" id="{919586C1-3851-40AC-98F4-22AB44CEB69D}"/>
+                <a16:creationId xmlns:a16="http://schemas.microsoft.com/office/drawing/2014/main" id="{16C3F763-A892-484E-AE14-FF68229FAF18}"/>
               </a:ext>
             </a:extLst>
           </p:cNvPr>
@@ -4361,7 +4361,7 @@
           <p:cNvPr id="15" name="">
             <a:extLst xmlns:a="http://schemas.openxmlformats.org/drawingml/2006/main">
               <a:ext uri="{FF2B5EF4-FFF2-40B4-BE49-F238E27FC236}">
-                <a16:creationId xmlns:a16="http://schemas.microsoft.com/office/drawing/2014/main" id="{D782C08E-B587-4C38-9B73-4F74D942E474}"/>
+                <a16:creationId xmlns:a16="http://schemas.microsoft.com/office/drawing/2014/main" id="{7B206697-B5BB-4F85-B8CA-B98C04AFE848}"/>
               </a:ext>
             </a:extLst>
           </p:cNvPr>
@@ -4418,7 +4418,7 @@
           <p:cNvPr id="16" name="">
             <a:extLst xmlns:a="http://schemas.openxmlformats.org/drawingml/2006/main">
               <a:ext uri="{FF2B5EF4-FFF2-40B4-BE49-F238E27FC236}">
-                <a16:creationId xmlns:a16="http://schemas.microsoft.com/office/drawing/2014/main" id="{45E08C51-3F0B-4200-BF4C-F7B8A720B612}"/>
+                <a16:creationId xmlns:a16="http://schemas.microsoft.com/office/drawing/2014/main" id="{9748EA4D-6113-4D62-848D-EEF79478F4E4}"/>
               </a:ext>
             </a:extLst>
           </p:cNvPr>
@@ -4553,7 +4553,7 @@
           <p:cNvPr id="20" name="">
             <a:extLst xmlns:a="http://schemas.openxmlformats.org/drawingml/2006/main">
               <a:ext uri="{FF2B5EF4-FFF2-40B4-BE49-F238E27FC236}">
-                <a16:creationId xmlns:a16="http://schemas.microsoft.com/office/drawing/2014/main" id="{A91835E4-C3B7-4DCD-A1A4-F39554308A3C}"/>
+                <a16:creationId xmlns:a16="http://schemas.microsoft.com/office/drawing/2014/main" id="{2D293D5D-E713-4E64-AE2C-648CB8073929}"/>
               </a:ext>
             </a:extLst>
           </p:cNvPr>
@@ -4588,7 +4588,7 @@
           <p:cNvPr id="21" name="">
             <a:extLst xmlns:a="http://schemas.openxmlformats.org/drawingml/2006/main">
               <a:ext uri="{FF2B5EF4-FFF2-40B4-BE49-F238E27FC236}">
-                <a16:creationId xmlns:a16="http://schemas.microsoft.com/office/drawing/2014/main" id="{ACD2520A-813B-4381-BDA8-826EDBF6167A}"/>
+                <a16:creationId xmlns:a16="http://schemas.microsoft.com/office/drawing/2014/main" id="{57F03553-3654-4C13-BE7B-689F8C425373}"/>
               </a:ext>
             </a:extLst>
           </p:cNvPr>
@@ -4645,7 +4645,7 @@
           <p:cNvPr id="22" name="">
             <a:extLst xmlns:a="http://schemas.openxmlformats.org/drawingml/2006/main">
               <a:ext uri="{FF2B5EF4-FFF2-40B4-BE49-F238E27FC236}">
-                <a16:creationId xmlns:a16="http://schemas.microsoft.com/office/drawing/2014/main" id="{A9A33CFC-1DFF-4762-9266-16798A76A54C}"/>
+                <a16:creationId xmlns:a16="http://schemas.microsoft.com/office/drawing/2014/main" id="{C3BF8127-A32D-42D5-977E-6D60981E7DEB}"/>
               </a:ext>
             </a:extLst>
           </p:cNvPr>
@@ -4702,7 +4702,7 @@
           <p:cNvPr id="23" name="">
             <a:extLst xmlns:a="http://schemas.openxmlformats.org/drawingml/2006/main">
               <a:ext uri="{FF2B5EF4-FFF2-40B4-BE49-F238E27FC236}">
-                <a16:creationId xmlns:a16="http://schemas.microsoft.com/office/drawing/2014/main" id="{F7C2E845-B1F2-4AD5-BE2D-6591285BB33D}"/>
+                <a16:creationId xmlns:a16="http://schemas.microsoft.com/office/drawing/2014/main" id="{90455D7A-9224-44E7-A0F8-852522E7A632}"/>
               </a:ext>
             </a:extLst>
           </p:cNvPr>
@@ -4737,7 +4737,7 @@
           <p:cNvPr id="24" name="">
             <a:extLst xmlns:a="http://schemas.openxmlformats.org/drawingml/2006/main">
               <a:ext uri="{FF2B5EF4-FFF2-40B4-BE49-F238E27FC236}">
-                <a16:creationId xmlns:a16="http://schemas.microsoft.com/office/drawing/2014/main" id="{55889E3F-55AE-411C-BE8B-8B527556F74B}"/>
+                <a16:creationId xmlns:a16="http://schemas.microsoft.com/office/drawing/2014/main" id="{AE917B34-8B3B-430F-95A0-D084B55A2012}"/>
               </a:ext>
             </a:extLst>
           </p:cNvPr>
@@ -4794,7 +4794,7 @@
           <p:cNvPr id="25" name="">
             <a:extLst xmlns:a="http://schemas.openxmlformats.org/drawingml/2006/main">
               <a:ext uri="{FF2B5EF4-FFF2-40B4-BE49-F238E27FC236}">
-                <a16:creationId xmlns:a16="http://schemas.microsoft.com/office/drawing/2014/main" id="{888A349E-984D-4FF0-97BF-7AA415B633D1}"/>
+                <a16:creationId xmlns:a16="http://schemas.microsoft.com/office/drawing/2014/main" id="{C3AB756C-E2D5-4BB4-AB32-B1B73A383001}"/>
               </a:ext>
             </a:extLst>
           </p:cNvPr>
@@ -4897,7 +4897,7 @@
           <p:cNvPr id="26" name="">
             <a:extLst xmlns:a="http://schemas.openxmlformats.org/drawingml/2006/main">
               <a:ext uri="{FF2B5EF4-FFF2-40B4-BE49-F238E27FC236}">
-                <a16:creationId xmlns:a16="http://schemas.microsoft.com/office/drawing/2014/main" id="{4D6C0BF4-543D-4C1B-98F0-274F5688389F}"/>
+                <a16:creationId xmlns:a16="http://schemas.microsoft.com/office/drawing/2014/main" id="{D618142F-B2BE-43F9-B63D-3153DFE866DB}"/>
               </a:ext>
             </a:extLst>
           </p:cNvPr>
@@ -4932,7 +4932,7 @@
           <p:cNvPr id="27" name="">
             <a:extLst xmlns:a="http://schemas.openxmlformats.org/drawingml/2006/main">
               <a:ext uri="{FF2B5EF4-FFF2-40B4-BE49-F238E27FC236}">
-                <a16:creationId xmlns:a16="http://schemas.microsoft.com/office/drawing/2014/main" id="{C289EA76-C4F1-4013-987E-CBDB5E5B2A3B}"/>
+                <a16:creationId xmlns:a16="http://schemas.microsoft.com/office/drawing/2014/main" id="{C4AC19CF-F1A1-4A5B-88DC-B3B10B247B03}"/>
               </a:ext>
             </a:extLst>
           </p:cNvPr>
@@ -4989,7 +4989,7 @@
           <p:cNvPr id="28" name="">
             <a:extLst xmlns:a="http://schemas.openxmlformats.org/drawingml/2006/main">
               <a:ext uri="{FF2B5EF4-FFF2-40B4-BE49-F238E27FC236}">
-                <a16:creationId xmlns:a16="http://schemas.microsoft.com/office/drawing/2014/main" id="{63D64BE2-89AB-436A-9161-726404BE406B}"/>
+                <a16:creationId xmlns:a16="http://schemas.microsoft.com/office/drawing/2014/main" id="{C321D33A-4379-4A46-9808-AFB36F9F5E91}"/>
               </a:ext>
             </a:extLst>
           </p:cNvPr>
@@ -5144,7 +5144,7 @@
           <p:cNvPr id="31" name="">
             <a:extLst xmlns:a="http://schemas.openxmlformats.org/drawingml/2006/main">
               <a:ext uri="{FF2B5EF4-FFF2-40B4-BE49-F238E27FC236}">
-                <a16:creationId xmlns:a16="http://schemas.microsoft.com/office/drawing/2014/main" id="{39C4C26B-2BC9-4359-9690-C85EACDE1779}"/>
+                <a16:creationId xmlns:a16="http://schemas.microsoft.com/office/drawing/2014/main" id="{4EE671A8-422D-4BEE-BA22-FD563066F703}"/>
               </a:ext>
             </a:extLst>
           </p:cNvPr>
@@ -5199,7 +5199,7 @@
     </p:spTree>
     <p:extLst>
       <p:ext uri="{BB962C8B-B14F-4D97-AF65-F5344CB8AC3E}">
-        <p14:creationId xmlns:p14="http://schemas.microsoft.com/office/powerpoint/2010/main" val="394963305"/>
+        <p14:creationId xmlns:p14="http://schemas.microsoft.com/office/powerpoint/2010/main" val="400189143"/>
       </p:ext>
     </p:extLst>
   </p:cSld>
@@ -5230,7 +5230,7 @@
           <p:cNvPr id="21" name="">
             <a:extLst xmlns:a="http://schemas.openxmlformats.org/drawingml/2006/main">
               <a:ext uri="{FF2B5EF4-FFF2-40B4-BE49-F238E27FC236}">
-                <a16:creationId xmlns:a16="http://schemas.microsoft.com/office/drawing/2014/main" id="{714628D4-207B-463F-B4F0-55BBA6E54B16}"/>
+                <a16:creationId xmlns:a16="http://schemas.microsoft.com/office/drawing/2014/main" id="{EDBAEC84-7254-4C63-944B-DF13E2FE455A}"/>
               </a:ext>
             </a:extLst>
           </p:cNvPr>
@@ -5260,7 +5260,7 @@
           <p:cNvPr id="2" name="">
             <a:extLst xmlns:a="http://schemas.openxmlformats.org/drawingml/2006/main">
               <a:ext uri="{FF2B5EF4-FFF2-40B4-BE49-F238E27FC236}">
-                <a16:creationId xmlns:a16="http://schemas.microsoft.com/office/drawing/2014/main" id="{C79A70D1-B483-4A15-87D7-DAA9B02AB4AE}"/>
+                <a16:creationId xmlns:a16="http://schemas.microsoft.com/office/drawing/2014/main" id="{D0EF6201-232A-40FD-9882-38D301884BCF}"/>
               </a:ext>
             </a:extLst>
           </p:cNvPr>
@@ -5317,7 +5317,7 @@
           <p:cNvPr id="3" name="">
             <a:extLst xmlns:a="http://schemas.openxmlformats.org/drawingml/2006/main">
               <a:ext uri="{FF2B5EF4-FFF2-40B4-BE49-F238E27FC236}">
-                <a16:creationId xmlns:a16="http://schemas.microsoft.com/office/drawing/2014/main" id="{2A2508CD-4129-4146-815D-FA33A3252294}"/>
+                <a16:creationId xmlns:a16="http://schemas.microsoft.com/office/drawing/2014/main" id="{668725BB-24CE-49D3-AB50-722F3A5C256C}"/>
               </a:ext>
             </a:extLst>
           </p:cNvPr>
@@ -5374,7 +5374,7 @@
           <p:cNvPr id="4" name="">
             <a:extLst xmlns:a="http://schemas.openxmlformats.org/drawingml/2006/main">
               <a:ext uri="{FF2B5EF4-FFF2-40B4-BE49-F238E27FC236}">
-                <a16:creationId xmlns:a16="http://schemas.microsoft.com/office/drawing/2014/main" id="{902957E1-D840-42CF-B7B9-0316F40E7133}"/>
+                <a16:creationId xmlns:a16="http://schemas.microsoft.com/office/drawing/2014/main" id="{E58310C3-4607-4386-A6A7-452EEA0BA521}"/>
               </a:ext>
             </a:extLst>
           </p:cNvPr>
@@ -5431,7 +5431,7 @@
           <p:cNvPr id="5" name="">
             <a:extLst xmlns:a="http://schemas.openxmlformats.org/drawingml/2006/main">
               <a:ext uri="{FF2B5EF4-FFF2-40B4-BE49-F238E27FC236}">
-                <a16:creationId xmlns:a16="http://schemas.microsoft.com/office/drawing/2014/main" id="{42092534-1384-41C2-8240-68F4F9283BC0}"/>
+                <a16:creationId xmlns:a16="http://schemas.microsoft.com/office/drawing/2014/main" id="{D9D009F2-B0EC-43BF-9391-A5AFEB79A637}"/>
               </a:ext>
             </a:extLst>
           </p:cNvPr>
@@ -5488,7 +5488,7 @@
           <p:cNvPr id="6" name="">
             <a:extLst xmlns:a="http://schemas.openxmlformats.org/drawingml/2006/main">
               <a:ext uri="{FF2B5EF4-FFF2-40B4-BE49-F238E27FC236}">
-                <a16:creationId xmlns:a16="http://schemas.microsoft.com/office/drawing/2014/main" id="{4F6BAFAA-093C-4FC9-A874-82CAEE5F9100}"/>
+                <a16:creationId xmlns:a16="http://schemas.microsoft.com/office/drawing/2014/main" id="{40534420-8D24-4D83-AC8C-99EAEC2B211B}"/>
               </a:ext>
             </a:extLst>
           </p:cNvPr>
@@ -5545,7 +5545,7 @@
           <p:cNvPr id="7" name="">
             <a:extLst xmlns:a="http://schemas.openxmlformats.org/drawingml/2006/main">
               <a:ext uri="{FF2B5EF4-FFF2-40B4-BE49-F238E27FC236}">
-                <a16:creationId xmlns:a16="http://schemas.microsoft.com/office/drawing/2014/main" id="{75D279F9-794C-4885-8D45-B385E96A6258}"/>
+                <a16:creationId xmlns:a16="http://schemas.microsoft.com/office/drawing/2014/main" id="{CBAD4825-70A0-4BAB-98A0-618F29289750}"/>
               </a:ext>
             </a:extLst>
           </p:cNvPr>
@@ -5602,7 +5602,7 @@
           <p:cNvPr id="8" name="">
             <a:extLst xmlns:a="http://schemas.openxmlformats.org/drawingml/2006/main">
               <a:ext uri="{FF2B5EF4-FFF2-40B4-BE49-F238E27FC236}">
-                <a16:creationId xmlns:a16="http://schemas.microsoft.com/office/drawing/2014/main" id="{8ABC4E9E-4B25-4A22-980D-EF73CB74A95B}"/>
+                <a16:creationId xmlns:a16="http://schemas.microsoft.com/office/drawing/2014/main" id="{4504C477-E1DF-4373-9EA2-54E662145B4D}"/>
               </a:ext>
             </a:extLst>
           </p:cNvPr>
@@ -5632,7 +5632,7 @@
           <p:cNvPr id="9" name="">
             <a:extLst xmlns:a="http://schemas.openxmlformats.org/drawingml/2006/main">
               <a:ext uri="{FF2B5EF4-FFF2-40B4-BE49-F238E27FC236}">
-                <a16:creationId xmlns:a16="http://schemas.microsoft.com/office/drawing/2014/main" id="{5CF3DE79-0431-484F-8811-D18EB54D63CD}"/>
+                <a16:creationId xmlns:a16="http://schemas.microsoft.com/office/drawing/2014/main" id="{40C8EC05-D30B-4EB6-83E5-EAB2191916CC}"/>
               </a:ext>
             </a:extLst>
           </p:cNvPr>
@@ -5689,7 +5689,7 @@
           <p:cNvPr id="10" name="">
             <a:extLst xmlns:a="http://schemas.openxmlformats.org/drawingml/2006/main">
               <a:ext uri="{FF2B5EF4-FFF2-40B4-BE49-F238E27FC236}">
-                <a16:creationId xmlns:a16="http://schemas.microsoft.com/office/drawing/2014/main" id="{9F81AA1C-74BE-4340-ADD3-A5AFE98A298F}"/>
+                <a16:creationId xmlns:a16="http://schemas.microsoft.com/office/drawing/2014/main" id="{6E785CE8-4C75-4C37-B607-02CFFDADFF92}"/>
               </a:ext>
             </a:extLst>
           </p:cNvPr>
@@ -5746,7 +5746,7 @@
           <p:cNvPr id="11" name="">
             <a:extLst xmlns:a="http://schemas.openxmlformats.org/drawingml/2006/main">
               <a:ext uri="{FF2B5EF4-FFF2-40B4-BE49-F238E27FC236}">
-                <a16:creationId xmlns:a16="http://schemas.microsoft.com/office/drawing/2014/main" id="{CBB69DE1-E9C0-4998-840B-E5FCAF0806EB}"/>
+                <a16:creationId xmlns:a16="http://schemas.microsoft.com/office/drawing/2014/main" id="{C5CBD3C2-DF81-4E98-BA91-D45DD572AF76}"/>
               </a:ext>
             </a:extLst>
           </p:cNvPr>
@@ -5803,7 +5803,7 @@
           <p:cNvPr id="12" name="">
             <a:extLst xmlns:a="http://schemas.openxmlformats.org/drawingml/2006/main">
               <a:ext uri="{FF2B5EF4-FFF2-40B4-BE49-F238E27FC236}">
-                <a16:creationId xmlns:a16="http://schemas.microsoft.com/office/drawing/2014/main" id="{F8790D38-B5F8-4FE7-B9D5-B6E47717B174}"/>
+                <a16:creationId xmlns:a16="http://schemas.microsoft.com/office/drawing/2014/main" id="{B55B98B1-AB22-4E4A-9614-9185CF3FC825}"/>
               </a:ext>
             </a:extLst>
           </p:cNvPr>
@@ -5833,7 +5833,7 @@
           <p:cNvPr id="13" name="">
             <a:extLst xmlns:a="http://schemas.openxmlformats.org/drawingml/2006/main">
               <a:ext uri="{FF2B5EF4-FFF2-40B4-BE49-F238E27FC236}">
-                <a16:creationId xmlns:a16="http://schemas.microsoft.com/office/drawing/2014/main" id="{4C1B8ECA-B6EA-409E-BD26-06552755C98A}"/>
+                <a16:creationId xmlns:a16="http://schemas.microsoft.com/office/drawing/2014/main" id="{0C09466E-85A7-47B3-87CD-3903E3B0CDC6}"/>
               </a:ext>
             </a:extLst>
           </p:cNvPr>
@@ -5890,7 +5890,7 @@
           <p:cNvPr id="14" name="">
             <a:extLst xmlns:a="http://schemas.openxmlformats.org/drawingml/2006/main">
               <a:ext uri="{FF2B5EF4-FFF2-40B4-BE49-F238E27FC236}">
-                <a16:creationId xmlns:a16="http://schemas.microsoft.com/office/drawing/2014/main" id="{22F0C3B3-FE27-4404-A8FD-BA81BEB8ED5B}"/>
+                <a16:creationId xmlns:a16="http://schemas.microsoft.com/office/drawing/2014/main" id="{27774C62-D372-4E11-805D-3444D42A1E39}"/>
               </a:ext>
             </a:extLst>
           </p:cNvPr>
@@ -5947,7 +5947,7 @@
           <p:cNvPr id="15" name="">
             <a:extLst xmlns:a="http://schemas.openxmlformats.org/drawingml/2006/main">
               <a:ext uri="{FF2B5EF4-FFF2-40B4-BE49-F238E27FC236}">
-                <a16:creationId xmlns:a16="http://schemas.microsoft.com/office/drawing/2014/main" id="{657FBA56-1137-46D0-B77E-58DBC5944A6D}"/>
+                <a16:creationId xmlns:a16="http://schemas.microsoft.com/office/drawing/2014/main" id="{C8B6CE03-4327-415C-8A2E-0B9859968029}"/>
               </a:ext>
             </a:extLst>
           </p:cNvPr>
@@ -6004,7 +6004,7 @@
           <p:cNvPr id="16" name="">
             <a:extLst xmlns:a="http://schemas.openxmlformats.org/drawingml/2006/main">
               <a:ext uri="{FF2B5EF4-FFF2-40B4-BE49-F238E27FC236}">
-                <a16:creationId xmlns:a16="http://schemas.microsoft.com/office/drawing/2014/main" id="{37899A06-9B1B-4A03-A7E2-976AA99B918D}"/>
+                <a16:creationId xmlns:a16="http://schemas.microsoft.com/office/drawing/2014/main" id="{8B32F0DA-D23F-436F-8CB1-A5D44DEE8347}"/>
               </a:ext>
             </a:extLst>
           </p:cNvPr>
@@ -6061,7 +6061,7 @@
           <p:cNvPr id="17" name="">
             <a:extLst xmlns:a="http://schemas.openxmlformats.org/drawingml/2006/main">
               <a:ext uri="{FF2B5EF4-FFF2-40B4-BE49-F238E27FC236}">
-                <a16:creationId xmlns:a16="http://schemas.microsoft.com/office/drawing/2014/main" id="{B12C6877-603A-405E-9C4B-39233D7B1545}"/>
+                <a16:creationId xmlns:a16="http://schemas.microsoft.com/office/drawing/2014/main" id="{C7500CA8-4B8F-4270-8F72-A2A729924747}"/>
               </a:ext>
             </a:extLst>
           </p:cNvPr>
@@ -6118,7 +6118,7 @@
           <p:cNvPr id="18" name="">
             <a:extLst xmlns:a="http://schemas.openxmlformats.org/drawingml/2006/main">
               <a:ext uri="{FF2B5EF4-FFF2-40B4-BE49-F238E27FC236}">
-                <a16:creationId xmlns:a16="http://schemas.microsoft.com/office/drawing/2014/main" id="{CCDAFC3D-4E25-427F-A470-5A9D7EF6DEDD}"/>
+                <a16:creationId xmlns:a16="http://schemas.microsoft.com/office/drawing/2014/main" id="{DAB1C7C3-0BDE-4812-ABB3-C741D5039669}"/>
               </a:ext>
             </a:extLst>
           </p:cNvPr>
@@ -6175,7 +6175,7 @@
           <p:cNvPr id="19" name="">
             <a:extLst xmlns:a="http://schemas.openxmlformats.org/drawingml/2006/main">
               <a:ext uri="{FF2B5EF4-FFF2-40B4-BE49-F238E27FC236}">
-                <a16:creationId xmlns:a16="http://schemas.microsoft.com/office/drawing/2014/main" id="{2EBC3343-7EA4-4BEE-9BA6-9840BE32DDF2}"/>
+                <a16:creationId xmlns:a16="http://schemas.microsoft.com/office/drawing/2014/main" id="{C6886FEA-85B7-4B55-AC7F-BCADE43D9EF6}"/>
               </a:ext>
             </a:extLst>
           </p:cNvPr>
@@ -6207,7 +6207,7 @@
           <p:cNvPr id="20" name="">
             <a:extLst xmlns:a="http://schemas.openxmlformats.org/drawingml/2006/main">
               <a:ext uri="{FF2B5EF4-FFF2-40B4-BE49-F238E27FC236}">
-                <a16:creationId xmlns:a16="http://schemas.microsoft.com/office/drawing/2014/main" id="{562E9416-818B-4C0C-AC8E-A5970CD61BC3}"/>
+                <a16:creationId xmlns:a16="http://schemas.microsoft.com/office/drawing/2014/main" id="{91A9A7CF-A525-410C-8458-A14F59B55189}"/>
               </a:ext>
             </a:extLst>
           </p:cNvPr>
@@ -6262,7 +6262,7 @@
     </p:spTree>
     <p:extLst>
       <p:ext uri="{BB962C8B-B14F-4D97-AF65-F5344CB8AC3E}">
-        <p14:creationId xmlns:p14="http://schemas.microsoft.com/office/powerpoint/2010/main" val="228776042"/>
+        <p14:creationId xmlns:p14="http://schemas.microsoft.com/office/powerpoint/2010/main" val="1417459753"/>
       </p:ext>
     </p:extLst>
   </p:cSld>
@@ -6293,7 +6293,7 @@
           <p:cNvPr id="20" name="">
             <a:extLst xmlns:a="http://schemas.openxmlformats.org/drawingml/2006/main">
               <a:ext uri="{FF2B5EF4-FFF2-40B4-BE49-F238E27FC236}">
-                <a16:creationId xmlns:a16="http://schemas.microsoft.com/office/drawing/2014/main" id="{3742F7FB-76C3-4F56-9940-4EAB2EA552B6}"/>
+                <a16:creationId xmlns:a16="http://schemas.microsoft.com/office/drawing/2014/main" id="{8877FF3B-EFFA-4E83-9C40-468E1E4E70CF}"/>
               </a:ext>
             </a:extLst>
           </p:cNvPr>
@@ -6323,7 +6323,7 @@
           <p:cNvPr id="2" name="">
             <a:extLst xmlns:a="http://schemas.openxmlformats.org/drawingml/2006/main">
               <a:ext uri="{FF2B5EF4-FFF2-40B4-BE49-F238E27FC236}">
-                <a16:creationId xmlns:a16="http://schemas.microsoft.com/office/drawing/2014/main" id="{553ECBB4-3F8B-445B-9FC6-FEA40826FF82}"/>
+                <a16:creationId xmlns:a16="http://schemas.microsoft.com/office/drawing/2014/main" id="{4C185F45-507D-48B2-BFD1-8AF8970AD82C}"/>
               </a:ext>
             </a:extLst>
           </p:cNvPr>
@@ -6380,7 +6380,7 @@
           <p:cNvPr id="3" name="">
             <a:extLst xmlns:a="http://schemas.openxmlformats.org/drawingml/2006/main">
               <a:ext uri="{FF2B5EF4-FFF2-40B4-BE49-F238E27FC236}">
-                <a16:creationId xmlns:a16="http://schemas.microsoft.com/office/drawing/2014/main" id="{5AFF637D-1971-4769-87A0-C866EAA1EC5F}"/>
+                <a16:creationId xmlns:a16="http://schemas.microsoft.com/office/drawing/2014/main" id="{DD23CC51-05FC-465D-9136-D0089276F3F0}"/>
               </a:ext>
             </a:extLst>
           </p:cNvPr>
@@ -6437,7 +6437,7 @@
           <p:cNvPr id="4" name="">
             <a:extLst xmlns:a="http://schemas.openxmlformats.org/drawingml/2006/main">
               <a:ext uri="{FF2B5EF4-FFF2-40B4-BE49-F238E27FC236}">
-                <a16:creationId xmlns:a16="http://schemas.microsoft.com/office/drawing/2014/main" id="{0761ED2C-E2CC-42B7-94B6-7F5B25D68E94}"/>
+                <a16:creationId xmlns:a16="http://schemas.microsoft.com/office/drawing/2014/main" id="{B7D17350-160A-4748-9587-42C3D5D4445C}"/>
               </a:ext>
             </a:extLst>
           </p:cNvPr>
@@ -6494,7 +6494,7 @@
           <p:cNvPr id="5" name="">
             <a:extLst xmlns:a="http://schemas.openxmlformats.org/drawingml/2006/main">
               <a:ext uri="{FF2B5EF4-FFF2-40B4-BE49-F238E27FC236}">
-                <a16:creationId xmlns:a16="http://schemas.microsoft.com/office/drawing/2014/main" id="{499CE4AA-267E-45AD-A369-0867B3A9EDA8}"/>
+                <a16:creationId xmlns:a16="http://schemas.microsoft.com/office/drawing/2014/main" id="{598A6687-062E-484A-ADC4-F11202B8EA92}"/>
               </a:ext>
             </a:extLst>
           </p:cNvPr>
@@ -6551,7 +6551,7 @@
           <p:cNvPr id="6" name="">
             <a:extLst xmlns:a="http://schemas.openxmlformats.org/drawingml/2006/main">
               <a:ext uri="{FF2B5EF4-FFF2-40B4-BE49-F238E27FC236}">
-                <a16:creationId xmlns:a16="http://schemas.microsoft.com/office/drawing/2014/main" id="{5131F2B2-482B-44F8-B3E5-6EAECA139A89}"/>
+                <a16:creationId xmlns:a16="http://schemas.microsoft.com/office/drawing/2014/main" id="{88304067-1E06-4748-B6D8-80EA26EBDD9F}"/>
               </a:ext>
             </a:extLst>
           </p:cNvPr>
@@ -6608,7 +6608,7 @@
           <p:cNvPr id="7" name="">
             <a:extLst xmlns:a="http://schemas.openxmlformats.org/drawingml/2006/main">
               <a:ext uri="{FF2B5EF4-FFF2-40B4-BE49-F238E27FC236}">
-                <a16:creationId xmlns:a16="http://schemas.microsoft.com/office/drawing/2014/main" id="{2AE3BC2A-602F-4114-AB43-E92380FD3959}"/>
+                <a16:creationId xmlns:a16="http://schemas.microsoft.com/office/drawing/2014/main" id="{546A5D44-C806-4AA6-AFD2-5D1D20603E4E}"/>
               </a:ext>
             </a:extLst>
           </p:cNvPr>
@@ -6665,7 +6665,7 @@
           <p:cNvPr id="8" name="">
             <a:extLst xmlns:a="http://schemas.openxmlformats.org/drawingml/2006/main">
               <a:ext uri="{FF2B5EF4-FFF2-40B4-BE49-F238E27FC236}">
-                <a16:creationId xmlns:a16="http://schemas.microsoft.com/office/drawing/2014/main" id="{0945BE8D-0451-4CE9-918D-D6119A07C3FE}"/>
+                <a16:creationId xmlns:a16="http://schemas.microsoft.com/office/drawing/2014/main" id="{3F126335-9819-431C-930C-B3C27863082A}"/>
               </a:ext>
             </a:extLst>
           </p:cNvPr>
@@ -6722,7 +6722,7 @@
           <p:cNvPr id="9" name="">
             <a:extLst xmlns:a="http://schemas.openxmlformats.org/drawingml/2006/main">
               <a:ext uri="{FF2B5EF4-FFF2-40B4-BE49-F238E27FC236}">
-                <a16:creationId xmlns:a16="http://schemas.microsoft.com/office/drawing/2014/main" id="{38FAE898-1DBF-4202-8068-451AEC7040F9}"/>
+                <a16:creationId xmlns:a16="http://schemas.microsoft.com/office/drawing/2014/main" id="{6495902D-71FA-4C07-99A7-57FE58E4144C}"/>
               </a:ext>
             </a:extLst>
           </p:cNvPr>
@@ -6752,7 +6752,7 @@
           <p:cNvPr id="10" name="">
             <a:extLst xmlns:a="http://schemas.openxmlformats.org/drawingml/2006/main">
               <a:ext uri="{FF2B5EF4-FFF2-40B4-BE49-F238E27FC236}">
-                <a16:creationId xmlns:a16="http://schemas.microsoft.com/office/drawing/2014/main" id="{A41A61F6-FF1E-454B-8D65-8B2646AC3C33}"/>
+                <a16:creationId xmlns:a16="http://schemas.microsoft.com/office/drawing/2014/main" id="{64EE3232-382F-4766-AABE-67CC977AC492}"/>
               </a:ext>
             </a:extLst>
           </p:cNvPr>
@@ -6809,7 +6809,7 @@
           <p:cNvPr id="11" name="">
             <a:extLst xmlns:a="http://schemas.openxmlformats.org/drawingml/2006/main">
               <a:ext uri="{FF2B5EF4-FFF2-40B4-BE49-F238E27FC236}">
-                <a16:creationId xmlns:a16="http://schemas.microsoft.com/office/drawing/2014/main" id="{DB101A68-8C29-4145-9D12-D7F95715E013}"/>
+                <a16:creationId xmlns:a16="http://schemas.microsoft.com/office/drawing/2014/main" id="{BE6135A3-6997-43A5-9C03-495783CCEC45}"/>
               </a:ext>
             </a:extLst>
           </p:cNvPr>
@@ -6866,7 +6866,7 @@
           <p:cNvPr id="12" name="">
             <a:extLst xmlns:a="http://schemas.openxmlformats.org/drawingml/2006/main">
               <a:ext uri="{FF2B5EF4-FFF2-40B4-BE49-F238E27FC236}">
-                <a16:creationId xmlns:a16="http://schemas.microsoft.com/office/drawing/2014/main" id="{A5EAE80C-6E6A-48D3-A159-B6202DEDAD46}"/>
+                <a16:creationId xmlns:a16="http://schemas.microsoft.com/office/drawing/2014/main" id="{8921D663-E7A9-4F27-98C5-06A7EBBE089A}"/>
               </a:ext>
             </a:extLst>
           </p:cNvPr>
@@ -6923,7 +6923,7 @@
           <p:cNvPr id="13" name="">
             <a:extLst xmlns:a="http://schemas.openxmlformats.org/drawingml/2006/main">
               <a:ext uri="{FF2B5EF4-FFF2-40B4-BE49-F238E27FC236}">
-                <a16:creationId xmlns:a16="http://schemas.microsoft.com/office/drawing/2014/main" id="{4F1F3E3F-560B-49C1-AB2D-4BC8FF6F2A57}"/>
+                <a16:creationId xmlns:a16="http://schemas.microsoft.com/office/drawing/2014/main" id="{996E74F5-8212-4512-B6F1-DDC5354EE0F8}"/>
               </a:ext>
             </a:extLst>
           </p:cNvPr>
@@ -6980,7 +6980,7 @@
           <p:cNvPr id="14" name="">
             <a:extLst xmlns:a="http://schemas.openxmlformats.org/drawingml/2006/main">
               <a:ext uri="{FF2B5EF4-FFF2-40B4-BE49-F238E27FC236}">
-                <a16:creationId xmlns:a16="http://schemas.microsoft.com/office/drawing/2014/main" id="{F19CFB97-1B87-490D-9EFA-98E542B5645D}"/>
+                <a16:creationId xmlns:a16="http://schemas.microsoft.com/office/drawing/2014/main" id="{BD5E868A-C7B5-416A-9828-A90F2B1B86EA}"/>
               </a:ext>
             </a:extLst>
           </p:cNvPr>
@@ -7010,7 +7010,7 @@
           <p:cNvPr id="15" name="">
             <a:extLst xmlns:a="http://schemas.openxmlformats.org/drawingml/2006/main">
               <a:ext uri="{FF2B5EF4-FFF2-40B4-BE49-F238E27FC236}">
-                <a16:creationId xmlns:a16="http://schemas.microsoft.com/office/drawing/2014/main" id="{C4178653-8136-4877-A464-E9E8552CDE7E}"/>
+                <a16:creationId xmlns:a16="http://schemas.microsoft.com/office/drawing/2014/main" id="{53FDE256-231E-4EEA-9FBA-83934BFE0B44}"/>
               </a:ext>
             </a:extLst>
           </p:cNvPr>
@@ -7067,7 +7067,7 @@
           <p:cNvPr id="16" name="">
             <a:extLst xmlns:a="http://schemas.openxmlformats.org/drawingml/2006/main">
               <a:ext uri="{FF2B5EF4-FFF2-40B4-BE49-F238E27FC236}">
-                <a16:creationId xmlns:a16="http://schemas.microsoft.com/office/drawing/2014/main" id="{D3034DBE-BC3F-4246-B83D-6A0959D7E2D0}"/>
+                <a16:creationId xmlns:a16="http://schemas.microsoft.com/office/drawing/2014/main" id="{66071DE4-620B-43C1-A9D6-F3F0A4E7F596}"/>
               </a:ext>
             </a:extLst>
           </p:cNvPr>
@@ -7124,7 +7124,7 @@
           <p:cNvPr id="17" name="">
             <a:extLst xmlns:a="http://schemas.openxmlformats.org/drawingml/2006/main">
               <a:ext uri="{FF2B5EF4-FFF2-40B4-BE49-F238E27FC236}">
-                <a16:creationId xmlns:a16="http://schemas.microsoft.com/office/drawing/2014/main" id="{A9DD3D83-705A-427E-88B5-4139370904DA}"/>
+                <a16:creationId xmlns:a16="http://schemas.microsoft.com/office/drawing/2014/main" id="{6400CA71-AE46-48BE-AE71-8537EA5D0AE0}"/>
               </a:ext>
             </a:extLst>
           </p:cNvPr>
@@ -7181,7 +7181,7 @@
           <p:cNvPr id="18" name="">
             <a:extLst xmlns:a="http://schemas.openxmlformats.org/drawingml/2006/main">
               <a:ext uri="{FF2B5EF4-FFF2-40B4-BE49-F238E27FC236}">
-                <a16:creationId xmlns:a16="http://schemas.microsoft.com/office/drawing/2014/main" id="{E3087D82-0F56-4BCD-ACA4-2FC4B235BC2D}"/>
+                <a16:creationId xmlns:a16="http://schemas.microsoft.com/office/drawing/2014/main" id="{368D43BF-DF7E-4FD0-88EE-7F09475C660E}"/>
               </a:ext>
             </a:extLst>
           </p:cNvPr>
@@ -7238,7 +7238,7 @@
           <p:cNvPr id="19" name="">
             <a:extLst xmlns:a="http://schemas.openxmlformats.org/drawingml/2006/main">
               <a:ext uri="{FF2B5EF4-FFF2-40B4-BE49-F238E27FC236}">
-                <a16:creationId xmlns:a16="http://schemas.microsoft.com/office/drawing/2014/main" id="{B2A02E50-D01A-4E54-AD4B-627652DAC095}"/>
+                <a16:creationId xmlns:a16="http://schemas.microsoft.com/office/drawing/2014/main" id="{8EDB1E9B-6839-462E-A911-4CE5E24BC887}"/>
               </a:ext>
             </a:extLst>
           </p:cNvPr>
@@ -7293,7 +7293,7 @@
     </p:spTree>
     <p:extLst>
       <p:ext uri="{BB962C8B-B14F-4D97-AF65-F5344CB8AC3E}">
-        <p14:creationId xmlns:p14="http://schemas.microsoft.com/office/powerpoint/2010/main" val="663177339"/>
+        <p14:creationId xmlns:p14="http://schemas.microsoft.com/office/powerpoint/2010/main" val="1324757018"/>
       </p:ext>
     </p:extLst>
   </p:cSld>
@@ -7324,7 +7324,7 @@
           <p:cNvPr id="20" name="">
             <a:extLst xmlns:a="http://schemas.openxmlformats.org/drawingml/2006/main">
               <a:ext uri="{FF2B5EF4-FFF2-40B4-BE49-F238E27FC236}">
-                <a16:creationId xmlns:a16="http://schemas.microsoft.com/office/drawing/2014/main" id="{0ED0E0D8-8069-4DB5-BCBB-7D7F7EB7D3A1}"/>
+                <a16:creationId xmlns:a16="http://schemas.microsoft.com/office/drawing/2014/main" id="{064BD39A-734E-47CB-91F6-E1F795CEB81B}"/>
               </a:ext>
             </a:extLst>
           </p:cNvPr>
@@ -7354,7 +7354,7 @@
           <p:cNvPr id="2" name="">
             <a:extLst xmlns:a="http://schemas.openxmlformats.org/drawingml/2006/main">
               <a:ext uri="{FF2B5EF4-FFF2-40B4-BE49-F238E27FC236}">
-                <a16:creationId xmlns:a16="http://schemas.microsoft.com/office/drawing/2014/main" id="{EE2EAA6A-CA27-4228-BFAD-4106A1579DB0}"/>
+                <a16:creationId xmlns:a16="http://schemas.microsoft.com/office/drawing/2014/main" id="{8A06C991-ED25-4A39-8782-23A9CA29055F}"/>
               </a:ext>
             </a:extLst>
           </p:cNvPr>
@@ -7411,7 +7411,7 @@
           <p:cNvPr id="3" name="">
             <a:extLst xmlns:a="http://schemas.openxmlformats.org/drawingml/2006/main">
               <a:ext uri="{FF2B5EF4-FFF2-40B4-BE49-F238E27FC236}">
-                <a16:creationId xmlns:a16="http://schemas.microsoft.com/office/drawing/2014/main" id="{8599E9D1-5E48-4CB0-922C-6231924510FC}"/>
+                <a16:creationId xmlns:a16="http://schemas.microsoft.com/office/drawing/2014/main" id="{8CD16639-E63B-4065-87C0-32CE3DDD72BF}"/>
               </a:ext>
             </a:extLst>
           </p:cNvPr>
@@ -7468,7 +7468,7 @@
           <p:cNvPr id="4" name="">
             <a:extLst xmlns:a="http://schemas.openxmlformats.org/drawingml/2006/main">
               <a:ext uri="{FF2B5EF4-FFF2-40B4-BE49-F238E27FC236}">
-                <a16:creationId xmlns:a16="http://schemas.microsoft.com/office/drawing/2014/main" id="{8561007A-BF7C-4B61-843B-9C311184E262}"/>
+                <a16:creationId xmlns:a16="http://schemas.microsoft.com/office/drawing/2014/main" id="{04BCF9CB-C1DE-40CB-908D-785D16A1A8BF}"/>
               </a:ext>
             </a:extLst>
           </p:cNvPr>
@@ -7525,7 +7525,7 @@
           <p:cNvPr id="5" name="">
             <a:extLst xmlns:a="http://schemas.openxmlformats.org/drawingml/2006/main">
               <a:ext uri="{FF2B5EF4-FFF2-40B4-BE49-F238E27FC236}">
-                <a16:creationId xmlns:a16="http://schemas.microsoft.com/office/drawing/2014/main" id="{5D3F97B0-D88C-4296-AFEB-5D21BE8222CD}"/>
+                <a16:creationId xmlns:a16="http://schemas.microsoft.com/office/drawing/2014/main" id="{272C7188-D5DD-4EF1-988C-CFAEF445F50B}"/>
               </a:ext>
             </a:extLst>
           </p:cNvPr>
@@ -7560,7 +7560,7 @@
           <p:cNvPr id="6" name="">
             <a:extLst xmlns:a="http://schemas.openxmlformats.org/drawingml/2006/main">
               <a:ext uri="{FF2B5EF4-FFF2-40B4-BE49-F238E27FC236}">
-                <a16:creationId xmlns:a16="http://schemas.microsoft.com/office/drawing/2014/main" id="{CEEF3E14-6BDD-4267-8083-0FA409303055}"/>
+                <a16:creationId xmlns:a16="http://schemas.microsoft.com/office/drawing/2014/main" id="{6E56EC9A-1D91-43CC-9BB5-2E19E3DE071C}"/>
               </a:ext>
             </a:extLst>
           </p:cNvPr>
@@ -7617,7 +7617,7 @@
           <p:cNvPr id="7" name="">
             <a:extLst xmlns:a="http://schemas.openxmlformats.org/drawingml/2006/main">
               <a:ext uri="{FF2B5EF4-FFF2-40B4-BE49-F238E27FC236}">
-                <a16:creationId xmlns:a16="http://schemas.microsoft.com/office/drawing/2014/main" id="{A18BDF05-BF87-4578-88B1-428906AC6EFD}"/>
+                <a16:creationId xmlns:a16="http://schemas.microsoft.com/office/drawing/2014/main" id="{3BC01480-47E9-450A-A028-EBB5736732CA}"/>
               </a:ext>
             </a:extLst>
           </p:cNvPr>
@@ -7674,7 +7674,7 @@
           <p:cNvPr id="8" name="">
             <a:extLst xmlns:a="http://schemas.openxmlformats.org/drawingml/2006/main">
               <a:ext uri="{FF2B5EF4-FFF2-40B4-BE49-F238E27FC236}">
-                <a16:creationId xmlns:a16="http://schemas.microsoft.com/office/drawing/2014/main" id="{644742E3-266B-48DD-8391-33B6E45EC383}"/>
+                <a16:creationId xmlns:a16="http://schemas.microsoft.com/office/drawing/2014/main" id="{A0D3D6FA-1BCA-41E2-A4DF-80CAE6804916}"/>
               </a:ext>
             </a:extLst>
           </p:cNvPr>
@@ -7709,7 +7709,7 @@
           <p:cNvPr id="9" name="">
             <a:extLst xmlns:a="http://schemas.openxmlformats.org/drawingml/2006/main">
               <a:ext uri="{FF2B5EF4-FFF2-40B4-BE49-F238E27FC236}">
-                <a16:creationId xmlns:a16="http://schemas.microsoft.com/office/drawing/2014/main" id="{F822CAD6-DF66-4A3A-8E18-A62B6844D1B2}"/>
+                <a16:creationId xmlns:a16="http://schemas.microsoft.com/office/drawing/2014/main" id="{393CA387-E428-4F38-8CD9-AA94F22C60C9}"/>
               </a:ext>
             </a:extLst>
           </p:cNvPr>
@@ -7766,7 +7766,7 @@
           <p:cNvPr id="10" name="">
             <a:extLst xmlns:a="http://schemas.openxmlformats.org/drawingml/2006/main">
               <a:ext uri="{FF2B5EF4-FFF2-40B4-BE49-F238E27FC236}">
-                <a16:creationId xmlns:a16="http://schemas.microsoft.com/office/drawing/2014/main" id="{C5EA4FF9-6BBA-4E95-8B5A-332FA66477B5}"/>
+                <a16:creationId xmlns:a16="http://schemas.microsoft.com/office/drawing/2014/main" id="{3B8D3572-A955-465A-9790-63F7AB9CFD3E}"/>
               </a:ext>
             </a:extLst>
           </p:cNvPr>
@@ -7823,7 +7823,7 @@
           <p:cNvPr id="11" name="">
             <a:extLst xmlns:a="http://schemas.openxmlformats.org/drawingml/2006/main">
               <a:ext uri="{FF2B5EF4-FFF2-40B4-BE49-F238E27FC236}">
-                <a16:creationId xmlns:a16="http://schemas.microsoft.com/office/drawing/2014/main" id="{DB4229D8-EC43-4B54-B3A7-181E1187DF91}"/>
+                <a16:creationId xmlns:a16="http://schemas.microsoft.com/office/drawing/2014/main" id="{335310F6-0F4D-408C-836A-BC92DAAB10F3}"/>
               </a:ext>
             </a:extLst>
           </p:cNvPr>
@@ -7858,7 +7858,7 @@
           <p:cNvPr id="12" name="">
             <a:extLst xmlns:a="http://schemas.openxmlformats.org/drawingml/2006/main">
               <a:ext uri="{FF2B5EF4-FFF2-40B4-BE49-F238E27FC236}">
-                <a16:creationId xmlns:a16="http://schemas.microsoft.com/office/drawing/2014/main" id="{7CC790A5-6E5D-41A0-BEB5-CC2F68CDAA02}"/>
+                <a16:creationId xmlns:a16="http://schemas.microsoft.com/office/drawing/2014/main" id="{B4121E08-1469-41AC-9516-3F0A0FD05AD8}"/>
               </a:ext>
             </a:extLst>
           </p:cNvPr>
@@ -7915,7 +7915,7 @@
           <p:cNvPr id="13" name="">
             <a:extLst xmlns:a="http://schemas.openxmlformats.org/drawingml/2006/main">
               <a:ext uri="{FF2B5EF4-FFF2-40B4-BE49-F238E27FC236}">
-                <a16:creationId xmlns:a16="http://schemas.microsoft.com/office/drawing/2014/main" id="{488B0A35-D436-47FB-8C0F-AFE2978A5789}"/>
+                <a16:creationId xmlns:a16="http://schemas.microsoft.com/office/drawing/2014/main" id="{BEAC8C41-1514-4104-B492-8202D6031521}"/>
               </a:ext>
             </a:extLst>
           </p:cNvPr>
@@ -7972,7 +7972,7 @@
           <p:cNvPr id="14" name="">
             <a:extLst xmlns:a="http://schemas.openxmlformats.org/drawingml/2006/main">
               <a:ext uri="{FF2B5EF4-FFF2-40B4-BE49-F238E27FC236}">
-                <a16:creationId xmlns:a16="http://schemas.microsoft.com/office/drawing/2014/main" id="{F23D0D6F-8D21-435C-BC58-0E1A6B01FF08}"/>
+                <a16:creationId xmlns:a16="http://schemas.microsoft.com/office/drawing/2014/main" id="{0DF6A210-C6CB-4A1F-BC16-B87FE3120979}"/>
               </a:ext>
             </a:extLst>
           </p:cNvPr>
@@ -8007,7 +8007,7 @@
           <p:cNvPr id="15" name="">
             <a:extLst xmlns:a="http://schemas.openxmlformats.org/drawingml/2006/main">
               <a:ext uri="{FF2B5EF4-FFF2-40B4-BE49-F238E27FC236}">
-                <a16:creationId xmlns:a16="http://schemas.microsoft.com/office/drawing/2014/main" id="{4F5257C5-E7B3-4767-A9D6-363D66CDD5BF}"/>
+                <a16:creationId xmlns:a16="http://schemas.microsoft.com/office/drawing/2014/main" id="{2D63275D-7BB6-413E-97C3-CC606419456D}"/>
               </a:ext>
             </a:extLst>
           </p:cNvPr>
@@ -8064,7 +8064,7 @@
           <p:cNvPr id="16" name="">
             <a:extLst xmlns:a="http://schemas.openxmlformats.org/drawingml/2006/main">
               <a:ext uri="{FF2B5EF4-FFF2-40B4-BE49-F238E27FC236}">
-                <a16:creationId xmlns:a16="http://schemas.microsoft.com/office/drawing/2014/main" id="{94A27714-0D3C-4183-89D0-7C96E951623C}"/>
+                <a16:creationId xmlns:a16="http://schemas.microsoft.com/office/drawing/2014/main" id="{8F08029D-B506-4F97-87B7-11CA49700F0A}"/>
               </a:ext>
             </a:extLst>
           </p:cNvPr>
@@ -8121,7 +8121,7 @@
           <p:cNvPr id="17" name="">
             <a:extLst xmlns:a="http://schemas.openxmlformats.org/drawingml/2006/main">
               <a:ext uri="{FF2B5EF4-FFF2-40B4-BE49-F238E27FC236}">
-                <a16:creationId xmlns:a16="http://schemas.microsoft.com/office/drawing/2014/main" id="{01C2FA3D-799C-4B44-8D9D-2469DBB4C14E}"/>
+                <a16:creationId xmlns:a16="http://schemas.microsoft.com/office/drawing/2014/main" id="{99BBE58E-FF35-466D-B732-934F6F5C29DF}"/>
               </a:ext>
             </a:extLst>
           </p:cNvPr>
@@ -8178,7 +8178,7 @@
           <p:cNvPr id="18" name="">
             <a:extLst xmlns:a="http://schemas.openxmlformats.org/drawingml/2006/main">
               <a:ext uri="{FF2B5EF4-FFF2-40B4-BE49-F238E27FC236}">
-                <a16:creationId xmlns:a16="http://schemas.microsoft.com/office/drawing/2014/main" id="{466A6CE2-186C-4AA4-BE27-E333553DD76C}"/>
+                <a16:creationId xmlns:a16="http://schemas.microsoft.com/office/drawing/2014/main" id="{4A77D3C5-DB52-48A6-8089-E9537287AAF9}"/>
               </a:ext>
             </a:extLst>
           </p:cNvPr>
@@ -8235,7 +8235,7 @@
           <p:cNvPr id="19" name="">
             <a:extLst xmlns:a="http://schemas.openxmlformats.org/drawingml/2006/main">
               <a:ext uri="{FF2B5EF4-FFF2-40B4-BE49-F238E27FC236}">
-                <a16:creationId xmlns:a16="http://schemas.microsoft.com/office/drawing/2014/main" id="{23DC799D-28BC-46A2-88DA-21F91C90FB44}"/>
+                <a16:creationId xmlns:a16="http://schemas.microsoft.com/office/drawing/2014/main" id="{907BE617-7187-4113-B962-DE0D6D31F423}"/>
               </a:ext>
             </a:extLst>
           </p:cNvPr>
@@ -8290,7 +8290,7 @@
     </p:spTree>
     <p:extLst>
       <p:ext uri="{BB962C8B-B14F-4D97-AF65-F5344CB8AC3E}">
-        <p14:creationId xmlns:p14="http://schemas.microsoft.com/office/powerpoint/2010/main" val="395533947"/>
+        <p14:creationId xmlns:p14="http://schemas.microsoft.com/office/powerpoint/2010/main" val="1813460972"/>
       </p:ext>
     </p:extLst>
   </p:cSld>
@@ -8321,7 +8321,7 @@
           <p:cNvPr id="20" name="">
             <a:extLst xmlns:a="http://schemas.openxmlformats.org/drawingml/2006/main">
               <a:ext uri="{FF2B5EF4-FFF2-40B4-BE49-F238E27FC236}">
-                <a16:creationId xmlns:a16="http://schemas.microsoft.com/office/drawing/2014/main" id="{540840AD-831D-4D00-BAB2-9994CC1375B1}"/>
+                <a16:creationId xmlns:a16="http://schemas.microsoft.com/office/drawing/2014/main" id="{6AEFD6D0-251D-4508-90CC-F794D1C006D9}"/>
               </a:ext>
             </a:extLst>
           </p:cNvPr>
@@ -8351,7 +8351,7 @@
           <p:cNvPr id="2" name="">
             <a:extLst xmlns:a="http://schemas.openxmlformats.org/drawingml/2006/main">
               <a:ext uri="{FF2B5EF4-FFF2-40B4-BE49-F238E27FC236}">
-                <a16:creationId xmlns:a16="http://schemas.microsoft.com/office/drawing/2014/main" id="{432752A4-10E8-49AF-9555-54A18772BBFA}"/>
+                <a16:creationId xmlns:a16="http://schemas.microsoft.com/office/drawing/2014/main" id="{55659F75-FDF5-4945-82D0-AEC49C4E21AD}"/>
               </a:ext>
             </a:extLst>
           </p:cNvPr>
@@ -8408,7 +8408,7 @@
           <p:cNvPr id="3" name="">
             <a:extLst xmlns:a="http://schemas.openxmlformats.org/drawingml/2006/main">
               <a:ext uri="{FF2B5EF4-FFF2-40B4-BE49-F238E27FC236}">
-                <a16:creationId xmlns:a16="http://schemas.microsoft.com/office/drawing/2014/main" id="{C690EF3C-6533-4423-81AF-5D7AF267869F}"/>
+                <a16:creationId xmlns:a16="http://schemas.microsoft.com/office/drawing/2014/main" id="{2D63D1BD-380A-4477-A600-350D23845AC2}"/>
               </a:ext>
             </a:extLst>
           </p:cNvPr>
@@ -8465,7 +8465,7 @@
           <p:cNvPr id="4" name="">
             <a:extLst xmlns:a="http://schemas.openxmlformats.org/drawingml/2006/main">
               <a:ext uri="{FF2B5EF4-FFF2-40B4-BE49-F238E27FC236}">
-                <a16:creationId xmlns:a16="http://schemas.microsoft.com/office/drawing/2014/main" id="{7D5BD479-5C8D-48C0-83E2-4B9A66762222}"/>
+                <a16:creationId xmlns:a16="http://schemas.microsoft.com/office/drawing/2014/main" id="{8414F2FF-AB89-4404-BF90-5A93E41A5540}"/>
               </a:ext>
             </a:extLst>
           </p:cNvPr>
@@ -8522,7 +8522,7 @@
           <p:cNvPr id="5" name="">
             <a:extLst xmlns:a="http://schemas.openxmlformats.org/drawingml/2006/main">
               <a:ext uri="{FF2B5EF4-FFF2-40B4-BE49-F238E27FC236}">
-                <a16:creationId xmlns:a16="http://schemas.microsoft.com/office/drawing/2014/main" id="{19192A08-9E72-498A-9ADD-B5CD024FCAB4}"/>
+                <a16:creationId xmlns:a16="http://schemas.microsoft.com/office/drawing/2014/main" id="{6DB1F590-0B80-4E37-9F42-DED7A1EA46ED}"/>
               </a:ext>
             </a:extLst>
           </p:cNvPr>
@@ -8579,7 +8579,7 @@
           <p:cNvPr id="6" name="">
             <a:extLst xmlns:a="http://schemas.openxmlformats.org/drawingml/2006/main">
               <a:ext uri="{FF2B5EF4-FFF2-40B4-BE49-F238E27FC236}">
-                <a16:creationId xmlns:a16="http://schemas.microsoft.com/office/drawing/2014/main" id="{CCE66D69-2324-4D55-9666-1EA8170799C6}"/>
+                <a16:creationId xmlns:a16="http://schemas.microsoft.com/office/drawing/2014/main" id="{BC222B2A-2BFF-4EDC-A141-167C2F5C8343}"/>
               </a:ext>
             </a:extLst>
           </p:cNvPr>
@@ -8636,7 +8636,7 @@
           <p:cNvPr id="7" name="">
             <a:extLst xmlns:a="http://schemas.openxmlformats.org/drawingml/2006/main">
               <a:ext uri="{FF2B5EF4-FFF2-40B4-BE49-F238E27FC236}">
-                <a16:creationId xmlns:a16="http://schemas.microsoft.com/office/drawing/2014/main" id="{7C241A2D-73E4-4282-AC90-DB6D66625C46}"/>
+                <a16:creationId xmlns:a16="http://schemas.microsoft.com/office/drawing/2014/main" id="{83DAD7D1-DCCD-4156-848A-28C7B423145A}"/>
               </a:ext>
             </a:extLst>
           </p:cNvPr>
@@ -8693,7 +8693,7 @@
           <p:cNvPr id="8" name="">
             <a:extLst xmlns:a="http://schemas.openxmlformats.org/drawingml/2006/main">
               <a:ext uri="{FF2B5EF4-FFF2-40B4-BE49-F238E27FC236}">
-                <a16:creationId xmlns:a16="http://schemas.microsoft.com/office/drawing/2014/main" id="{9CD33B20-DF1B-4115-98F6-CCEA296DF8C5}"/>
+                <a16:creationId xmlns:a16="http://schemas.microsoft.com/office/drawing/2014/main" id="{6D924F5A-AC13-47CA-AC0E-B86B549E13F9}"/>
               </a:ext>
             </a:extLst>
           </p:cNvPr>
@@ -8750,7 +8750,7 @@
           <p:cNvPr id="9" name="">
             <a:extLst xmlns:a="http://schemas.openxmlformats.org/drawingml/2006/main">
               <a:ext uri="{FF2B5EF4-FFF2-40B4-BE49-F238E27FC236}">
-                <a16:creationId xmlns:a16="http://schemas.microsoft.com/office/drawing/2014/main" id="{46125940-E015-41F7-AF22-F0B309A56E51}"/>
+                <a16:creationId xmlns:a16="http://schemas.microsoft.com/office/drawing/2014/main" id="{404E6679-9A71-4D7A-A0FA-9B3B7F577A9F}"/>
               </a:ext>
             </a:extLst>
           </p:cNvPr>
@@ -8807,7 +8807,7 @@
           <p:cNvPr id="10" name="">
             <a:extLst xmlns:a="http://schemas.openxmlformats.org/drawingml/2006/main">
               <a:ext uri="{FF2B5EF4-FFF2-40B4-BE49-F238E27FC236}">
-                <a16:creationId xmlns:a16="http://schemas.microsoft.com/office/drawing/2014/main" id="{4396DF23-609B-4F98-B602-669C488DA022}"/>
+                <a16:creationId xmlns:a16="http://schemas.microsoft.com/office/drawing/2014/main" id="{89A6DBCF-259C-4FCD-9A9F-C18F6DE08CCE}"/>
               </a:ext>
             </a:extLst>
           </p:cNvPr>
@@ -8864,7 +8864,7 @@
           <p:cNvPr id="11" name="">
             <a:extLst xmlns:a="http://schemas.openxmlformats.org/drawingml/2006/main">
               <a:ext uri="{FF2B5EF4-FFF2-40B4-BE49-F238E27FC236}">
-                <a16:creationId xmlns:a16="http://schemas.microsoft.com/office/drawing/2014/main" id="{2077FB88-10CD-4ADD-88F0-265786952BE0}"/>
+                <a16:creationId xmlns:a16="http://schemas.microsoft.com/office/drawing/2014/main" id="{44347327-6EBF-4AAD-8156-020609EDBBE6}"/>
               </a:ext>
             </a:extLst>
           </p:cNvPr>
@@ -8921,7 +8921,7 @@
           <p:cNvPr id="12" name="">
             <a:extLst xmlns:a="http://schemas.openxmlformats.org/drawingml/2006/main">
               <a:ext uri="{FF2B5EF4-FFF2-40B4-BE49-F238E27FC236}">
-                <a16:creationId xmlns:a16="http://schemas.microsoft.com/office/drawing/2014/main" id="{8B804D9C-1D52-4A1E-9226-35F3FBA3E0FE}"/>
+                <a16:creationId xmlns:a16="http://schemas.microsoft.com/office/drawing/2014/main" id="{0B038193-9385-4489-840E-135C45200F4F}"/>
               </a:ext>
             </a:extLst>
           </p:cNvPr>
@@ -8978,7 +8978,7 @@
           <p:cNvPr id="13" name="">
             <a:extLst xmlns:a="http://schemas.openxmlformats.org/drawingml/2006/main">
               <a:ext uri="{FF2B5EF4-FFF2-40B4-BE49-F238E27FC236}">
-                <a16:creationId xmlns:a16="http://schemas.microsoft.com/office/drawing/2014/main" id="{BF82BD87-05DF-413C-8FD1-C9032D804662}"/>
+                <a16:creationId xmlns:a16="http://schemas.microsoft.com/office/drawing/2014/main" id="{D9936F2D-83D2-423F-8EB9-C955996A1887}"/>
               </a:ext>
             </a:extLst>
           </p:cNvPr>
@@ -9035,7 +9035,7 @@
           <p:cNvPr id="14" name="">
             <a:extLst xmlns:a="http://schemas.openxmlformats.org/drawingml/2006/main">
               <a:ext uri="{FF2B5EF4-FFF2-40B4-BE49-F238E27FC236}">
-                <a16:creationId xmlns:a16="http://schemas.microsoft.com/office/drawing/2014/main" id="{A8EE12D6-DFB3-4CC2-885C-8244E7408C84}"/>
+                <a16:creationId xmlns:a16="http://schemas.microsoft.com/office/drawing/2014/main" id="{94EFE792-15AD-4C5C-98B3-C96E1F8B8E77}"/>
               </a:ext>
             </a:extLst>
           </p:cNvPr>
@@ -9065,7 +9065,7 @@
           <p:cNvPr id="15" name="">
             <a:extLst xmlns:a="http://schemas.openxmlformats.org/drawingml/2006/main">
               <a:ext uri="{FF2B5EF4-FFF2-40B4-BE49-F238E27FC236}">
-                <a16:creationId xmlns:a16="http://schemas.microsoft.com/office/drawing/2014/main" id="{BE431B92-A68B-4AAF-989A-989853286B85}"/>
+                <a16:creationId xmlns:a16="http://schemas.microsoft.com/office/drawing/2014/main" id="{57BC42D6-B683-4C80-A77C-DF4A24DE7370}"/>
               </a:ext>
             </a:extLst>
           </p:cNvPr>
@@ -9122,7 +9122,7 @@
           <p:cNvPr id="16" name="">
             <a:extLst xmlns:a="http://schemas.openxmlformats.org/drawingml/2006/main">
               <a:ext uri="{FF2B5EF4-FFF2-40B4-BE49-F238E27FC236}">
-                <a16:creationId xmlns:a16="http://schemas.microsoft.com/office/drawing/2014/main" id="{EC6FE49A-A76E-419D-B873-395A0A150512}"/>
+                <a16:creationId xmlns:a16="http://schemas.microsoft.com/office/drawing/2014/main" id="{ACBF56C9-AE23-4FA0-87F9-C90D2362F217}"/>
               </a:ext>
             </a:extLst>
           </p:cNvPr>
@@ -9179,7 +9179,7 @@
           <p:cNvPr id="17" name="">
             <a:extLst xmlns:a="http://schemas.openxmlformats.org/drawingml/2006/main">
               <a:ext uri="{FF2B5EF4-FFF2-40B4-BE49-F238E27FC236}">
-                <a16:creationId xmlns:a16="http://schemas.microsoft.com/office/drawing/2014/main" id="{5B2A2A2B-C1B7-4648-B23E-FD89E1FC823A}"/>
+                <a16:creationId xmlns:a16="http://schemas.microsoft.com/office/drawing/2014/main" id="{9DABA890-3D1D-4C1C-A473-37D24D75B518}"/>
               </a:ext>
             </a:extLst>
           </p:cNvPr>
@@ -9236,7 +9236,7 @@
           <p:cNvPr id="18" name="">
             <a:extLst xmlns:a="http://schemas.openxmlformats.org/drawingml/2006/main">
               <a:ext uri="{FF2B5EF4-FFF2-40B4-BE49-F238E27FC236}">
-                <a16:creationId xmlns:a16="http://schemas.microsoft.com/office/drawing/2014/main" id="{CF9BBD71-FC1F-4B35-8F73-7056A2CA5A5E}"/>
+                <a16:creationId xmlns:a16="http://schemas.microsoft.com/office/drawing/2014/main" id="{CD69C100-463B-490C-B782-2B659DA3CFAF}"/>
               </a:ext>
             </a:extLst>
           </p:cNvPr>
@@ -9293,7 +9293,7 @@
           <p:cNvPr id="19" name="">
             <a:extLst xmlns:a="http://schemas.openxmlformats.org/drawingml/2006/main">
               <a:ext uri="{FF2B5EF4-FFF2-40B4-BE49-F238E27FC236}">
-                <a16:creationId xmlns:a16="http://schemas.microsoft.com/office/drawing/2014/main" id="{6F076C64-8D1A-45D9-AE43-DB0700F69611}"/>
+                <a16:creationId xmlns:a16="http://schemas.microsoft.com/office/drawing/2014/main" id="{4A972AB7-3EBF-4ED4-A92E-C3A58F21B90C}"/>
               </a:ext>
             </a:extLst>
           </p:cNvPr>
@@ -9348,7 +9348,7 @@
     </p:spTree>
     <p:extLst>
       <p:ext uri="{BB962C8B-B14F-4D97-AF65-F5344CB8AC3E}">
-        <p14:creationId xmlns:p14="http://schemas.microsoft.com/office/powerpoint/2010/main" val="627370282"/>
+        <p14:creationId xmlns:p14="http://schemas.microsoft.com/office/powerpoint/2010/main" val="1172245197"/>
       </p:ext>
     </p:extLst>
   </p:cSld>

</xml_diff>

<commit_message>
brand: finalize approved ProofLend monogram
</commit_message>
<xml_diff>
--- a/submission/ProofLend_Hackathon_Deck.pptx
+++ b/submission/ProofLend_Hackathon_Deck.pptx
@@ -2,20 +2,20 @@
 <file path=ppt/presentation.xml><?xml version="1.0" encoding="utf-8"?>
 <p:presentation xmlns:p="http://schemas.openxmlformats.org/presentationml/2006/main">
   <p:sldMasterIdLst>
-    <p:sldMasterId xmlns:r="http://schemas.openxmlformats.org/officeDocument/2006/relationships" id="2147483648" r:id="R01e5dd25454f4c4a"/>
+    <p:sldMasterId xmlns:r="http://schemas.openxmlformats.org/officeDocument/2006/relationships" id="2147483648" r:id="R7c83c9aaf4e04f16"/>
   </p:sldMasterIdLst>
   <p:notesMasterIdLst>
-    <p:notesMasterId xmlns:r="http://schemas.openxmlformats.org/officeDocument/2006/relationships" r:id="R0e1914e1d87249f5"/>
+    <p:notesMasterId xmlns:r="http://schemas.openxmlformats.org/officeDocument/2006/relationships" r:id="R485bfe4553bb41cb"/>
   </p:notesMasterIdLst>
   <p:sldIdLst>
-    <p:sldId xmlns:r="http://schemas.openxmlformats.org/officeDocument/2006/relationships" id="256" r:id="R97cfb32fcb2c446d"/>
-    <p:sldId xmlns:r="http://schemas.openxmlformats.org/officeDocument/2006/relationships" id="257" r:id="R8c9a5b0c20c84e4c"/>
-    <p:sldId xmlns:r="http://schemas.openxmlformats.org/officeDocument/2006/relationships" id="258" r:id="Re0f1652207c8473f"/>
-    <p:sldId xmlns:r="http://schemas.openxmlformats.org/officeDocument/2006/relationships" id="259" r:id="R76a1e97e73744a20"/>
-    <p:sldId xmlns:r="http://schemas.openxmlformats.org/officeDocument/2006/relationships" id="260" r:id="Re23095db94864a7e"/>
-    <p:sldId xmlns:r="http://schemas.openxmlformats.org/officeDocument/2006/relationships" id="261" r:id="R0de5d302de5a4db1"/>
-    <p:sldId xmlns:r="http://schemas.openxmlformats.org/officeDocument/2006/relationships" id="262" r:id="Rccc452a5a2234a68"/>
-    <p:sldId xmlns:r="http://schemas.openxmlformats.org/officeDocument/2006/relationships" id="263" r:id="Ra4cac417885c4ebc"/>
+    <p:sldId xmlns:r="http://schemas.openxmlformats.org/officeDocument/2006/relationships" id="256" r:id="Rdb8ea2fef55c4c7e"/>
+    <p:sldId xmlns:r="http://schemas.openxmlformats.org/officeDocument/2006/relationships" id="257" r:id="Rbb5c6f75f41b4280"/>
+    <p:sldId xmlns:r="http://schemas.openxmlformats.org/officeDocument/2006/relationships" id="258" r:id="Re0df972c72484b69"/>
+    <p:sldId xmlns:r="http://schemas.openxmlformats.org/officeDocument/2006/relationships" id="259" r:id="Rb14c07a66ca044c6"/>
+    <p:sldId xmlns:r="http://schemas.openxmlformats.org/officeDocument/2006/relationships" id="260" r:id="R1be7515f413440fa"/>
+    <p:sldId xmlns:r="http://schemas.openxmlformats.org/officeDocument/2006/relationships" id="261" r:id="R0800907882d44987"/>
+    <p:sldId xmlns:r="http://schemas.openxmlformats.org/officeDocument/2006/relationships" id="262" r:id="R048ed67e5ce443ad"/>
+    <p:sldId xmlns:r="http://schemas.openxmlformats.org/officeDocument/2006/relationships" id="263" r:id="Rb337ec684d8a424e"/>
   </p:sldIdLst>
   <p:sldSz cx="12192000" cy="6858000"/>
   <p:notesSz cx="6858000" cy="9144000"/>
@@ -1147,7 +1147,7 @@
   </p:cSld>
   <p:clrMap bg1="lt1" tx1="dk1" bg2="lt2" tx2="dk2" accent1="accent1" accent2="accent2" accent3="accent3" accent4="accent4" accent5="accent5" accent6="accent6" hlink="hlink" folHlink="folHlink"/>
   <p:sldLayoutIdLst>
-    <p:sldLayoutId xmlns:r="http://schemas.openxmlformats.org/officeDocument/2006/relationships" id="2147483649" r:id="R17146ac6b6444597"/>
+    <p:sldLayoutId xmlns:r="http://schemas.openxmlformats.org/officeDocument/2006/relationships" id="2147483649" r:id="Ra6a262db9a1f42c0"/>
   </p:sldLayoutIdLst>
   <p:txStyles>
     <p:titleStyle>
@@ -1698,7 +1698,7 @@
           <p:cNvPr id="9" name="">
             <a:extLst xmlns:a="http://schemas.openxmlformats.org/drawingml/2006/main">
               <a:ext uri="{FF2B5EF4-FFF2-40B4-BE49-F238E27FC236}">
-                <a16:creationId xmlns:a16="http://schemas.microsoft.com/office/drawing/2014/main" id="{F2200CCB-E7DD-443C-B648-43AF1E48BFEE}"/>
+                <a16:creationId xmlns:a16="http://schemas.microsoft.com/office/drawing/2014/main" id="{B1F91042-1F81-4C73-A5E3-AD9C41D215A9}"/>
               </a:ext>
             </a:extLst>
           </p:cNvPr>
@@ -1732,7 +1732,7 @@
           <p:nvPr/>
         </p:nvPicPr>
         <p:blipFill>
-          <a:blip xmlns:r="http://schemas.openxmlformats.org/officeDocument/2006/relationships" xmlns:a="http://schemas.openxmlformats.org/drawingml/2006/main" r:embed="Rbcba652af2d543af"/>
+          <a:blip xmlns:r="http://schemas.openxmlformats.org/officeDocument/2006/relationships" xmlns:a="http://schemas.openxmlformats.org/drawingml/2006/main" r:embed="R95109a82afd14d76"/>
           <a:stretch xmlns:a="http://schemas.openxmlformats.org/drawingml/2006/main"/>
         </p:blipFill>
         <p:spPr>
@@ -1750,7 +1750,7 @@
           <p:cNvPr id="3" name="">
             <a:extLst xmlns:a="http://schemas.openxmlformats.org/drawingml/2006/main">
               <a:ext uri="{FF2B5EF4-FFF2-40B4-BE49-F238E27FC236}">
-                <a16:creationId xmlns:a16="http://schemas.microsoft.com/office/drawing/2014/main" id="{F2CC314D-D0A1-481D-B8E6-8B2F6858E671}"/>
+                <a16:creationId xmlns:a16="http://schemas.microsoft.com/office/drawing/2014/main" id="{6290768F-C6B5-4301-A741-F3FFA6BD9E4D}"/>
               </a:ext>
             </a:extLst>
           </p:cNvPr>
@@ -1807,7 +1807,7 @@
           <p:cNvPr id="4" name="">
             <a:extLst xmlns:a="http://schemas.openxmlformats.org/drawingml/2006/main">
               <a:ext uri="{FF2B5EF4-FFF2-40B4-BE49-F238E27FC236}">
-                <a16:creationId xmlns:a16="http://schemas.microsoft.com/office/drawing/2014/main" id="{E221612D-7E1A-41E2-A24E-E764D987D4FE}"/>
+                <a16:creationId xmlns:a16="http://schemas.microsoft.com/office/drawing/2014/main" id="{5D9E6CD8-EDBD-4940-89B3-FC910F12D285}"/>
               </a:ext>
             </a:extLst>
           </p:cNvPr>
@@ -1864,7 +1864,7 @@
           <p:cNvPr id="5" name="">
             <a:extLst xmlns:a="http://schemas.openxmlformats.org/drawingml/2006/main">
               <a:ext uri="{FF2B5EF4-FFF2-40B4-BE49-F238E27FC236}">
-                <a16:creationId xmlns:a16="http://schemas.microsoft.com/office/drawing/2014/main" id="{05DF4B65-1463-43F5-82CF-D2BB6DE5835A}"/>
+                <a16:creationId xmlns:a16="http://schemas.microsoft.com/office/drawing/2014/main" id="{EFE2517F-D946-43ED-BC3C-0531D780C307}"/>
               </a:ext>
             </a:extLst>
           </p:cNvPr>
@@ -1894,7 +1894,7 @@
           <p:cNvPr id="6" name="">
             <a:extLst xmlns:a="http://schemas.openxmlformats.org/drawingml/2006/main">
               <a:ext uri="{FF2B5EF4-FFF2-40B4-BE49-F238E27FC236}">
-                <a16:creationId xmlns:a16="http://schemas.microsoft.com/office/drawing/2014/main" id="{0D8A42B2-9A30-466D-8269-933CF9B7F78B}"/>
+                <a16:creationId xmlns:a16="http://schemas.microsoft.com/office/drawing/2014/main" id="{F8E4EAD7-1A13-469F-A36E-3B634213A6C2}"/>
               </a:ext>
             </a:extLst>
           </p:cNvPr>
@@ -1951,7 +1951,7 @@
           <p:cNvPr id="7" name="">
             <a:extLst xmlns:a="http://schemas.openxmlformats.org/drawingml/2006/main">
               <a:ext uri="{FF2B5EF4-FFF2-40B4-BE49-F238E27FC236}">
-                <a16:creationId xmlns:a16="http://schemas.microsoft.com/office/drawing/2014/main" id="{ABA443F7-B983-47EF-9130-8132551221A8}"/>
+                <a16:creationId xmlns:a16="http://schemas.microsoft.com/office/drawing/2014/main" id="{05A0273A-0E93-4886-B733-6E30E7A9D9DB}"/>
               </a:ext>
             </a:extLst>
           </p:cNvPr>
@@ -2008,7 +2008,7 @@
           <p:cNvPr id="8" name="">
             <a:extLst xmlns:a="http://schemas.openxmlformats.org/drawingml/2006/main">
               <a:ext uri="{FF2B5EF4-FFF2-40B4-BE49-F238E27FC236}">
-                <a16:creationId xmlns:a16="http://schemas.microsoft.com/office/drawing/2014/main" id="{D678AE84-8267-459F-9B5C-A99CA5F68D9B}"/>
+                <a16:creationId xmlns:a16="http://schemas.microsoft.com/office/drawing/2014/main" id="{25C836C0-792A-4522-9F77-635586516DE5}"/>
               </a:ext>
             </a:extLst>
           </p:cNvPr>
@@ -2063,7 +2063,7 @@
     </p:spTree>
     <p:extLst>
       <p:ext uri="{BB962C8B-B14F-4D97-AF65-F5344CB8AC3E}">
-        <p14:creationId xmlns:p14="http://schemas.microsoft.com/office/powerpoint/2010/main" val="1103289619"/>
+        <p14:creationId xmlns:p14="http://schemas.microsoft.com/office/powerpoint/2010/main" val="696718715"/>
       </p:ext>
     </p:extLst>
   </p:cSld>
@@ -2094,7 +2094,7 @@
           <p:cNvPr id="14" name="">
             <a:extLst xmlns:a="http://schemas.openxmlformats.org/drawingml/2006/main">
               <a:ext uri="{FF2B5EF4-FFF2-40B4-BE49-F238E27FC236}">
-                <a16:creationId xmlns:a16="http://schemas.microsoft.com/office/drawing/2014/main" id="{6D5ADB83-95FA-4301-A21D-2F96BCC4CE43}"/>
+                <a16:creationId xmlns:a16="http://schemas.microsoft.com/office/drawing/2014/main" id="{AB2181DA-41C0-4944-B57C-C1D401D28832}"/>
               </a:ext>
             </a:extLst>
           </p:cNvPr>
@@ -2124,7 +2124,7 @@
           <p:cNvPr id="2" name="">
             <a:extLst xmlns:a="http://schemas.openxmlformats.org/drawingml/2006/main">
               <a:ext uri="{FF2B5EF4-FFF2-40B4-BE49-F238E27FC236}">
-                <a16:creationId xmlns:a16="http://schemas.microsoft.com/office/drawing/2014/main" id="{D9048C2C-8C72-4905-B577-AEE30CAF3820}"/>
+                <a16:creationId xmlns:a16="http://schemas.microsoft.com/office/drawing/2014/main" id="{F9BEE8A9-605D-4E93-882F-225E193069BE}"/>
               </a:ext>
             </a:extLst>
           </p:cNvPr>
@@ -2181,7 +2181,7 @@
           <p:cNvPr id="3" name="">
             <a:extLst xmlns:a="http://schemas.openxmlformats.org/drawingml/2006/main">
               <a:ext uri="{FF2B5EF4-FFF2-40B4-BE49-F238E27FC236}">
-                <a16:creationId xmlns:a16="http://schemas.microsoft.com/office/drawing/2014/main" id="{ADF45C40-A763-412C-A30C-DEDE5D9F35CD}"/>
+                <a16:creationId xmlns:a16="http://schemas.microsoft.com/office/drawing/2014/main" id="{CBD9E04A-A080-4530-9BF3-9245E2FB65AD}"/>
               </a:ext>
             </a:extLst>
           </p:cNvPr>
@@ -2238,7 +2238,7 @@
           <p:cNvPr id="4" name="">
             <a:extLst xmlns:a="http://schemas.openxmlformats.org/drawingml/2006/main">
               <a:ext uri="{FF2B5EF4-FFF2-40B4-BE49-F238E27FC236}">
-                <a16:creationId xmlns:a16="http://schemas.microsoft.com/office/drawing/2014/main" id="{6D407953-DDC6-4BEF-9195-34F06C7CBA8D}"/>
+                <a16:creationId xmlns:a16="http://schemas.microsoft.com/office/drawing/2014/main" id="{8A4CF3DF-6E0D-49BC-B3CF-6557F328AA72}"/>
               </a:ext>
             </a:extLst>
           </p:cNvPr>
@@ -2295,7 +2295,7 @@
           <p:cNvPr id="5" name="">
             <a:extLst xmlns:a="http://schemas.openxmlformats.org/drawingml/2006/main">
               <a:ext uri="{FF2B5EF4-FFF2-40B4-BE49-F238E27FC236}">
-                <a16:creationId xmlns:a16="http://schemas.microsoft.com/office/drawing/2014/main" id="{988F2121-3266-43F0-8F42-1B389A8BC76C}"/>
+                <a16:creationId xmlns:a16="http://schemas.microsoft.com/office/drawing/2014/main" id="{72A4D213-8754-4119-878C-17817664D1DD}"/>
               </a:ext>
             </a:extLst>
           </p:cNvPr>
@@ -2352,7 +2352,7 @@
           <p:cNvPr id="6" name="">
             <a:extLst xmlns:a="http://schemas.openxmlformats.org/drawingml/2006/main">
               <a:ext uri="{FF2B5EF4-FFF2-40B4-BE49-F238E27FC236}">
-                <a16:creationId xmlns:a16="http://schemas.microsoft.com/office/drawing/2014/main" id="{6E1CE1E2-ABE4-4EFA-8549-FAECE6C2A57D}"/>
+                <a16:creationId xmlns:a16="http://schemas.microsoft.com/office/drawing/2014/main" id="{30B97802-5F2B-42FB-9A20-C8408A0118E3}"/>
               </a:ext>
             </a:extLst>
           </p:cNvPr>
@@ -2387,7 +2387,7 @@
           <p:cNvPr id="7" name="">
             <a:extLst xmlns:a="http://schemas.openxmlformats.org/drawingml/2006/main">
               <a:ext uri="{FF2B5EF4-FFF2-40B4-BE49-F238E27FC236}">
-                <a16:creationId xmlns:a16="http://schemas.microsoft.com/office/drawing/2014/main" id="{5E2260CE-BB42-404B-8E56-9279AEC6BFC5}"/>
+                <a16:creationId xmlns:a16="http://schemas.microsoft.com/office/drawing/2014/main" id="{66FF65F5-2C3C-4F81-A06D-CA3F54D38FA0}"/>
               </a:ext>
             </a:extLst>
           </p:cNvPr>
@@ -2444,7 +2444,7 @@
           <p:cNvPr id="8" name="">
             <a:extLst xmlns:a="http://schemas.openxmlformats.org/drawingml/2006/main">
               <a:ext uri="{FF2B5EF4-FFF2-40B4-BE49-F238E27FC236}">
-                <a16:creationId xmlns:a16="http://schemas.microsoft.com/office/drawing/2014/main" id="{4B9F6285-E35A-47BF-89AD-FB4857FFD5FF}"/>
+                <a16:creationId xmlns:a16="http://schemas.microsoft.com/office/drawing/2014/main" id="{EB699619-5594-460C-A5D8-65E8D9DBA184}"/>
               </a:ext>
             </a:extLst>
           </p:cNvPr>
@@ -2501,7 +2501,7 @@
           <p:cNvPr id="9" name="">
             <a:extLst xmlns:a="http://schemas.openxmlformats.org/drawingml/2006/main">
               <a:ext uri="{FF2B5EF4-FFF2-40B4-BE49-F238E27FC236}">
-                <a16:creationId xmlns:a16="http://schemas.microsoft.com/office/drawing/2014/main" id="{698C294F-086D-470E-A9F1-511B500C8A26}"/>
+                <a16:creationId xmlns:a16="http://schemas.microsoft.com/office/drawing/2014/main" id="{0E64259B-3DC5-4E30-8305-56B67C9CB730}"/>
               </a:ext>
             </a:extLst>
           </p:cNvPr>
@@ -2558,7 +2558,7 @@
           <p:cNvPr id="10" name="">
             <a:extLst xmlns:a="http://schemas.openxmlformats.org/drawingml/2006/main">
               <a:ext uri="{FF2B5EF4-FFF2-40B4-BE49-F238E27FC236}">
-                <a16:creationId xmlns:a16="http://schemas.microsoft.com/office/drawing/2014/main" id="{764133CE-870E-42B4-AC54-56362B342E9B}"/>
+                <a16:creationId xmlns:a16="http://schemas.microsoft.com/office/drawing/2014/main" id="{48A167AC-292A-4CDD-9E9C-4F855275F0F4}"/>
               </a:ext>
             </a:extLst>
           </p:cNvPr>
@@ -2593,7 +2593,7 @@
           <p:cNvPr id="11" name="">
             <a:extLst xmlns:a="http://schemas.openxmlformats.org/drawingml/2006/main">
               <a:ext uri="{FF2B5EF4-FFF2-40B4-BE49-F238E27FC236}">
-                <a16:creationId xmlns:a16="http://schemas.microsoft.com/office/drawing/2014/main" id="{570DC1C9-2541-4A31-B7DE-9374F3BC11EC}"/>
+                <a16:creationId xmlns:a16="http://schemas.microsoft.com/office/drawing/2014/main" id="{E94073E6-15E7-460E-B431-7FBA8A5E278B}"/>
               </a:ext>
             </a:extLst>
           </p:cNvPr>
@@ -2650,7 +2650,7 @@
           <p:cNvPr id="12" name="">
             <a:extLst xmlns:a="http://schemas.openxmlformats.org/drawingml/2006/main">
               <a:ext uri="{FF2B5EF4-FFF2-40B4-BE49-F238E27FC236}">
-                <a16:creationId xmlns:a16="http://schemas.microsoft.com/office/drawing/2014/main" id="{B6FD6909-E98D-4339-A507-D6EA6FF07210}"/>
+                <a16:creationId xmlns:a16="http://schemas.microsoft.com/office/drawing/2014/main" id="{E0DE67C9-056C-4CC6-95E6-5D8972FC5BF0}"/>
               </a:ext>
             </a:extLst>
           </p:cNvPr>
@@ -2707,7 +2707,7 @@
           <p:cNvPr id="13" name="">
             <a:extLst xmlns:a="http://schemas.openxmlformats.org/drawingml/2006/main">
               <a:ext uri="{FF2B5EF4-FFF2-40B4-BE49-F238E27FC236}">
-                <a16:creationId xmlns:a16="http://schemas.microsoft.com/office/drawing/2014/main" id="{BE080295-5D07-4895-9B4E-F4E4B3B7F88D}"/>
+                <a16:creationId xmlns:a16="http://schemas.microsoft.com/office/drawing/2014/main" id="{81991FA8-C5C1-4F39-8A9C-424C2136EA72}"/>
               </a:ext>
             </a:extLst>
           </p:cNvPr>
@@ -2762,7 +2762,7 @@
     </p:spTree>
     <p:extLst>
       <p:ext uri="{BB962C8B-B14F-4D97-AF65-F5344CB8AC3E}">
-        <p14:creationId xmlns:p14="http://schemas.microsoft.com/office/powerpoint/2010/main" val="723333205"/>
+        <p14:creationId xmlns:p14="http://schemas.microsoft.com/office/powerpoint/2010/main" val="167508530"/>
       </p:ext>
     </p:extLst>
   </p:cSld>
@@ -2793,7 +2793,7 @@
           <p:cNvPr id="17" name="">
             <a:extLst xmlns:a="http://schemas.openxmlformats.org/drawingml/2006/main">
               <a:ext uri="{FF2B5EF4-FFF2-40B4-BE49-F238E27FC236}">
-                <a16:creationId xmlns:a16="http://schemas.microsoft.com/office/drawing/2014/main" id="{547D8B80-49EE-456A-9648-B64824178DA9}"/>
+                <a16:creationId xmlns:a16="http://schemas.microsoft.com/office/drawing/2014/main" id="{D9D1D1E4-E984-4B34-A915-BDDF5BDA8B93}"/>
               </a:ext>
             </a:extLst>
           </p:cNvPr>
@@ -2823,7 +2823,7 @@
           <p:cNvPr id="2" name="">
             <a:extLst xmlns:a="http://schemas.openxmlformats.org/drawingml/2006/main">
               <a:ext uri="{FF2B5EF4-FFF2-40B4-BE49-F238E27FC236}">
-                <a16:creationId xmlns:a16="http://schemas.microsoft.com/office/drawing/2014/main" id="{58C532B3-4CB8-40DF-8C3E-C17936939DC6}"/>
+                <a16:creationId xmlns:a16="http://schemas.microsoft.com/office/drawing/2014/main" id="{300F06B4-5A24-4655-83D5-71AEF60F576E}"/>
               </a:ext>
             </a:extLst>
           </p:cNvPr>
@@ -2880,7 +2880,7 @@
           <p:cNvPr id="3" name="">
             <a:extLst xmlns:a="http://schemas.openxmlformats.org/drawingml/2006/main">
               <a:ext uri="{FF2B5EF4-FFF2-40B4-BE49-F238E27FC236}">
-                <a16:creationId xmlns:a16="http://schemas.microsoft.com/office/drawing/2014/main" id="{567E5912-5345-4EC9-889C-7FC961A8F24C}"/>
+                <a16:creationId xmlns:a16="http://schemas.microsoft.com/office/drawing/2014/main" id="{FD5445C5-A95A-4433-967B-46951169F0AB}"/>
               </a:ext>
             </a:extLst>
           </p:cNvPr>
@@ -2937,7 +2937,7 @@
           <p:cNvPr id="4" name="">
             <a:extLst xmlns:a="http://schemas.openxmlformats.org/drawingml/2006/main">
               <a:ext uri="{FF2B5EF4-FFF2-40B4-BE49-F238E27FC236}">
-                <a16:creationId xmlns:a16="http://schemas.microsoft.com/office/drawing/2014/main" id="{0E68C3E1-9754-4390-9DCE-4AE90FF50DA4}"/>
+                <a16:creationId xmlns:a16="http://schemas.microsoft.com/office/drawing/2014/main" id="{B50A631D-FA87-46B5-BB3A-7C7E0ACE7BAD}"/>
               </a:ext>
             </a:extLst>
           </p:cNvPr>
@@ -2994,7 +2994,7 @@
           <p:cNvPr id="5" name="">
             <a:extLst xmlns:a="http://schemas.openxmlformats.org/drawingml/2006/main">
               <a:ext uri="{FF2B5EF4-FFF2-40B4-BE49-F238E27FC236}">
-                <a16:creationId xmlns:a16="http://schemas.microsoft.com/office/drawing/2014/main" id="{08C2C766-C8B8-43C6-AD70-F153AB76F2DE}"/>
+                <a16:creationId xmlns:a16="http://schemas.microsoft.com/office/drawing/2014/main" id="{91DB88E5-329A-4649-9425-9FA49E9FA2B3}"/>
               </a:ext>
             </a:extLst>
           </p:cNvPr>
@@ -3033,7 +3033,7 @@
           <p:nvPr/>
         </p:nvPicPr>
         <p:blipFill>
-          <a:blip xmlns:r="http://schemas.openxmlformats.org/officeDocument/2006/relationships" xmlns:a="http://schemas.openxmlformats.org/drawingml/2006/main" r:embed="R59d9bd2eed52440e"/>
+          <a:blip xmlns:r="http://schemas.openxmlformats.org/officeDocument/2006/relationships" xmlns:a="http://schemas.openxmlformats.org/drawingml/2006/main" r:embed="R616f4b717e804059"/>
           <a:srcRect xmlns:a="http://schemas.openxmlformats.org/drawingml/2006/main" l="0" t="18027" r="0" b="18027"/>
           <a:stretch xmlns:a="http://schemas.openxmlformats.org/drawingml/2006/main">
             <a:fillRect l="0" t="0" r="0" b="0"/>
@@ -3056,7 +3056,7 @@
           <p:cNvPr id="7" name="">
             <a:extLst xmlns:a="http://schemas.openxmlformats.org/drawingml/2006/main">
               <a:ext uri="{FF2B5EF4-FFF2-40B4-BE49-F238E27FC236}">
-                <a16:creationId xmlns:a16="http://schemas.microsoft.com/office/drawing/2014/main" id="{0093DA1A-5C47-43C4-A0A6-72EC7534A970}"/>
+                <a16:creationId xmlns:a16="http://schemas.microsoft.com/office/drawing/2014/main" id="{F0EED226-B41C-44D2-8232-EFBC2BF2B418}"/>
               </a:ext>
             </a:extLst>
           </p:cNvPr>
@@ -3113,7 +3113,7 @@
           <p:cNvPr id="8" name="">
             <a:extLst xmlns:a="http://schemas.openxmlformats.org/drawingml/2006/main">
               <a:ext uri="{FF2B5EF4-FFF2-40B4-BE49-F238E27FC236}">
-                <a16:creationId xmlns:a16="http://schemas.microsoft.com/office/drawing/2014/main" id="{7476BB07-7DF8-4AFE-9287-1CCE1BDB7440}"/>
+                <a16:creationId xmlns:a16="http://schemas.microsoft.com/office/drawing/2014/main" id="{1B42C63F-A04B-4516-BF31-289DF152E511}"/>
               </a:ext>
             </a:extLst>
           </p:cNvPr>
@@ -3170,7 +3170,7 @@
           <p:cNvPr id="9" name="">
             <a:extLst xmlns:a="http://schemas.openxmlformats.org/drawingml/2006/main">
               <a:ext uri="{FF2B5EF4-FFF2-40B4-BE49-F238E27FC236}">
-                <a16:creationId xmlns:a16="http://schemas.microsoft.com/office/drawing/2014/main" id="{60F5F742-9454-43DC-BA87-DBA7C5B6DF82}"/>
+                <a16:creationId xmlns:a16="http://schemas.microsoft.com/office/drawing/2014/main" id="{F1FB4CDC-C691-4E7F-BDFC-56AB0CE96B45}"/>
               </a:ext>
             </a:extLst>
           </p:cNvPr>
@@ -3227,7 +3227,7 @@
           <p:cNvPr id="10" name="">
             <a:extLst xmlns:a="http://schemas.openxmlformats.org/drawingml/2006/main">
               <a:ext uri="{FF2B5EF4-FFF2-40B4-BE49-F238E27FC236}">
-                <a16:creationId xmlns:a16="http://schemas.microsoft.com/office/drawing/2014/main" id="{732EF85A-8A78-4CB5-90A8-7F5A2478A039}"/>
+                <a16:creationId xmlns:a16="http://schemas.microsoft.com/office/drawing/2014/main" id="{25A49105-EBA5-4843-8E89-93605867FF99}"/>
               </a:ext>
             </a:extLst>
           </p:cNvPr>
@@ -3284,7 +3284,7 @@
           <p:cNvPr id="11" name="">
             <a:extLst xmlns:a="http://schemas.openxmlformats.org/drawingml/2006/main">
               <a:ext uri="{FF2B5EF4-FFF2-40B4-BE49-F238E27FC236}">
-                <a16:creationId xmlns:a16="http://schemas.microsoft.com/office/drawing/2014/main" id="{55C4E02C-F6EE-4C28-9DB0-B94306A5A49F}"/>
+                <a16:creationId xmlns:a16="http://schemas.microsoft.com/office/drawing/2014/main" id="{55587249-4F2D-4331-A775-8C01E018D445}"/>
               </a:ext>
             </a:extLst>
           </p:cNvPr>
@@ -3341,7 +3341,7 @@
           <p:cNvPr id="12" name="">
             <a:extLst xmlns:a="http://schemas.openxmlformats.org/drawingml/2006/main">
               <a:ext uri="{FF2B5EF4-FFF2-40B4-BE49-F238E27FC236}">
-                <a16:creationId xmlns:a16="http://schemas.microsoft.com/office/drawing/2014/main" id="{DC7B45B4-BD57-4E34-ACC9-9DE2DBCA883F}"/>
+                <a16:creationId xmlns:a16="http://schemas.microsoft.com/office/drawing/2014/main" id="{2064DE94-3213-4139-879F-338D069D93DE}"/>
               </a:ext>
             </a:extLst>
           </p:cNvPr>
@@ -3398,7 +3398,7 @@
           <p:cNvPr id="13" name="">
             <a:extLst xmlns:a="http://schemas.openxmlformats.org/drawingml/2006/main">
               <a:ext uri="{FF2B5EF4-FFF2-40B4-BE49-F238E27FC236}">
-                <a16:creationId xmlns:a16="http://schemas.microsoft.com/office/drawing/2014/main" id="{72F623A1-F444-4411-821D-71ACB430CAE1}"/>
+                <a16:creationId xmlns:a16="http://schemas.microsoft.com/office/drawing/2014/main" id="{5C51BE1D-7EE4-433C-B09E-1F87678B484F}"/>
               </a:ext>
             </a:extLst>
           </p:cNvPr>
@@ -3455,7 +3455,7 @@
           <p:cNvPr id="14" name="">
             <a:extLst xmlns:a="http://schemas.openxmlformats.org/drawingml/2006/main">
               <a:ext uri="{FF2B5EF4-FFF2-40B4-BE49-F238E27FC236}">
-                <a16:creationId xmlns:a16="http://schemas.microsoft.com/office/drawing/2014/main" id="{1B750013-64AC-4533-BB5E-5BA100ED3DF9}"/>
+                <a16:creationId xmlns:a16="http://schemas.microsoft.com/office/drawing/2014/main" id="{241BD93F-2665-46E3-BEFA-D1E1ED215C74}"/>
               </a:ext>
             </a:extLst>
           </p:cNvPr>
@@ -3512,7 +3512,7 @@
           <p:cNvPr id="15" name="">
             <a:extLst xmlns:a="http://schemas.openxmlformats.org/drawingml/2006/main">
               <a:ext uri="{FF2B5EF4-FFF2-40B4-BE49-F238E27FC236}">
-                <a16:creationId xmlns:a16="http://schemas.microsoft.com/office/drawing/2014/main" id="{30D068D1-2947-4FF4-8D18-44364C533A76}"/>
+                <a16:creationId xmlns:a16="http://schemas.microsoft.com/office/drawing/2014/main" id="{DDFCFABB-E9EF-4B52-81E0-75269DBCC102}"/>
               </a:ext>
             </a:extLst>
           </p:cNvPr>
@@ -3569,7 +3569,7 @@
           <p:cNvPr id="16" name="">
             <a:extLst xmlns:a="http://schemas.openxmlformats.org/drawingml/2006/main">
               <a:ext uri="{FF2B5EF4-FFF2-40B4-BE49-F238E27FC236}">
-                <a16:creationId xmlns:a16="http://schemas.microsoft.com/office/drawing/2014/main" id="{F59AE1F3-F354-4947-A737-3D8F306C085D}"/>
+                <a16:creationId xmlns:a16="http://schemas.microsoft.com/office/drawing/2014/main" id="{3FF0DCCC-3852-4376-82C1-3E58D5DCDCA7}"/>
               </a:ext>
             </a:extLst>
           </p:cNvPr>
@@ -3624,7 +3624,7 @@
     </p:spTree>
     <p:extLst>
       <p:ext uri="{BB962C8B-B14F-4D97-AF65-F5344CB8AC3E}">
-        <p14:creationId xmlns:p14="http://schemas.microsoft.com/office/powerpoint/2010/main" val="1467849850"/>
+        <p14:creationId xmlns:p14="http://schemas.microsoft.com/office/powerpoint/2010/main" val="568947202"/>
       </p:ext>
     </p:extLst>
   </p:cSld>
@@ -3655,7 +3655,7 @@
           <p:cNvPr id="32" name="">
             <a:extLst xmlns:a="http://schemas.openxmlformats.org/drawingml/2006/main">
               <a:ext uri="{FF2B5EF4-FFF2-40B4-BE49-F238E27FC236}">
-                <a16:creationId xmlns:a16="http://schemas.microsoft.com/office/drawing/2014/main" id="{4D1D1F1C-816D-4770-A3D6-390199E9088B}"/>
+                <a16:creationId xmlns:a16="http://schemas.microsoft.com/office/drawing/2014/main" id="{5C24A28C-569D-47AE-996F-CF348CFFD23A}"/>
               </a:ext>
             </a:extLst>
           </p:cNvPr>
@@ -3685,7 +3685,7 @@
           <p:cNvPr id="2" name="">
             <a:extLst xmlns:a="http://schemas.openxmlformats.org/drawingml/2006/main">
               <a:ext uri="{FF2B5EF4-FFF2-40B4-BE49-F238E27FC236}">
-                <a16:creationId xmlns:a16="http://schemas.microsoft.com/office/drawing/2014/main" id="{BFCCB984-0C80-4074-9805-673054494FF6}"/>
+                <a16:creationId xmlns:a16="http://schemas.microsoft.com/office/drawing/2014/main" id="{490B0883-CBB5-4550-94A4-72AF4B166517}"/>
               </a:ext>
             </a:extLst>
           </p:cNvPr>
@@ -3742,7 +3742,7 @@
           <p:cNvPr id="3" name="">
             <a:extLst xmlns:a="http://schemas.openxmlformats.org/drawingml/2006/main">
               <a:ext uri="{FF2B5EF4-FFF2-40B4-BE49-F238E27FC236}">
-                <a16:creationId xmlns:a16="http://schemas.microsoft.com/office/drawing/2014/main" id="{CB95589C-90BE-4499-95FF-9B9DC5C84B10}"/>
+                <a16:creationId xmlns:a16="http://schemas.microsoft.com/office/drawing/2014/main" id="{E5BF70D1-3E2E-4F4E-B465-10DDBB790960}"/>
               </a:ext>
             </a:extLst>
           </p:cNvPr>
@@ -3799,7 +3799,7 @@
           <p:cNvPr id="4" name="">
             <a:extLst xmlns:a="http://schemas.openxmlformats.org/drawingml/2006/main">
               <a:ext uri="{FF2B5EF4-FFF2-40B4-BE49-F238E27FC236}">
-                <a16:creationId xmlns:a16="http://schemas.microsoft.com/office/drawing/2014/main" id="{71A87614-BCEE-4921-8797-37B163A46265}"/>
+                <a16:creationId xmlns:a16="http://schemas.microsoft.com/office/drawing/2014/main" id="{BB39083F-75D2-40AE-BCC7-CEC13A9231E9}"/>
               </a:ext>
             </a:extLst>
           </p:cNvPr>
@@ -3856,7 +3856,7 @@
           <p:cNvPr id="5" name="">
             <a:extLst xmlns:a="http://schemas.openxmlformats.org/drawingml/2006/main">
               <a:ext uri="{FF2B5EF4-FFF2-40B4-BE49-F238E27FC236}">
-                <a16:creationId xmlns:a16="http://schemas.microsoft.com/office/drawing/2014/main" id="{59A76829-16B4-4847-B114-0F31E34A88B6}"/>
+                <a16:creationId xmlns:a16="http://schemas.microsoft.com/office/drawing/2014/main" id="{98BC9C02-4578-4BBA-A3F7-41A8DC0C2492}"/>
               </a:ext>
             </a:extLst>
           </p:cNvPr>
@@ -3891,7 +3891,7 @@
           <p:cNvPr id="6" name="">
             <a:extLst xmlns:a="http://schemas.openxmlformats.org/drawingml/2006/main">
               <a:ext uri="{FF2B5EF4-FFF2-40B4-BE49-F238E27FC236}">
-                <a16:creationId xmlns:a16="http://schemas.microsoft.com/office/drawing/2014/main" id="{86D8589F-CAC6-46C4-B056-9BC87D671E44}"/>
+                <a16:creationId xmlns:a16="http://schemas.microsoft.com/office/drawing/2014/main" id="{39BB560E-FB48-4DA0-992A-6DB19AAF82F6}"/>
               </a:ext>
             </a:extLst>
           </p:cNvPr>
@@ -3948,7 +3948,7 @@
           <p:cNvPr id="7" name="">
             <a:extLst xmlns:a="http://schemas.openxmlformats.org/drawingml/2006/main">
               <a:ext uri="{FF2B5EF4-FFF2-40B4-BE49-F238E27FC236}">
-                <a16:creationId xmlns:a16="http://schemas.microsoft.com/office/drawing/2014/main" id="{6BE7F70D-D31B-48D6-AE96-E9942B3EBEC4}"/>
+                <a16:creationId xmlns:a16="http://schemas.microsoft.com/office/drawing/2014/main" id="{94F5E6DC-D087-4C4D-B8E7-6F5E5DFAF564}"/>
               </a:ext>
             </a:extLst>
           </p:cNvPr>
@@ -4005,7 +4005,7 @@
           <p:cNvPr id="8" name="">
             <a:extLst xmlns:a="http://schemas.openxmlformats.org/drawingml/2006/main">
               <a:ext uri="{FF2B5EF4-FFF2-40B4-BE49-F238E27FC236}">
-                <a16:creationId xmlns:a16="http://schemas.microsoft.com/office/drawing/2014/main" id="{A609AB96-6F8C-488B-A917-5E1B9BB7BBD4}"/>
+                <a16:creationId xmlns:a16="http://schemas.microsoft.com/office/drawing/2014/main" id="{4249C291-0B7E-4071-8919-17AA89214D1A}"/>
               </a:ext>
             </a:extLst>
           </p:cNvPr>
@@ -4040,7 +4040,7 @@
           <p:cNvPr id="9" name="">
             <a:extLst xmlns:a="http://schemas.openxmlformats.org/drawingml/2006/main">
               <a:ext uri="{FF2B5EF4-FFF2-40B4-BE49-F238E27FC236}">
-                <a16:creationId xmlns:a16="http://schemas.microsoft.com/office/drawing/2014/main" id="{ACBE0212-5081-46DB-B955-ECBDF5F1464A}"/>
+                <a16:creationId xmlns:a16="http://schemas.microsoft.com/office/drawing/2014/main" id="{7A504AFD-8F53-4DBB-BFDA-2274D6061602}"/>
               </a:ext>
             </a:extLst>
           </p:cNvPr>
@@ -4097,7 +4097,7 @@
           <p:cNvPr id="10" name="">
             <a:extLst xmlns:a="http://schemas.openxmlformats.org/drawingml/2006/main">
               <a:ext uri="{FF2B5EF4-FFF2-40B4-BE49-F238E27FC236}">
-                <a16:creationId xmlns:a16="http://schemas.microsoft.com/office/drawing/2014/main" id="{0A3724C6-37FC-4A9D-87F5-667F97F6FDE6}"/>
+                <a16:creationId xmlns:a16="http://schemas.microsoft.com/office/drawing/2014/main" id="{CCF6A85C-1240-4032-AA77-0F231695C2FF}"/>
               </a:ext>
             </a:extLst>
           </p:cNvPr>
@@ -4154,7 +4154,7 @@
           <p:cNvPr id="11" name="">
             <a:extLst xmlns:a="http://schemas.openxmlformats.org/drawingml/2006/main">
               <a:ext uri="{FF2B5EF4-FFF2-40B4-BE49-F238E27FC236}">
-                <a16:creationId xmlns:a16="http://schemas.microsoft.com/office/drawing/2014/main" id="{A551E78E-C655-4E43-B162-CEEC1D588EAE}"/>
+                <a16:creationId xmlns:a16="http://schemas.microsoft.com/office/drawing/2014/main" id="{149C6403-1BB2-448B-A05E-4AD074680D55}"/>
               </a:ext>
             </a:extLst>
           </p:cNvPr>
@@ -4189,7 +4189,7 @@
           <p:cNvPr id="12" name="">
             <a:extLst xmlns:a="http://schemas.openxmlformats.org/drawingml/2006/main">
               <a:ext uri="{FF2B5EF4-FFF2-40B4-BE49-F238E27FC236}">
-                <a16:creationId xmlns:a16="http://schemas.microsoft.com/office/drawing/2014/main" id="{250403D6-E1C0-4AD3-9FAF-73D1F9C84596}"/>
+                <a16:creationId xmlns:a16="http://schemas.microsoft.com/office/drawing/2014/main" id="{47F723AA-D3B1-4AE0-9FBF-6C777ECFFB69}"/>
               </a:ext>
             </a:extLst>
           </p:cNvPr>
@@ -4246,7 +4246,7 @@
           <p:cNvPr id="13" name="">
             <a:extLst xmlns:a="http://schemas.openxmlformats.org/drawingml/2006/main">
               <a:ext uri="{FF2B5EF4-FFF2-40B4-BE49-F238E27FC236}">
-                <a16:creationId xmlns:a16="http://schemas.microsoft.com/office/drawing/2014/main" id="{602740E8-0BC6-46D5-B13E-8A1E3911016B}"/>
+                <a16:creationId xmlns:a16="http://schemas.microsoft.com/office/drawing/2014/main" id="{9520CC2E-453A-47A5-ACC8-F921A2E4CD9D}"/>
               </a:ext>
             </a:extLst>
           </p:cNvPr>
@@ -4326,7 +4326,7 @@
           <p:cNvPr id="14" name="">
             <a:extLst xmlns:a="http://schemas.openxmlformats.org/drawingml/2006/main">
               <a:ext uri="{FF2B5EF4-FFF2-40B4-BE49-F238E27FC236}">
-                <a16:creationId xmlns:a16="http://schemas.microsoft.com/office/drawing/2014/main" id="{16C3F763-A892-484E-AE14-FF68229FAF18}"/>
+                <a16:creationId xmlns:a16="http://schemas.microsoft.com/office/drawing/2014/main" id="{0591C255-043F-430F-AC98-5E5DA117DB63}"/>
               </a:ext>
             </a:extLst>
           </p:cNvPr>
@@ -4361,7 +4361,7 @@
           <p:cNvPr id="15" name="">
             <a:extLst xmlns:a="http://schemas.openxmlformats.org/drawingml/2006/main">
               <a:ext uri="{FF2B5EF4-FFF2-40B4-BE49-F238E27FC236}">
-                <a16:creationId xmlns:a16="http://schemas.microsoft.com/office/drawing/2014/main" id="{7B206697-B5BB-4F85-B8CA-B98C04AFE848}"/>
+                <a16:creationId xmlns:a16="http://schemas.microsoft.com/office/drawing/2014/main" id="{D7E445E4-CEBE-49F1-BDC3-7CB2EF79EEE0}"/>
               </a:ext>
             </a:extLst>
           </p:cNvPr>
@@ -4418,7 +4418,7 @@
           <p:cNvPr id="16" name="">
             <a:extLst xmlns:a="http://schemas.openxmlformats.org/drawingml/2006/main">
               <a:ext uri="{FF2B5EF4-FFF2-40B4-BE49-F238E27FC236}">
-                <a16:creationId xmlns:a16="http://schemas.microsoft.com/office/drawing/2014/main" id="{9748EA4D-6113-4D62-848D-EEF79478F4E4}"/>
+                <a16:creationId xmlns:a16="http://schemas.microsoft.com/office/drawing/2014/main" id="{52E879E6-C02A-4C7C-8323-932A428DFA13}"/>
               </a:ext>
             </a:extLst>
           </p:cNvPr>
@@ -4553,7 +4553,7 @@
           <p:cNvPr id="20" name="">
             <a:extLst xmlns:a="http://schemas.openxmlformats.org/drawingml/2006/main">
               <a:ext uri="{FF2B5EF4-FFF2-40B4-BE49-F238E27FC236}">
-                <a16:creationId xmlns:a16="http://schemas.microsoft.com/office/drawing/2014/main" id="{2D293D5D-E713-4E64-AE2C-648CB8073929}"/>
+                <a16:creationId xmlns:a16="http://schemas.microsoft.com/office/drawing/2014/main" id="{2428F83C-67D9-469B-BCAB-A10D053CB820}"/>
               </a:ext>
             </a:extLst>
           </p:cNvPr>
@@ -4588,7 +4588,7 @@
           <p:cNvPr id="21" name="">
             <a:extLst xmlns:a="http://schemas.openxmlformats.org/drawingml/2006/main">
               <a:ext uri="{FF2B5EF4-FFF2-40B4-BE49-F238E27FC236}">
-                <a16:creationId xmlns:a16="http://schemas.microsoft.com/office/drawing/2014/main" id="{57F03553-3654-4C13-BE7B-689F8C425373}"/>
+                <a16:creationId xmlns:a16="http://schemas.microsoft.com/office/drawing/2014/main" id="{FBF16366-9B03-4400-B5D4-B5672AD50111}"/>
               </a:ext>
             </a:extLst>
           </p:cNvPr>
@@ -4645,7 +4645,7 @@
           <p:cNvPr id="22" name="">
             <a:extLst xmlns:a="http://schemas.openxmlformats.org/drawingml/2006/main">
               <a:ext uri="{FF2B5EF4-FFF2-40B4-BE49-F238E27FC236}">
-                <a16:creationId xmlns:a16="http://schemas.microsoft.com/office/drawing/2014/main" id="{C3BF8127-A32D-42D5-977E-6D60981E7DEB}"/>
+                <a16:creationId xmlns:a16="http://schemas.microsoft.com/office/drawing/2014/main" id="{938B1F2C-5F71-4128-A21A-99F4EF6979D2}"/>
               </a:ext>
             </a:extLst>
           </p:cNvPr>
@@ -4702,7 +4702,7 @@
           <p:cNvPr id="23" name="">
             <a:extLst xmlns:a="http://schemas.openxmlformats.org/drawingml/2006/main">
               <a:ext uri="{FF2B5EF4-FFF2-40B4-BE49-F238E27FC236}">
-                <a16:creationId xmlns:a16="http://schemas.microsoft.com/office/drawing/2014/main" id="{90455D7A-9224-44E7-A0F8-852522E7A632}"/>
+                <a16:creationId xmlns:a16="http://schemas.microsoft.com/office/drawing/2014/main" id="{CED2E63E-889D-4FFD-AF57-3BE17A0A09B6}"/>
               </a:ext>
             </a:extLst>
           </p:cNvPr>
@@ -4737,7 +4737,7 @@
           <p:cNvPr id="24" name="">
             <a:extLst xmlns:a="http://schemas.openxmlformats.org/drawingml/2006/main">
               <a:ext uri="{FF2B5EF4-FFF2-40B4-BE49-F238E27FC236}">
-                <a16:creationId xmlns:a16="http://schemas.microsoft.com/office/drawing/2014/main" id="{AE917B34-8B3B-430F-95A0-D084B55A2012}"/>
+                <a16:creationId xmlns:a16="http://schemas.microsoft.com/office/drawing/2014/main" id="{53C163F1-247A-4C6E-A0A2-07C4F6320A6C}"/>
               </a:ext>
             </a:extLst>
           </p:cNvPr>
@@ -4794,7 +4794,7 @@
           <p:cNvPr id="25" name="">
             <a:extLst xmlns:a="http://schemas.openxmlformats.org/drawingml/2006/main">
               <a:ext uri="{FF2B5EF4-FFF2-40B4-BE49-F238E27FC236}">
-                <a16:creationId xmlns:a16="http://schemas.microsoft.com/office/drawing/2014/main" id="{C3AB756C-E2D5-4BB4-AB32-B1B73A383001}"/>
+                <a16:creationId xmlns:a16="http://schemas.microsoft.com/office/drawing/2014/main" id="{8637F0F7-45B9-41E3-BF2D-DED89F1879DB}"/>
               </a:ext>
             </a:extLst>
           </p:cNvPr>
@@ -4897,7 +4897,7 @@
           <p:cNvPr id="26" name="">
             <a:extLst xmlns:a="http://schemas.openxmlformats.org/drawingml/2006/main">
               <a:ext uri="{FF2B5EF4-FFF2-40B4-BE49-F238E27FC236}">
-                <a16:creationId xmlns:a16="http://schemas.microsoft.com/office/drawing/2014/main" id="{D618142F-B2BE-43F9-B63D-3153DFE866DB}"/>
+                <a16:creationId xmlns:a16="http://schemas.microsoft.com/office/drawing/2014/main" id="{30696130-69A1-4A2A-8543-2CA7446BBE10}"/>
               </a:ext>
             </a:extLst>
           </p:cNvPr>
@@ -4932,7 +4932,7 @@
           <p:cNvPr id="27" name="">
             <a:extLst xmlns:a="http://schemas.openxmlformats.org/drawingml/2006/main">
               <a:ext uri="{FF2B5EF4-FFF2-40B4-BE49-F238E27FC236}">
-                <a16:creationId xmlns:a16="http://schemas.microsoft.com/office/drawing/2014/main" id="{C4AC19CF-F1A1-4A5B-88DC-B3B10B247B03}"/>
+                <a16:creationId xmlns:a16="http://schemas.microsoft.com/office/drawing/2014/main" id="{FA8F51B2-6BD8-4BFE-8E04-B6F521DD42E1}"/>
               </a:ext>
             </a:extLst>
           </p:cNvPr>
@@ -4989,7 +4989,7 @@
           <p:cNvPr id="28" name="">
             <a:extLst xmlns:a="http://schemas.openxmlformats.org/drawingml/2006/main">
               <a:ext uri="{FF2B5EF4-FFF2-40B4-BE49-F238E27FC236}">
-                <a16:creationId xmlns:a16="http://schemas.microsoft.com/office/drawing/2014/main" id="{C321D33A-4379-4A46-9808-AFB36F9F5E91}"/>
+                <a16:creationId xmlns:a16="http://schemas.microsoft.com/office/drawing/2014/main" id="{640AFDE7-4005-428E-BA3F-19ABEA535450}"/>
               </a:ext>
             </a:extLst>
           </p:cNvPr>
@@ -5144,7 +5144,7 @@
           <p:cNvPr id="31" name="">
             <a:extLst xmlns:a="http://schemas.openxmlformats.org/drawingml/2006/main">
               <a:ext uri="{FF2B5EF4-FFF2-40B4-BE49-F238E27FC236}">
-                <a16:creationId xmlns:a16="http://schemas.microsoft.com/office/drawing/2014/main" id="{4EE671A8-422D-4BEE-BA22-FD563066F703}"/>
+                <a16:creationId xmlns:a16="http://schemas.microsoft.com/office/drawing/2014/main" id="{B4279520-636F-40D1-8B86-A4A37E0F01FD}"/>
               </a:ext>
             </a:extLst>
           </p:cNvPr>
@@ -5199,7 +5199,7 @@
     </p:spTree>
     <p:extLst>
       <p:ext uri="{BB962C8B-B14F-4D97-AF65-F5344CB8AC3E}">
-        <p14:creationId xmlns:p14="http://schemas.microsoft.com/office/powerpoint/2010/main" val="400189143"/>
+        <p14:creationId xmlns:p14="http://schemas.microsoft.com/office/powerpoint/2010/main" val="308775284"/>
       </p:ext>
     </p:extLst>
   </p:cSld>
@@ -5230,7 +5230,7 @@
           <p:cNvPr id="21" name="">
             <a:extLst xmlns:a="http://schemas.openxmlformats.org/drawingml/2006/main">
               <a:ext uri="{FF2B5EF4-FFF2-40B4-BE49-F238E27FC236}">
-                <a16:creationId xmlns:a16="http://schemas.microsoft.com/office/drawing/2014/main" id="{EDBAEC84-7254-4C63-944B-DF13E2FE455A}"/>
+                <a16:creationId xmlns:a16="http://schemas.microsoft.com/office/drawing/2014/main" id="{87474A44-1F9B-4D0B-81C2-CB85720F6207}"/>
               </a:ext>
             </a:extLst>
           </p:cNvPr>
@@ -5260,7 +5260,7 @@
           <p:cNvPr id="2" name="">
             <a:extLst xmlns:a="http://schemas.openxmlformats.org/drawingml/2006/main">
               <a:ext uri="{FF2B5EF4-FFF2-40B4-BE49-F238E27FC236}">
-                <a16:creationId xmlns:a16="http://schemas.microsoft.com/office/drawing/2014/main" id="{D0EF6201-232A-40FD-9882-38D301884BCF}"/>
+                <a16:creationId xmlns:a16="http://schemas.microsoft.com/office/drawing/2014/main" id="{4F45A1DB-E43B-45BE-BA65-FB4FB4E7A56A}"/>
               </a:ext>
             </a:extLst>
           </p:cNvPr>
@@ -5317,7 +5317,7 @@
           <p:cNvPr id="3" name="">
             <a:extLst xmlns:a="http://schemas.openxmlformats.org/drawingml/2006/main">
               <a:ext uri="{FF2B5EF4-FFF2-40B4-BE49-F238E27FC236}">
-                <a16:creationId xmlns:a16="http://schemas.microsoft.com/office/drawing/2014/main" id="{668725BB-24CE-49D3-AB50-722F3A5C256C}"/>
+                <a16:creationId xmlns:a16="http://schemas.microsoft.com/office/drawing/2014/main" id="{A3B4EFA8-456C-4827-A930-98CDD66331B9}"/>
               </a:ext>
             </a:extLst>
           </p:cNvPr>
@@ -5374,7 +5374,7 @@
           <p:cNvPr id="4" name="">
             <a:extLst xmlns:a="http://schemas.openxmlformats.org/drawingml/2006/main">
               <a:ext uri="{FF2B5EF4-FFF2-40B4-BE49-F238E27FC236}">
-                <a16:creationId xmlns:a16="http://schemas.microsoft.com/office/drawing/2014/main" id="{E58310C3-4607-4386-A6A7-452EEA0BA521}"/>
+                <a16:creationId xmlns:a16="http://schemas.microsoft.com/office/drawing/2014/main" id="{F67882DF-53FD-44FD-A344-9338DF297CF2}"/>
               </a:ext>
             </a:extLst>
           </p:cNvPr>
@@ -5431,7 +5431,7 @@
           <p:cNvPr id="5" name="">
             <a:extLst xmlns:a="http://schemas.openxmlformats.org/drawingml/2006/main">
               <a:ext uri="{FF2B5EF4-FFF2-40B4-BE49-F238E27FC236}">
-                <a16:creationId xmlns:a16="http://schemas.microsoft.com/office/drawing/2014/main" id="{D9D009F2-B0EC-43BF-9391-A5AFEB79A637}"/>
+                <a16:creationId xmlns:a16="http://schemas.microsoft.com/office/drawing/2014/main" id="{0C0FFA38-B686-4F6F-A2D2-451CBC375A49}"/>
               </a:ext>
             </a:extLst>
           </p:cNvPr>
@@ -5488,7 +5488,7 @@
           <p:cNvPr id="6" name="">
             <a:extLst xmlns:a="http://schemas.openxmlformats.org/drawingml/2006/main">
               <a:ext uri="{FF2B5EF4-FFF2-40B4-BE49-F238E27FC236}">
-                <a16:creationId xmlns:a16="http://schemas.microsoft.com/office/drawing/2014/main" id="{40534420-8D24-4D83-AC8C-99EAEC2B211B}"/>
+                <a16:creationId xmlns:a16="http://schemas.microsoft.com/office/drawing/2014/main" id="{5B8BF081-3DEC-4D99-AD1C-4E587A36768E}"/>
               </a:ext>
             </a:extLst>
           </p:cNvPr>
@@ -5545,7 +5545,7 @@
           <p:cNvPr id="7" name="">
             <a:extLst xmlns:a="http://schemas.openxmlformats.org/drawingml/2006/main">
               <a:ext uri="{FF2B5EF4-FFF2-40B4-BE49-F238E27FC236}">
-                <a16:creationId xmlns:a16="http://schemas.microsoft.com/office/drawing/2014/main" id="{CBAD4825-70A0-4BAB-98A0-618F29289750}"/>
+                <a16:creationId xmlns:a16="http://schemas.microsoft.com/office/drawing/2014/main" id="{F9D120F5-9E6B-4C45-9278-DA785A5FAE15}"/>
               </a:ext>
             </a:extLst>
           </p:cNvPr>
@@ -5602,7 +5602,7 @@
           <p:cNvPr id="8" name="">
             <a:extLst xmlns:a="http://schemas.openxmlformats.org/drawingml/2006/main">
               <a:ext uri="{FF2B5EF4-FFF2-40B4-BE49-F238E27FC236}">
-                <a16:creationId xmlns:a16="http://schemas.microsoft.com/office/drawing/2014/main" id="{4504C477-E1DF-4373-9EA2-54E662145B4D}"/>
+                <a16:creationId xmlns:a16="http://schemas.microsoft.com/office/drawing/2014/main" id="{3DE9CA88-7EF1-4D97-933B-168C38CFB44D}"/>
               </a:ext>
             </a:extLst>
           </p:cNvPr>
@@ -5632,7 +5632,7 @@
           <p:cNvPr id="9" name="">
             <a:extLst xmlns:a="http://schemas.openxmlformats.org/drawingml/2006/main">
               <a:ext uri="{FF2B5EF4-FFF2-40B4-BE49-F238E27FC236}">
-                <a16:creationId xmlns:a16="http://schemas.microsoft.com/office/drawing/2014/main" id="{40C8EC05-D30B-4EB6-83E5-EAB2191916CC}"/>
+                <a16:creationId xmlns:a16="http://schemas.microsoft.com/office/drawing/2014/main" id="{CACCAA1B-FBBA-4BA6-8A1F-DC67AACA2DCD}"/>
               </a:ext>
             </a:extLst>
           </p:cNvPr>
@@ -5689,7 +5689,7 @@
           <p:cNvPr id="10" name="">
             <a:extLst xmlns:a="http://schemas.openxmlformats.org/drawingml/2006/main">
               <a:ext uri="{FF2B5EF4-FFF2-40B4-BE49-F238E27FC236}">
-                <a16:creationId xmlns:a16="http://schemas.microsoft.com/office/drawing/2014/main" id="{6E785CE8-4C75-4C37-B607-02CFFDADFF92}"/>
+                <a16:creationId xmlns:a16="http://schemas.microsoft.com/office/drawing/2014/main" id="{DD9610C1-07DF-4AA4-B813-CD1625B8830C}"/>
               </a:ext>
             </a:extLst>
           </p:cNvPr>
@@ -5746,7 +5746,7 @@
           <p:cNvPr id="11" name="">
             <a:extLst xmlns:a="http://schemas.openxmlformats.org/drawingml/2006/main">
               <a:ext uri="{FF2B5EF4-FFF2-40B4-BE49-F238E27FC236}">
-                <a16:creationId xmlns:a16="http://schemas.microsoft.com/office/drawing/2014/main" id="{C5CBD3C2-DF81-4E98-BA91-D45DD572AF76}"/>
+                <a16:creationId xmlns:a16="http://schemas.microsoft.com/office/drawing/2014/main" id="{218E1120-97F6-46A8-9F89-A6AE2DF0C0BC}"/>
               </a:ext>
             </a:extLst>
           </p:cNvPr>
@@ -5803,7 +5803,7 @@
           <p:cNvPr id="12" name="">
             <a:extLst xmlns:a="http://schemas.openxmlformats.org/drawingml/2006/main">
               <a:ext uri="{FF2B5EF4-FFF2-40B4-BE49-F238E27FC236}">
-                <a16:creationId xmlns:a16="http://schemas.microsoft.com/office/drawing/2014/main" id="{B55B98B1-AB22-4E4A-9614-9185CF3FC825}"/>
+                <a16:creationId xmlns:a16="http://schemas.microsoft.com/office/drawing/2014/main" id="{DAA474D0-D742-43AC-9D48-22DBC68122D2}"/>
               </a:ext>
             </a:extLst>
           </p:cNvPr>
@@ -5833,7 +5833,7 @@
           <p:cNvPr id="13" name="">
             <a:extLst xmlns:a="http://schemas.openxmlformats.org/drawingml/2006/main">
               <a:ext uri="{FF2B5EF4-FFF2-40B4-BE49-F238E27FC236}">
-                <a16:creationId xmlns:a16="http://schemas.microsoft.com/office/drawing/2014/main" id="{0C09466E-85A7-47B3-87CD-3903E3B0CDC6}"/>
+                <a16:creationId xmlns:a16="http://schemas.microsoft.com/office/drawing/2014/main" id="{2993D29C-7EBF-4C55-BFF4-7CCE5CB08D93}"/>
               </a:ext>
             </a:extLst>
           </p:cNvPr>
@@ -5890,7 +5890,7 @@
           <p:cNvPr id="14" name="">
             <a:extLst xmlns:a="http://schemas.openxmlformats.org/drawingml/2006/main">
               <a:ext uri="{FF2B5EF4-FFF2-40B4-BE49-F238E27FC236}">
-                <a16:creationId xmlns:a16="http://schemas.microsoft.com/office/drawing/2014/main" id="{27774C62-D372-4E11-805D-3444D42A1E39}"/>
+                <a16:creationId xmlns:a16="http://schemas.microsoft.com/office/drawing/2014/main" id="{28E1DEDD-1E6E-4129-95CB-B39914BC67EE}"/>
               </a:ext>
             </a:extLst>
           </p:cNvPr>
@@ -5947,7 +5947,7 @@
           <p:cNvPr id="15" name="">
             <a:extLst xmlns:a="http://schemas.openxmlformats.org/drawingml/2006/main">
               <a:ext uri="{FF2B5EF4-FFF2-40B4-BE49-F238E27FC236}">
-                <a16:creationId xmlns:a16="http://schemas.microsoft.com/office/drawing/2014/main" id="{C8B6CE03-4327-415C-8A2E-0B9859968029}"/>
+                <a16:creationId xmlns:a16="http://schemas.microsoft.com/office/drawing/2014/main" id="{B8E37ABE-FED0-4057-BEA8-1AE85BB52901}"/>
               </a:ext>
             </a:extLst>
           </p:cNvPr>
@@ -6004,7 +6004,7 @@
           <p:cNvPr id="16" name="">
             <a:extLst xmlns:a="http://schemas.openxmlformats.org/drawingml/2006/main">
               <a:ext uri="{FF2B5EF4-FFF2-40B4-BE49-F238E27FC236}">
-                <a16:creationId xmlns:a16="http://schemas.microsoft.com/office/drawing/2014/main" id="{8B32F0DA-D23F-436F-8CB1-A5D44DEE8347}"/>
+                <a16:creationId xmlns:a16="http://schemas.microsoft.com/office/drawing/2014/main" id="{4EFA918B-5383-4247-AE76-796E9771A09A}"/>
               </a:ext>
             </a:extLst>
           </p:cNvPr>
@@ -6061,7 +6061,7 @@
           <p:cNvPr id="17" name="">
             <a:extLst xmlns:a="http://schemas.openxmlformats.org/drawingml/2006/main">
               <a:ext uri="{FF2B5EF4-FFF2-40B4-BE49-F238E27FC236}">
-                <a16:creationId xmlns:a16="http://schemas.microsoft.com/office/drawing/2014/main" id="{C7500CA8-4B8F-4270-8F72-A2A729924747}"/>
+                <a16:creationId xmlns:a16="http://schemas.microsoft.com/office/drawing/2014/main" id="{7525E758-19F5-4704-817B-EDD3065A5174}"/>
               </a:ext>
             </a:extLst>
           </p:cNvPr>
@@ -6118,7 +6118,7 @@
           <p:cNvPr id="18" name="">
             <a:extLst xmlns:a="http://schemas.openxmlformats.org/drawingml/2006/main">
               <a:ext uri="{FF2B5EF4-FFF2-40B4-BE49-F238E27FC236}">
-                <a16:creationId xmlns:a16="http://schemas.microsoft.com/office/drawing/2014/main" id="{DAB1C7C3-0BDE-4812-ABB3-C741D5039669}"/>
+                <a16:creationId xmlns:a16="http://schemas.microsoft.com/office/drawing/2014/main" id="{B9F695A9-56BE-4227-9599-D93A1AAE49CD}"/>
               </a:ext>
             </a:extLst>
           </p:cNvPr>
@@ -6175,7 +6175,7 @@
           <p:cNvPr id="19" name="">
             <a:extLst xmlns:a="http://schemas.openxmlformats.org/drawingml/2006/main">
               <a:ext uri="{FF2B5EF4-FFF2-40B4-BE49-F238E27FC236}">
-                <a16:creationId xmlns:a16="http://schemas.microsoft.com/office/drawing/2014/main" id="{C6886FEA-85B7-4B55-AC7F-BCADE43D9EF6}"/>
+                <a16:creationId xmlns:a16="http://schemas.microsoft.com/office/drawing/2014/main" id="{03760FFD-29C7-43F9-9A47-2544C5978913}"/>
               </a:ext>
             </a:extLst>
           </p:cNvPr>
@@ -6207,7 +6207,7 @@
           <p:cNvPr id="20" name="">
             <a:extLst xmlns:a="http://schemas.openxmlformats.org/drawingml/2006/main">
               <a:ext uri="{FF2B5EF4-FFF2-40B4-BE49-F238E27FC236}">
-                <a16:creationId xmlns:a16="http://schemas.microsoft.com/office/drawing/2014/main" id="{91A9A7CF-A525-410C-8458-A14F59B55189}"/>
+                <a16:creationId xmlns:a16="http://schemas.microsoft.com/office/drawing/2014/main" id="{0DB61A3D-622B-4C4F-8881-E58938DE97CF}"/>
               </a:ext>
             </a:extLst>
           </p:cNvPr>
@@ -6262,7 +6262,7 @@
     </p:spTree>
     <p:extLst>
       <p:ext uri="{BB962C8B-B14F-4D97-AF65-F5344CB8AC3E}">
-        <p14:creationId xmlns:p14="http://schemas.microsoft.com/office/powerpoint/2010/main" val="1417459753"/>
+        <p14:creationId xmlns:p14="http://schemas.microsoft.com/office/powerpoint/2010/main" val="1654998689"/>
       </p:ext>
     </p:extLst>
   </p:cSld>
@@ -6293,7 +6293,7 @@
           <p:cNvPr id="20" name="">
             <a:extLst xmlns:a="http://schemas.openxmlformats.org/drawingml/2006/main">
               <a:ext uri="{FF2B5EF4-FFF2-40B4-BE49-F238E27FC236}">
-                <a16:creationId xmlns:a16="http://schemas.microsoft.com/office/drawing/2014/main" id="{8877FF3B-EFFA-4E83-9C40-468E1E4E70CF}"/>
+                <a16:creationId xmlns:a16="http://schemas.microsoft.com/office/drawing/2014/main" id="{084BB246-31B1-46F7-8C53-F23F616B9E56}"/>
               </a:ext>
             </a:extLst>
           </p:cNvPr>
@@ -6323,7 +6323,7 @@
           <p:cNvPr id="2" name="">
             <a:extLst xmlns:a="http://schemas.openxmlformats.org/drawingml/2006/main">
               <a:ext uri="{FF2B5EF4-FFF2-40B4-BE49-F238E27FC236}">
-                <a16:creationId xmlns:a16="http://schemas.microsoft.com/office/drawing/2014/main" id="{4C185F45-507D-48B2-BFD1-8AF8970AD82C}"/>
+                <a16:creationId xmlns:a16="http://schemas.microsoft.com/office/drawing/2014/main" id="{5F52F820-8F20-4560-A406-DB3F1677A8DB}"/>
               </a:ext>
             </a:extLst>
           </p:cNvPr>
@@ -6380,7 +6380,7 @@
           <p:cNvPr id="3" name="">
             <a:extLst xmlns:a="http://schemas.openxmlformats.org/drawingml/2006/main">
               <a:ext uri="{FF2B5EF4-FFF2-40B4-BE49-F238E27FC236}">
-                <a16:creationId xmlns:a16="http://schemas.microsoft.com/office/drawing/2014/main" id="{DD23CC51-05FC-465D-9136-D0089276F3F0}"/>
+                <a16:creationId xmlns:a16="http://schemas.microsoft.com/office/drawing/2014/main" id="{9BF0AE8A-7828-4004-85E8-D4456454D882}"/>
               </a:ext>
             </a:extLst>
           </p:cNvPr>
@@ -6437,7 +6437,7 @@
           <p:cNvPr id="4" name="">
             <a:extLst xmlns:a="http://schemas.openxmlformats.org/drawingml/2006/main">
               <a:ext uri="{FF2B5EF4-FFF2-40B4-BE49-F238E27FC236}">
-                <a16:creationId xmlns:a16="http://schemas.microsoft.com/office/drawing/2014/main" id="{B7D17350-160A-4748-9587-42C3D5D4445C}"/>
+                <a16:creationId xmlns:a16="http://schemas.microsoft.com/office/drawing/2014/main" id="{6F7994A3-037D-4A4D-BF03-ABAB775CB5FC}"/>
               </a:ext>
             </a:extLst>
           </p:cNvPr>
@@ -6494,7 +6494,7 @@
           <p:cNvPr id="5" name="">
             <a:extLst xmlns:a="http://schemas.openxmlformats.org/drawingml/2006/main">
               <a:ext uri="{FF2B5EF4-FFF2-40B4-BE49-F238E27FC236}">
-                <a16:creationId xmlns:a16="http://schemas.microsoft.com/office/drawing/2014/main" id="{598A6687-062E-484A-ADC4-F11202B8EA92}"/>
+                <a16:creationId xmlns:a16="http://schemas.microsoft.com/office/drawing/2014/main" id="{CF76C49C-0CE3-4953-9BB7-73756507588D}"/>
               </a:ext>
             </a:extLst>
           </p:cNvPr>
@@ -6551,7 +6551,7 @@
           <p:cNvPr id="6" name="">
             <a:extLst xmlns:a="http://schemas.openxmlformats.org/drawingml/2006/main">
               <a:ext uri="{FF2B5EF4-FFF2-40B4-BE49-F238E27FC236}">
-                <a16:creationId xmlns:a16="http://schemas.microsoft.com/office/drawing/2014/main" id="{88304067-1E06-4748-B6D8-80EA26EBDD9F}"/>
+                <a16:creationId xmlns:a16="http://schemas.microsoft.com/office/drawing/2014/main" id="{6E6C5881-703F-4CDB-A0CF-6030B82FDEEB}"/>
               </a:ext>
             </a:extLst>
           </p:cNvPr>
@@ -6608,7 +6608,7 @@
           <p:cNvPr id="7" name="">
             <a:extLst xmlns:a="http://schemas.openxmlformats.org/drawingml/2006/main">
               <a:ext uri="{FF2B5EF4-FFF2-40B4-BE49-F238E27FC236}">
-                <a16:creationId xmlns:a16="http://schemas.microsoft.com/office/drawing/2014/main" id="{546A5D44-C806-4AA6-AFD2-5D1D20603E4E}"/>
+                <a16:creationId xmlns:a16="http://schemas.microsoft.com/office/drawing/2014/main" id="{F6427A46-42EA-4CA3-92D5-CDAA26F6BE1A}"/>
               </a:ext>
             </a:extLst>
           </p:cNvPr>
@@ -6665,7 +6665,7 @@
           <p:cNvPr id="8" name="">
             <a:extLst xmlns:a="http://schemas.openxmlformats.org/drawingml/2006/main">
               <a:ext uri="{FF2B5EF4-FFF2-40B4-BE49-F238E27FC236}">
-                <a16:creationId xmlns:a16="http://schemas.microsoft.com/office/drawing/2014/main" id="{3F126335-9819-431C-930C-B3C27863082A}"/>
+                <a16:creationId xmlns:a16="http://schemas.microsoft.com/office/drawing/2014/main" id="{5C2495F1-5146-4CF9-B00A-547A67418EBA}"/>
               </a:ext>
             </a:extLst>
           </p:cNvPr>
@@ -6722,7 +6722,7 @@
           <p:cNvPr id="9" name="">
             <a:extLst xmlns:a="http://schemas.openxmlformats.org/drawingml/2006/main">
               <a:ext uri="{FF2B5EF4-FFF2-40B4-BE49-F238E27FC236}">
-                <a16:creationId xmlns:a16="http://schemas.microsoft.com/office/drawing/2014/main" id="{6495902D-71FA-4C07-99A7-57FE58E4144C}"/>
+                <a16:creationId xmlns:a16="http://schemas.microsoft.com/office/drawing/2014/main" id="{E6566633-4620-47C4-9A71-ECD3B3E50D95}"/>
               </a:ext>
             </a:extLst>
           </p:cNvPr>
@@ -6752,7 +6752,7 @@
           <p:cNvPr id="10" name="">
             <a:extLst xmlns:a="http://schemas.openxmlformats.org/drawingml/2006/main">
               <a:ext uri="{FF2B5EF4-FFF2-40B4-BE49-F238E27FC236}">
-                <a16:creationId xmlns:a16="http://schemas.microsoft.com/office/drawing/2014/main" id="{64EE3232-382F-4766-AABE-67CC977AC492}"/>
+                <a16:creationId xmlns:a16="http://schemas.microsoft.com/office/drawing/2014/main" id="{A16E08C8-D5D5-426C-9258-3214CCA92631}"/>
               </a:ext>
             </a:extLst>
           </p:cNvPr>
@@ -6809,7 +6809,7 @@
           <p:cNvPr id="11" name="">
             <a:extLst xmlns:a="http://schemas.openxmlformats.org/drawingml/2006/main">
               <a:ext uri="{FF2B5EF4-FFF2-40B4-BE49-F238E27FC236}">
-                <a16:creationId xmlns:a16="http://schemas.microsoft.com/office/drawing/2014/main" id="{BE6135A3-6997-43A5-9C03-495783CCEC45}"/>
+                <a16:creationId xmlns:a16="http://schemas.microsoft.com/office/drawing/2014/main" id="{EF4DD820-6A1C-459C-96C1-61A7602C4890}"/>
               </a:ext>
             </a:extLst>
           </p:cNvPr>
@@ -6866,7 +6866,7 @@
           <p:cNvPr id="12" name="">
             <a:extLst xmlns:a="http://schemas.openxmlformats.org/drawingml/2006/main">
               <a:ext uri="{FF2B5EF4-FFF2-40B4-BE49-F238E27FC236}">
-                <a16:creationId xmlns:a16="http://schemas.microsoft.com/office/drawing/2014/main" id="{8921D663-E7A9-4F27-98C5-06A7EBBE089A}"/>
+                <a16:creationId xmlns:a16="http://schemas.microsoft.com/office/drawing/2014/main" id="{E092C3B0-8A2D-4D90-B30A-9E6B87608B9A}"/>
               </a:ext>
             </a:extLst>
           </p:cNvPr>
@@ -6923,7 +6923,7 @@
           <p:cNvPr id="13" name="">
             <a:extLst xmlns:a="http://schemas.openxmlformats.org/drawingml/2006/main">
               <a:ext uri="{FF2B5EF4-FFF2-40B4-BE49-F238E27FC236}">
-                <a16:creationId xmlns:a16="http://schemas.microsoft.com/office/drawing/2014/main" id="{996E74F5-8212-4512-B6F1-DDC5354EE0F8}"/>
+                <a16:creationId xmlns:a16="http://schemas.microsoft.com/office/drawing/2014/main" id="{51847F2B-FF67-400F-83FB-6837EBE5DCED}"/>
               </a:ext>
             </a:extLst>
           </p:cNvPr>
@@ -6980,7 +6980,7 @@
           <p:cNvPr id="14" name="">
             <a:extLst xmlns:a="http://schemas.openxmlformats.org/drawingml/2006/main">
               <a:ext uri="{FF2B5EF4-FFF2-40B4-BE49-F238E27FC236}">
-                <a16:creationId xmlns:a16="http://schemas.microsoft.com/office/drawing/2014/main" id="{BD5E868A-C7B5-416A-9828-A90F2B1B86EA}"/>
+                <a16:creationId xmlns:a16="http://schemas.microsoft.com/office/drawing/2014/main" id="{08C28423-FA59-4E04-99C7-CA2CD75ED765}"/>
               </a:ext>
             </a:extLst>
           </p:cNvPr>
@@ -7010,7 +7010,7 @@
           <p:cNvPr id="15" name="">
             <a:extLst xmlns:a="http://schemas.openxmlformats.org/drawingml/2006/main">
               <a:ext uri="{FF2B5EF4-FFF2-40B4-BE49-F238E27FC236}">
-                <a16:creationId xmlns:a16="http://schemas.microsoft.com/office/drawing/2014/main" id="{53FDE256-231E-4EEA-9FBA-83934BFE0B44}"/>
+                <a16:creationId xmlns:a16="http://schemas.microsoft.com/office/drawing/2014/main" id="{22AE95EC-88F2-4EFC-AFD5-C69A1F02CEC0}"/>
               </a:ext>
             </a:extLst>
           </p:cNvPr>
@@ -7067,7 +7067,7 @@
           <p:cNvPr id="16" name="">
             <a:extLst xmlns:a="http://schemas.openxmlformats.org/drawingml/2006/main">
               <a:ext uri="{FF2B5EF4-FFF2-40B4-BE49-F238E27FC236}">
-                <a16:creationId xmlns:a16="http://schemas.microsoft.com/office/drawing/2014/main" id="{66071DE4-620B-43C1-A9D6-F3F0A4E7F596}"/>
+                <a16:creationId xmlns:a16="http://schemas.microsoft.com/office/drawing/2014/main" id="{94D4D563-9727-48B4-BE0A-E8092DFCA617}"/>
               </a:ext>
             </a:extLst>
           </p:cNvPr>
@@ -7124,7 +7124,7 @@
           <p:cNvPr id="17" name="">
             <a:extLst xmlns:a="http://schemas.openxmlformats.org/drawingml/2006/main">
               <a:ext uri="{FF2B5EF4-FFF2-40B4-BE49-F238E27FC236}">
-                <a16:creationId xmlns:a16="http://schemas.microsoft.com/office/drawing/2014/main" id="{6400CA71-AE46-48BE-AE71-8537EA5D0AE0}"/>
+                <a16:creationId xmlns:a16="http://schemas.microsoft.com/office/drawing/2014/main" id="{CB3D98D1-D291-4448-9E22-82BE0D18B23E}"/>
               </a:ext>
             </a:extLst>
           </p:cNvPr>
@@ -7181,7 +7181,7 @@
           <p:cNvPr id="18" name="">
             <a:extLst xmlns:a="http://schemas.openxmlformats.org/drawingml/2006/main">
               <a:ext uri="{FF2B5EF4-FFF2-40B4-BE49-F238E27FC236}">
-                <a16:creationId xmlns:a16="http://schemas.microsoft.com/office/drawing/2014/main" id="{368D43BF-DF7E-4FD0-88EE-7F09475C660E}"/>
+                <a16:creationId xmlns:a16="http://schemas.microsoft.com/office/drawing/2014/main" id="{77121DE6-BC22-4B77-8409-ADF5E74FF7DD}"/>
               </a:ext>
             </a:extLst>
           </p:cNvPr>
@@ -7238,7 +7238,7 @@
           <p:cNvPr id="19" name="">
             <a:extLst xmlns:a="http://schemas.openxmlformats.org/drawingml/2006/main">
               <a:ext uri="{FF2B5EF4-FFF2-40B4-BE49-F238E27FC236}">
-                <a16:creationId xmlns:a16="http://schemas.microsoft.com/office/drawing/2014/main" id="{8EDB1E9B-6839-462E-A911-4CE5E24BC887}"/>
+                <a16:creationId xmlns:a16="http://schemas.microsoft.com/office/drawing/2014/main" id="{11A795E5-8AAB-4D41-9AF5-B503F1618222}"/>
               </a:ext>
             </a:extLst>
           </p:cNvPr>
@@ -7293,7 +7293,7 @@
     </p:spTree>
     <p:extLst>
       <p:ext uri="{BB962C8B-B14F-4D97-AF65-F5344CB8AC3E}">
-        <p14:creationId xmlns:p14="http://schemas.microsoft.com/office/powerpoint/2010/main" val="1324757018"/>
+        <p14:creationId xmlns:p14="http://schemas.microsoft.com/office/powerpoint/2010/main" val="163497458"/>
       </p:ext>
     </p:extLst>
   </p:cSld>
@@ -7324,7 +7324,7 @@
           <p:cNvPr id="20" name="">
             <a:extLst xmlns:a="http://schemas.openxmlformats.org/drawingml/2006/main">
               <a:ext uri="{FF2B5EF4-FFF2-40B4-BE49-F238E27FC236}">
-                <a16:creationId xmlns:a16="http://schemas.microsoft.com/office/drawing/2014/main" id="{064BD39A-734E-47CB-91F6-E1F795CEB81B}"/>
+                <a16:creationId xmlns:a16="http://schemas.microsoft.com/office/drawing/2014/main" id="{90C58D41-520C-4768-A316-B6ABC5D9B822}"/>
               </a:ext>
             </a:extLst>
           </p:cNvPr>
@@ -7354,7 +7354,7 @@
           <p:cNvPr id="2" name="">
             <a:extLst xmlns:a="http://schemas.openxmlformats.org/drawingml/2006/main">
               <a:ext uri="{FF2B5EF4-FFF2-40B4-BE49-F238E27FC236}">
-                <a16:creationId xmlns:a16="http://schemas.microsoft.com/office/drawing/2014/main" id="{8A06C991-ED25-4A39-8782-23A9CA29055F}"/>
+                <a16:creationId xmlns:a16="http://schemas.microsoft.com/office/drawing/2014/main" id="{3D9C5E89-1D78-490D-A490-6FECF5E9F6E7}"/>
               </a:ext>
             </a:extLst>
           </p:cNvPr>
@@ -7411,7 +7411,7 @@
           <p:cNvPr id="3" name="">
             <a:extLst xmlns:a="http://schemas.openxmlformats.org/drawingml/2006/main">
               <a:ext uri="{FF2B5EF4-FFF2-40B4-BE49-F238E27FC236}">
-                <a16:creationId xmlns:a16="http://schemas.microsoft.com/office/drawing/2014/main" id="{8CD16639-E63B-4065-87C0-32CE3DDD72BF}"/>
+                <a16:creationId xmlns:a16="http://schemas.microsoft.com/office/drawing/2014/main" id="{00F8A221-5E2C-44FC-AF76-2A3E240EB13C}"/>
               </a:ext>
             </a:extLst>
           </p:cNvPr>
@@ -7468,7 +7468,7 @@
           <p:cNvPr id="4" name="">
             <a:extLst xmlns:a="http://schemas.openxmlformats.org/drawingml/2006/main">
               <a:ext uri="{FF2B5EF4-FFF2-40B4-BE49-F238E27FC236}">
-                <a16:creationId xmlns:a16="http://schemas.microsoft.com/office/drawing/2014/main" id="{04BCF9CB-C1DE-40CB-908D-785D16A1A8BF}"/>
+                <a16:creationId xmlns:a16="http://schemas.microsoft.com/office/drawing/2014/main" id="{675A75BB-DBBB-4667-B88C-F08D818C3196}"/>
               </a:ext>
             </a:extLst>
           </p:cNvPr>
@@ -7525,7 +7525,7 @@
           <p:cNvPr id="5" name="">
             <a:extLst xmlns:a="http://schemas.openxmlformats.org/drawingml/2006/main">
               <a:ext uri="{FF2B5EF4-FFF2-40B4-BE49-F238E27FC236}">
-                <a16:creationId xmlns:a16="http://schemas.microsoft.com/office/drawing/2014/main" id="{272C7188-D5DD-4EF1-988C-CFAEF445F50B}"/>
+                <a16:creationId xmlns:a16="http://schemas.microsoft.com/office/drawing/2014/main" id="{60B714C7-BD56-4556-BBF6-98F7E4D586BE}"/>
               </a:ext>
             </a:extLst>
           </p:cNvPr>
@@ -7560,7 +7560,7 @@
           <p:cNvPr id="6" name="">
             <a:extLst xmlns:a="http://schemas.openxmlformats.org/drawingml/2006/main">
               <a:ext uri="{FF2B5EF4-FFF2-40B4-BE49-F238E27FC236}">
-                <a16:creationId xmlns:a16="http://schemas.microsoft.com/office/drawing/2014/main" id="{6E56EC9A-1D91-43CC-9BB5-2E19E3DE071C}"/>
+                <a16:creationId xmlns:a16="http://schemas.microsoft.com/office/drawing/2014/main" id="{51CE246F-287E-4C72-9418-198ED7BC1A6B}"/>
               </a:ext>
             </a:extLst>
           </p:cNvPr>
@@ -7617,7 +7617,7 @@
           <p:cNvPr id="7" name="">
             <a:extLst xmlns:a="http://schemas.openxmlformats.org/drawingml/2006/main">
               <a:ext uri="{FF2B5EF4-FFF2-40B4-BE49-F238E27FC236}">
-                <a16:creationId xmlns:a16="http://schemas.microsoft.com/office/drawing/2014/main" id="{3BC01480-47E9-450A-A028-EBB5736732CA}"/>
+                <a16:creationId xmlns:a16="http://schemas.microsoft.com/office/drawing/2014/main" id="{92706C00-D2A7-401A-9E13-D929DD8F73D1}"/>
               </a:ext>
             </a:extLst>
           </p:cNvPr>
@@ -7674,7 +7674,7 @@
           <p:cNvPr id="8" name="">
             <a:extLst xmlns:a="http://schemas.openxmlformats.org/drawingml/2006/main">
               <a:ext uri="{FF2B5EF4-FFF2-40B4-BE49-F238E27FC236}">
-                <a16:creationId xmlns:a16="http://schemas.microsoft.com/office/drawing/2014/main" id="{A0D3D6FA-1BCA-41E2-A4DF-80CAE6804916}"/>
+                <a16:creationId xmlns:a16="http://schemas.microsoft.com/office/drawing/2014/main" id="{5F51BD1E-982A-437F-B707-5230CD3BDA45}"/>
               </a:ext>
             </a:extLst>
           </p:cNvPr>
@@ -7709,7 +7709,7 @@
           <p:cNvPr id="9" name="">
             <a:extLst xmlns:a="http://schemas.openxmlformats.org/drawingml/2006/main">
               <a:ext uri="{FF2B5EF4-FFF2-40B4-BE49-F238E27FC236}">
-                <a16:creationId xmlns:a16="http://schemas.microsoft.com/office/drawing/2014/main" id="{393CA387-E428-4F38-8CD9-AA94F22C60C9}"/>
+                <a16:creationId xmlns:a16="http://schemas.microsoft.com/office/drawing/2014/main" id="{40FD93A5-1CAC-4DF7-B3A5-68429F2DFAB5}"/>
               </a:ext>
             </a:extLst>
           </p:cNvPr>
@@ -7766,7 +7766,7 @@
           <p:cNvPr id="10" name="">
             <a:extLst xmlns:a="http://schemas.openxmlformats.org/drawingml/2006/main">
               <a:ext uri="{FF2B5EF4-FFF2-40B4-BE49-F238E27FC236}">
-                <a16:creationId xmlns:a16="http://schemas.microsoft.com/office/drawing/2014/main" id="{3B8D3572-A955-465A-9790-63F7AB9CFD3E}"/>
+                <a16:creationId xmlns:a16="http://schemas.microsoft.com/office/drawing/2014/main" id="{04FCB78F-9845-4EDC-B964-524C088FF831}"/>
               </a:ext>
             </a:extLst>
           </p:cNvPr>
@@ -7823,7 +7823,7 @@
           <p:cNvPr id="11" name="">
             <a:extLst xmlns:a="http://schemas.openxmlformats.org/drawingml/2006/main">
               <a:ext uri="{FF2B5EF4-FFF2-40B4-BE49-F238E27FC236}">
-                <a16:creationId xmlns:a16="http://schemas.microsoft.com/office/drawing/2014/main" id="{335310F6-0F4D-408C-836A-BC92DAAB10F3}"/>
+                <a16:creationId xmlns:a16="http://schemas.microsoft.com/office/drawing/2014/main" id="{826EE389-759F-4B64-AF53-3D2FE33267A3}"/>
               </a:ext>
             </a:extLst>
           </p:cNvPr>
@@ -7858,7 +7858,7 @@
           <p:cNvPr id="12" name="">
             <a:extLst xmlns:a="http://schemas.openxmlformats.org/drawingml/2006/main">
               <a:ext uri="{FF2B5EF4-FFF2-40B4-BE49-F238E27FC236}">
-                <a16:creationId xmlns:a16="http://schemas.microsoft.com/office/drawing/2014/main" id="{B4121E08-1469-41AC-9516-3F0A0FD05AD8}"/>
+                <a16:creationId xmlns:a16="http://schemas.microsoft.com/office/drawing/2014/main" id="{79F022EF-A908-4B1D-B382-6D59291ED8B7}"/>
               </a:ext>
             </a:extLst>
           </p:cNvPr>
@@ -7915,7 +7915,7 @@
           <p:cNvPr id="13" name="">
             <a:extLst xmlns:a="http://schemas.openxmlformats.org/drawingml/2006/main">
               <a:ext uri="{FF2B5EF4-FFF2-40B4-BE49-F238E27FC236}">
-                <a16:creationId xmlns:a16="http://schemas.microsoft.com/office/drawing/2014/main" id="{BEAC8C41-1514-4104-B492-8202D6031521}"/>
+                <a16:creationId xmlns:a16="http://schemas.microsoft.com/office/drawing/2014/main" id="{145FBBD0-30B5-4E4F-832E-BB0BAE13D236}"/>
               </a:ext>
             </a:extLst>
           </p:cNvPr>
@@ -7972,7 +7972,7 @@
           <p:cNvPr id="14" name="">
             <a:extLst xmlns:a="http://schemas.openxmlformats.org/drawingml/2006/main">
               <a:ext uri="{FF2B5EF4-FFF2-40B4-BE49-F238E27FC236}">
-                <a16:creationId xmlns:a16="http://schemas.microsoft.com/office/drawing/2014/main" id="{0DF6A210-C6CB-4A1F-BC16-B87FE3120979}"/>
+                <a16:creationId xmlns:a16="http://schemas.microsoft.com/office/drawing/2014/main" id="{3BDDD33F-09B9-4D9C-AC42-257B6B617ADB}"/>
               </a:ext>
             </a:extLst>
           </p:cNvPr>
@@ -8007,7 +8007,7 @@
           <p:cNvPr id="15" name="">
             <a:extLst xmlns:a="http://schemas.openxmlformats.org/drawingml/2006/main">
               <a:ext uri="{FF2B5EF4-FFF2-40B4-BE49-F238E27FC236}">
-                <a16:creationId xmlns:a16="http://schemas.microsoft.com/office/drawing/2014/main" id="{2D63275D-7BB6-413E-97C3-CC606419456D}"/>
+                <a16:creationId xmlns:a16="http://schemas.microsoft.com/office/drawing/2014/main" id="{04B10158-9466-4A17-B2A8-F5BFBF0A1F02}"/>
               </a:ext>
             </a:extLst>
           </p:cNvPr>
@@ -8064,7 +8064,7 @@
           <p:cNvPr id="16" name="">
             <a:extLst xmlns:a="http://schemas.openxmlformats.org/drawingml/2006/main">
               <a:ext uri="{FF2B5EF4-FFF2-40B4-BE49-F238E27FC236}">
-                <a16:creationId xmlns:a16="http://schemas.microsoft.com/office/drawing/2014/main" id="{8F08029D-B506-4F97-87B7-11CA49700F0A}"/>
+                <a16:creationId xmlns:a16="http://schemas.microsoft.com/office/drawing/2014/main" id="{D1D9D76F-87FA-48EF-AD22-8218B04C1950}"/>
               </a:ext>
             </a:extLst>
           </p:cNvPr>
@@ -8121,7 +8121,7 @@
           <p:cNvPr id="17" name="">
             <a:extLst xmlns:a="http://schemas.openxmlformats.org/drawingml/2006/main">
               <a:ext uri="{FF2B5EF4-FFF2-40B4-BE49-F238E27FC236}">
-                <a16:creationId xmlns:a16="http://schemas.microsoft.com/office/drawing/2014/main" id="{99BBE58E-FF35-466D-B732-934F6F5C29DF}"/>
+                <a16:creationId xmlns:a16="http://schemas.microsoft.com/office/drawing/2014/main" id="{C304A5D0-7E74-407D-8E47-84EA087662A0}"/>
               </a:ext>
             </a:extLst>
           </p:cNvPr>
@@ -8178,7 +8178,7 @@
           <p:cNvPr id="18" name="">
             <a:extLst xmlns:a="http://schemas.openxmlformats.org/drawingml/2006/main">
               <a:ext uri="{FF2B5EF4-FFF2-40B4-BE49-F238E27FC236}">
-                <a16:creationId xmlns:a16="http://schemas.microsoft.com/office/drawing/2014/main" id="{4A77D3C5-DB52-48A6-8089-E9537287AAF9}"/>
+                <a16:creationId xmlns:a16="http://schemas.microsoft.com/office/drawing/2014/main" id="{44323BAF-18E7-4123-B609-82649861A002}"/>
               </a:ext>
             </a:extLst>
           </p:cNvPr>
@@ -8235,7 +8235,7 @@
           <p:cNvPr id="19" name="">
             <a:extLst xmlns:a="http://schemas.openxmlformats.org/drawingml/2006/main">
               <a:ext uri="{FF2B5EF4-FFF2-40B4-BE49-F238E27FC236}">
-                <a16:creationId xmlns:a16="http://schemas.microsoft.com/office/drawing/2014/main" id="{907BE617-7187-4113-B962-DE0D6D31F423}"/>
+                <a16:creationId xmlns:a16="http://schemas.microsoft.com/office/drawing/2014/main" id="{01C1063B-6E4F-4158-9D63-B4ADDE5B8C6F}"/>
               </a:ext>
             </a:extLst>
           </p:cNvPr>
@@ -8290,7 +8290,7 @@
     </p:spTree>
     <p:extLst>
       <p:ext uri="{BB962C8B-B14F-4D97-AF65-F5344CB8AC3E}">
-        <p14:creationId xmlns:p14="http://schemas.microsoft.com/office/powerpoint/2010/main" val="1813460972"/>
+        <p14:creationId xmlns:p14="http://schemas.microsoft.com/office/powerpoint/2010/main" val="489893868"/>
       </p:ext>
     </p:extLst>
   </p:cSld>
@@ -8321,7 +8321,7 @@
           <p:cNvPr id="20" name="">
             <a:extLst xmlns:a="http://schemas.openxmlformats.org/drawingml/2006/main">
               <a:ext uri="{FF2B5EF4-FFF2-40B4-BE49-F238E27FC236}">
-                <a16:creationId xmlns:a16="http://schemas.microsoft.com/office/drawing/2014/main" id="{6AEFD6D0-251D-4508-90CC-F794D1C006D9}"/>
+                <a16:creationId xmlns:a16="http://schemas.microsoft.com/office/drawing/2014/main" id="{38D10808-B4E9-4730-AC8B-F1961493BE36}"/>
               </a:ext>
             </a:extLst>
           </p:cNvPr>
@@ -8351,7 +8351,7 @@
           <p:cNvPr id="2" name="">
             <a:extLst xmlns:a="http://schemas.openxmlformats.org/drawingml/2006/main">
               <a:ext uri="{FF2B5EF4-FFF2-40B4-BE49-F238E27FC236}">
-                <a16:creationId xmlns:a16="http://schemas.microsoft.com/office/drawing/2014/main" id="{55659F75-FDF5-4945-82D0-AEC49C4E21AD}"/>
+                <a16:creationId xmlns:a16="http://schemas.microsoft.com/office/drawing/2014/main" id="{E6443CC7-1394-4F87-BB8A-9DDDC5A6DF4C}"/>
               </a:ext>
             </a:extLst>
           </p:cNvPr>
@@ -8408,7 +8408,7 @@
           <p:cNvPr id="3" name="">
             <a:extLst xmlns:a="http://schemas.openxmlformats.org/drawingml/2006/main">
               <a:ext uri="{FF2B5EF4-FFF2-40B4-BE49-F238E27FC236}">
-                <a16:creationId xmlns:a16="http://schemas.microsoft.com/office/drawing/2014/main" id="{2D63D1BD-380A-4477-A600-350D23845AC2}"/>
+                <a16:creationId xmlns:a16="http://schemas.microsoft.com/office/drawing/2014/main" id="{7A5902D5-01C8-4AD9-9FFA-8E31366A30D7}"/>
               </a:ext>
             </a:extLst>
           </p:cNvPr>
@@ -8465,7 +8465,7 @@
           <p:cNvPr id="4" name="">
             <a:extLst xmlns:a="http://schemas.openxmlformats.org/drawingml/2006/main">
               <a:ext uri="{FF2B5EF4-FFF2-40B4-BE49-F238E27FC236}">
-                <a16:creationId xmlns:a16="http://schemas.microsoft.com/office/drawing/2014/main" id="{8414F2FF-AB89-4404-BF90-5A93E41A5540}"/>
+                <a16:creationId xmlns:a16="http://schemas.microsoft.com/office/drawing/2014/main" id="{2B8D7A8C-2D53-496F-B3CA-3F0AF9403324}"/>
               </a:ext>
             </a:extLst>
           </p:cNvPr>
@@ -8522,7 +8522,7 @@
           <p:cNvPr id="5" name="">
             <a:extLst xmlns:a="http://schemas.openxmlformats.org/drawingml/2006/main">
               <a:ext uri="{FF2B5EF4-FFF2-40B4-BE49-F238E27FC236}">
-                <a16:creationId xmlns:a16="http://schemas.microsoft.com/office/drawing/2014/main" id="{6DB1F590-0B80-4E37-9F42-DED7A1EA46ED}"/>
+                <a16:creationId xmlns:a16="http://schemas.microsoft.com/office/drawing/2014/main" id="{E2591CD4-5800-4D5C-A2D1-766F6C25EE20}"/>
               </a:ext>
             </a:extLst>
           </p:cNvPr>
@@ -8579,7 +8579,7 @@
           <p:cNvPr id="6" name="">
             <a:extLst xmlns:a="http://schemas.openxmlformats.org/drawingml/2006/main">
               <a:ext uri="{FF2B5EF4-FFF2-40B4-BE49-F238E27FC236}">
-                <a16:creationId xmlns:a16="http://schemas.microsoft.com/office/drawing/2014/main" id="{BC222B2A-2BFF-4EDC-A141-167C2F5C8343}"/>
+                <a16:creationId xmlns:a16="http://schemas.microsoft.com/office/drawing/2014/main" id="{B16408CC-FAC5-4E25-B21C-35630058C925}"/>
               </a:ext>
             </a:extLst>
           </p:cNvPr>
@@ -8636,7 +8636,7 @@
           <p:cNvPr id="7" name="">
             <a:extLst xmlns:a="http://schemas.openxmlformats.org/drawingml/2006/main">
               <a:ext uri="{FF2B5EF4-FFF2-40B4-BE49-F238E27FC236}">
-                <a16:creationId xmlns:a16="http://schemas.microsoft.com/office/drawing/2014/main" id="{83DAD7D1-DCCD-4156-848A-28C7B423145A}"/>
+                <a16:creationId xmlns:a16="http://schemas.microsoft.com/office/drawing/2014/main" id="{D25BC4DC-B5F1-4AD1-BCF6-F5A5D233E641}"/>
               </a:ext>
             </a:extLst>
           </p:cNvPr>
@@ -8693,7 +8693,7 @@
           <p:cNvPr id="8" name="">
             <a:extLst xmlns:a="http://schemas.openxmlformats.org/drawingml/2006/main">
               <a:ext uri="{FF2B5EF4-FFF2-40B4-BE49-F238E27FC236}">
-                <a16:creationId xmlns:a16="http://schemas.microsoft.com/office/drawing/2014/main" id="{6D924F5A-AC13-47CA-AC0E-B86B549E13F9}"/>
+                <a16:creationId xmlns:a16="http://schemas.microsoft.com/office/drawing/2014/main" id="{6C42BE1A-CD70-4EF9-B3CD-7EA82663066A}"/>
               </a:ext>
             </a:extLst>
           </p:cNvPr>
@@ -8750,7 +8750,7 @@
           <p:cNvPr id="9" name="">
             <a:extLst xmlns:a="http://schemas.openxmlformats.org/drawingml/2006/main">
               <a:ext uri="{FF2B5EF4-FFF2-40B4-BE49-F238E27FC236}">
-                <a16:creationId xmlns:a16="http://schemas.microsoft.com/office/drawing/2014/main" id="{404E6679-9A71-4D7A-A0FA-9B3B7F577A9F}"/>
+                <a16:creationId xmlns:a16="http://schemas.microsoft.com/office/drawing/2014/main" id="{ED8EE32A-B1D1-48BA-9738-8560389D4E6F}"/>
               </a:ext>
             </a:extLst>
           </p:cNvPr>
@@ -8807,7 +8807,7 @@
           <p:cNvPr id="10" name="">
             <a:extLst xmlns:a="http://schemas.openxmlformats.org/drawingml/2006/main">
               <a:ext uri="{FF2B5EF4-FFF2-40B4-BE49-F238E27FC236}">
-                <a16:creationId xmlns:a16="http://schemas.microsoft.com/office/drawing/2014/main" id="{89A6DBCF-259C-4FCD-9A9F-C18F6DE08CCE}"/>
+                <a16:creationId xmlns:a16="http://schemas.microsoft.com/office/drawing/2014/main" id="{89EC130D-6CBC-4A62-8B84-D562C39F8918}"/>
               </a:ext>
             </a:extLst>
           </p:cNvPr>
@@ -8864,7 +8864,7 @@
           <p:cNvPr id="11" name="">
             <a:extLst xmlns:a="http://schemas.openxmlformats.org/drawingml/2006/main">
               <a:ext uri="{FF2B5EF4-FFF2-40B4-BE49-F238E27FC236}">
-                <a16:creationId xmlns:a16="http://schemas.microsoft.com/office/drawing/2014/main" id="{44347327-6EBF-4AAD-8156-020609EDBBE6}"/>
+                <a16:creationId xmlns:a16="http://schemas.microsoft.com/office/drawing/2014/main" id="{CDC91F01-BDD9-426F-B0B2-A1ADBC66A648}"/>
               </a:ext>
             </a:extLst>
           </p:cNvPr>
@@ -8921,7 +8921,7 @@
           <p:cNvPr id="12" name="">
             <a:extLst xmlns:a="http://schemas.openxmlformats.org/drawingml/2006/main">
               <a:ext uri="{FF2B5EF4-FFF2-40B4-BE49-F238E27FC236}">
-                <a16:creationId xmlns:a16="http://schemas.microsoft.com/office/drawing/2014/main" id="{0B038193-9385-4489-840E-135C45200F4F}"/>
+                <a16:creationId xmlns:a16="http://schemas.microsoft.com/office/drawing/2014/main" id="{11FD97D2-2FE7-49E8-A106-FD879A98BB55}"/>
               </a:ext>
             </a:extLst>
           </p:cNvPr>
@@ -8978,7 +8978,7 @@
           <p:cNvPr id="13" name="">
             <a:extLst xmlns:a="http://schemas.openxmlformats.org/drawingml/2006/main">
               <a:ext uri="{FF2B5EF4-FFF2-40B4-BE49-F238E27FC236}">
-                <a16:creationId xmlns:a16="http://schemas.microsoft.com/office/drawing/2014/main" id="{D9936F2D-83D2-423F-8EB9-C955996A1887}"/>
+                <a16:creationId xmlns:a16="http://schemas.microsoft.com/office/drawing/2014/main" id="{89054AB7-9BD8-4FE7-8BA1-4FBB331A73A3}"/>
               </a:ext>
             </a:extLst>
           </p:cNvPr>
@@ -9035,7 +9035,7 @@
           <p:cNvPr id="14" name="">
             <a:extLst xmlns:a="http://schemas.openxmlformats.org/drawingml/2006/main">
               <a:ext uri="{FF2B5EF4-FFF2-40B4-BE49-F238E27FC236}">
-                <a16:creationId xmlns:a16="http://schemas.microsoft.com/office/drawing/2014/main" id="{94EFE792-15AD-4C5C-98B3-C96E1F8B8E77}"/>
+                <a16:creationId xmlns:a16="http://schemas.microsoft.com/office/drawing/2014/main" id="{7313649F-6E4A-46E0-B167-583734DE39AA}"/>
               </a:ext>
             </a:extLst>
           </p:cNvPr>
@@ -9065,7 +9065,7 @@
           <p:cNvPr id="15" name="">
             <a:extLst xmlns:a="http://schemas.openxmlformats.org/drawingml/2006/main">
               <a:ext uri="{FF2B5EF4-FFF2-40B4-BE49-F238E27FC236}">
-                <a16:creationId xmlns:a16="http://schemas.microsoft.com/office/drawing/2014/main" id="{57BC42D6-B683-4C80-A77C-DF4A24DE7370}"/>
+                <a16:creationId xmlns:a16="http://schemas.microsoft.com/office/drawing/2014/main" id="{59F7F168-1329-4B4F-ABC9-8ADDBAFC23A9}"/>
               </a:ext>
             </a:extLst>
           </p:cNvPr>
@@ -9122,7 +9122,7 @@
           <p:cNvPr id="16" name="">
             <a:extLst xmlns:a="http://schemas.openxmlformats.org/drawingml/2006/main">
               <a:ext uri="{FF2B5EF4-FFF2-40B4-BE49-F238E27FC236}">
-                <a16:creationId xmlns:a16="http://schemas.microsoft.com/office/drawing/2014/main" id="{ACBF56C9-AE23-4FA0-87F9-C90D2362F217}"/>
+                <a16:creationId xmlns:a16="http://schemas.microsoft.com/office/drawing/2014/main" id="{CF7228E6-DE64-4BD1-9D9B-2382E1F84956}"/>
               </a:ext>
             </a:extLst>
           </p:cNvPr>
@@ -9179,7 +9179,7 @@
           <p:cNvPr id="17" name="">
             <a:extLst xmlns:a="http://schemas.openxmlformats.org/drawingml/2006/main">
               <a:ext uri="{FF2B5EF4-FFF2-40B4-BE49-F238E27FC236}">
-                <a16:creationId xmlns:a16="http://schemas.microsoft.com/office/drawing/2014/main" id="{9DABA890-3D1D-4C1C-A473-37D24D75B518}"/>
+                <a16:creationId xmlns:a16="http://schemas.microsoft.com/office/drawing/2014/main" id="{D2E8CAD1-88D8-4B28-8A1F-A00349AE8F79}"/>
               </a:ext>
             </a:extLst>
           </p:cNvPr>
@@ -9236,7 +9236,7 @@
           <p:cNvPr id="18" name="">
             <a:extLst xmlns:a="http://schemas.openxmlformats.org/drawingml/2006/main">
               <a:ext uri="{FF2B5EF4-FFF2-40B4-BE49-F238E27FC236}">
-                <a16:creationId xmlns:a16="http://schemas.microsoft.com/office/drawing/2014/main" id="{CD69C100-463B-490C-B782-2B659DA3CFAF}"/>
+                <a16:creationId xmlns:a16="http://schemas.microsoft.com/office/drawing/2014/main" id="{7F471A57-AD90-4069-BA26-7845F6EACB5B}"/>
               </a:ext>
             </a:extLst>
           </p:cNvPr>
@@ -9293,7 +9293,7 @@
           <p:cNvPr id="19" name="">
             <a:extLst xmlns:a="http://schemas.openxmlformats.org/drawingml/2006/main">
               <a:ext uri="{FF2B5EF4-FFF2-40B4-BE49-F238E27FC236}">
-                <a16:creationId xmlns:a16="http://schemas.microsoft.com/office/drawing/2014/main" id="{4A972AB7-3EBF-4ED4-A92E-C3A58F21B90C}"/>
+                <a16:creationId xmlns:a16="http://schemas.microsoft.com/office/drawing/2014/main" id="{C74599C7-DB61-4528-A100-D2597528D65C}"/>
               </a:ext>
             </a:extLst>
           </p:cNvPr>
@@ -9348,7 +9348,7 @@
     </p:spTree>
     <p:extLst>
       <p:ext uri="{BB962C8B-B14F-4D97-AF65-F5344CB8AC3E}">
-        <p14:creationId xmlns:p14="http://schemas.microsoft.com/office/powerpoint/2010/main" val="1172245197"/>
+        <p14:creationId xmlns:p14="http://schemas.microsoft.com/office/powerpoint/2010/main" val="270194953"/>
       </p:ext>
     </p:extLst>
   </p:cSld>

</xml_diff>